<commit_message>
Exp-04 results: audio-conditioned calibration wins — deck, spec, wiki updated
GPU run (dev TUNE shards, ~1,385 pairs): W_audio achieves 1.000
held-out top-1 on both dev splits while the silence-fitted W transfers
at only 0.28/0.31 on identical audio-conditioned pools (paired cosine
0.48 -> 0.13); best layer shifts 4 -> 3; 25%-prefix retrieval improves
0.29 -> 0.39/0.41. Deck gains a results slide (now 15) and decision 3
cites the measurement; spec §4/§10.3 propose freezing
whisper_to_sonar_W_audio.pt; wiki files exp-04 with supersession notes
in the linear-map page and overview.

Co-Authored-By: Claude Fable 5 <noreply@anthropic.com>
</commit_message>
<xml_diff>
--- a/phase0_spec_review.pptx
+++ b/phase0_spec_review.pptx
@@ -19,9 +19,10 @@
     <p:sldId id="267" r:id="rId13"/>
     <p:sldId id="268" r:id="rId14"/>
     <p:sldId id="269" r:id="rId15"/>
+    <p:sldId id="270" r:id="rId16"/>
   </p:sldIdLst>
   <p:notesMasterIdLst>
-    <p:notesMasterId r:id="rId16"/>
+    <p:notesMasterId r:id="rId17"/>
   </p:notesMasterIdLst>
   <p:sldSz cx="12188952" cy="6858000"/>
   <p:notesSz cx="6858000" cy="12188952"/>
@@ -867,7 +868,7 @@
           <a:p>
             <a:r>
               <a:rPr lang="en-US" dirty="0"/>
-              <a:t>Phases 2/3 being 'prepped' is exploratory authoring, not experiment execution — nothing reportable runs before approvals.</a:t>
+              <a:t>The transfer gap (1.000 vs 0.28/0.31 on identical pools) settles the corpus/conditioning question; the text-only LibriSpeech cell of the 2x2 remains optional completeness. Layer choice for the hook changes 4 -&gt; 3 if adopted.</a:t>
             </a:r>
             <a:endParaRPr lang="en-US" dirty="0"/>
           </a:p>
@@ -955,7 +956,7 @@
           <a:p>
             <a:r>
               <a:rPr lang="en-US" dirty="0"/>
-              <a:t>End on decisions, not summary. Each maps to spec section 10; minute the outcomes and update the spec to v1.0 for the audit trail.</a:t>
+              <a:t>Phases 2/3 being 'prepped' is exploratory authoring, not experiment execution — nothing reportable runs before approvals.</a:t>
             </a:r>
             <a:endParaRPr lang="en-US" dirty="0"/>
           </a:p>
@@ -979,6 +980,94 @@
             <a:fld id="{F7021451-1387-4CA6-816F-3879F97B5CBC}" type="slidenum">
               <a:rPr lang="en-US"/>
               <a:t>14</a:t>
+            </a:fld>
+            <a:endParaRPr lang="en-US"/>
+          </a:p>
+        </p:txBody>
+      </p:sp>
+    </p:spTree>
+    <p:extLst>
+      <p:ext uri="{BB962C8B-B14F-4D97-AF65-F5344CB8AC3E}">
+        <p14:creationId xmlns:p14="http://schemas.microsoft.com/office/powerpoint/2010/main" val="1024086991"/>
+      </p:ext>
+    </p:extLst>
+  </p:cSld>
+  <p:clrMapOvr>
+    <a:masterClrMapping/>
+  </p:clrMapOvr>
+</p:notes>
+</file>
+
+<file path=ppt/notesSlides/notesSlide15.xml><?xml version="1.0" encoding="utf-8"?>
+<p:notes xmlns:a="http://schemas.openxmlformats.org/drawingml/2006/main" xmlns:r="http://schemas.openxmlformats.org/officeDocument/2006/relationships" xmlns:p="http://schemas.openxmlformats.org/presentationml/2006/main">
+  <p:cSld>
+    <p:spTree>
+      <p:nvGrpSpPr>
+        <p:cNvPr id="1" name=""/>
+        <p:cNvGrpSpPr/>
+        <p:nvPr/>
+      </p:nvGrpSpPr>
+      <p:grpSpPr>
+        <a:xfrm>
+          <a:off x="0" y="0"/>
+          <a:ext cx="0" cy="0"/>
+          <a:chOff x="0" y="0"/>
+          <a:chExt cx="0" cy="0"/>
+        </a:xfrm>
+      </p:grpSpPr>
+      <p:sp>
+        <p:nvSpPr>
+          <p:cNvPr id="2" name="Slide Image Placeholder 1"/>
+          <p:cNvSpPr>
+            <a:spLocks noGrp="1" noRot="1" noChangeAspect="1"/>
+          </p:cNvSpPr>
+          <p:nvPr>
+            <p:ph type="sldImg"/>
+          </p:nvPr>
+        </p:nvSpPr>
+        <p:spPr/>
+      </p:sp>
+      <p:sp>
+        <p:nvSpPr>
+          <p:cNvPr id="3" name="Notes Placeholder 2"/>
+          <p:cNvSpPr>
+            <a:spLocks noGrp="1"/>
+          </p:cNvSpPr>
+          <p:nvPr>
+            <p:ph type="body" idx="1"/>
+          </p:nvPr>
+        </p:nvSpPr>
+        <p:spPr/>
+        <p:txBody>
+          <a:bodyPr/>
+          <a:lstStyle/>
+          <a:p>
+            <a:r>
+              <a:rPr lang="en-US" dirty="0"/>
+              <a:t>End on decisions, not summary. Each maps to spec section 10; minute the outcomes and update the spec to v1.0 for the audit trail.</a:t>
+            </a:r>
+            <a:endParaRPr lang="en-US" dirty="0"/>
+          </a:p>
+        </p:txBody>
+      </p:sp>
+      <p:sp>
+        <p:nvSpPr>
+          <p:cNvPr id="4" name="Slide Number Placeholder 3"/>
+          <p:cNvSpPr>
+            <a:spLocks noGrp="1"/>
+          </p:cNvSpPr>
+          <p:nvPr>
+            <p:ph type="sldNum" sz="quarter" idx="10"/>
+          </p:nvPr>
+        </p:nvSpPr>
+        <p:spPr/>
+        <p:txBody>
+          <a:bodyPr/>
+          <a:lstStyle/>
+          <a:p>
+            <a:fld id="{F7021451-1387-4CA6-816F-3879F97B5CBC}" type="slidenum">
+              <a:rPr lang="en-US"/>
+              <a:t>15</a:t>
             </a:fld>
             <a:endParaRPr lang="en-US"/>
           </a:p>
@@ -5485,7 +5574,7 @@
                 <a:ea typeface="Calibri" pitchFamily="34" charset="-122"/>
                 <a:cs typeface="Calibri" pitchFamily="34" charset="-120"/>
               </a:rPr>
-              <a:t>Audio-conditioned and text-only LibriSpeech alignment notebooks fit W variants and cross-evaluate every artifact — the corpus decision gets made by measurement, then frozen.</a:t>
+              <a:t>Audio-conditioned and text-only LibriSpeech alignment notebooks fit W variants and cross-evaluate every artifact — the corpus decision gets made by measurement, then frozen. Audio-conditioned run COMPLETE → next slide.</a:t>
             </a:r>
             <a:endParaRPr lang="en-US" sz="1100" dirty="0"/>
           </a:p>
@@ -5639,7 +5728,7 @@
                 <a:ea typeface="Calibri" pitchFamily="34" charset="-122"/>
                 <a:cs typeface="Calibri" pitchFamily="34" charset="-120"/>
               </a:rPr>
-              <a:t>PROCESS</a:t>
+              <a:t>NEW RESULT · PHASE 0 SUPPORTING ANALYSIS</a:t>
             </a:r>
             <a:endParaRPr lang="en-US" sz="1100" dirty="0"/>
           </a:p>
@@ -5678,7 +5767,7 @@
                 <a:ea typeface="Cambria" pitchFamily="34" charset="-122"/>
                 <a:cs typeface="Cambria" pitchFamily="34" charset="-120"/>
               </a:rPr>
-              <a:t>Where we are in the approval flow</a:t>
+              <a:t>§10.3 answered by measurement: calibrate W on audio</a:t>
             </a:r>
             <a:endParaRPr lang="en-US" sz="2700" dirty="0"/>
           </a:p>
@@ -5692,12 +5781,12 @@
         </p:nvSpPr>
         <p:spPr>
           <a:xfrm>
-            <a:off x="548640" y="1920240"/>
-            <a:ext cx="1658112" cy="3108960"/>
+            <a:off x="548640" y="1481328"/>
+            <a:ext cx="11091672" cy="411480"/>
           </a:xfrm>
           <a:prstGeom prst="roundRect">
             <a:avLst>
-              <a:gd name="adj" fmla="val 4963"/>
+              <a:gd name="adj" fmla="val 20000"/>
             </a:avLst>
           </a:prstGeom>
           <a:solidFill>
@@ -5708,34 +5797,14 @@
       </p:sp>
       <p:sp>
         <p:nvSpPr>
-          <p:cNvPr id="7" name="Shape 4"/>
-          <p:cNvSpPr/>
-          <p:nvPr/>
-        </p:nvSpPr>
-        <p:spPr>
-          <a:xfrm>
-            <a:off x="1103376" y="2148840"/>
-            <a:ext cx="548640" cy="548640"/>
-          </a:xfrm>
-          <a:prstGeom prst="ellipse">
-            <a:avLst/>
-          </a:prstGeom>
-          <a:solidFill>
-            <a:srgbClr val="B07A1E"/>
-          </a:solidFill>
-          <a:ln/>
-        </p:spPr>
-      </p:sp>
-      <p:sp>
-        <p:nvSpPr>
-          <p:cNvPr id="8" name="Text 5"/>
-          <p:cNvSpPr/>
-          <p:nvPr/>
-        </p:nvSpPr>
-        <p:spPr>
-          <a:xfrm>
-            <a:off x="1103376" y="2176272"/>
-            <a:ext cx="548640" cy="502920"/>
+          <p:cNvPr id="7" name="Text 4"/>
+          <p:cNvSpPr/>
+          <p:nvPr/>
+        </p:nvSpPr>
+        <p:spPr>
+          <a:xfrm>
+            <a:off x="777240" y="1572768"/>
+            <a:ext cx="10634472" cy="274320"/>
           </a:xfrm>
           <a:prstGeom prst="rect">
             <a:avLst/>
@@ -5747,34 +5816,134 @@
           <a:bodyPr wrap="square" lIns="0" tIns="0" rIns="0" bIns="0" rtlCol="0" anchor="ctr"/>
           <a:lstStyle/>
           <a:p>
-            <a:pPr algn="ctr" indent="0" marL="0">
+            <a:pPr indent="0" marL="0">
               <a:buNone/>
             </a:pPr>
             <a:r>
-              <a:rPr lang="en-US" sz="2000" b="1" dirty="0">
-                <a:solidFill>
-                  <a:srgbClr val="FFFFFF"/>
+              <a:rPr lang="en-US" sz="1100" b="1" dirty="0">
+                <a:solidFill>
+                  <a:srgbClr val="B07A1E"/>
+                </a:solidFill>
+                <a:latin typeface="Calibri" pitchFamily="34" charset="0"/>
+                <a:ea typeface="Calibri" pitchFamily="34" charset="-122"/>
+                <a:cs typeface="Calibri" pitchFamily="34" charset="-120"/>
+              </a:rPr>
+              <a:t>Audio-conditioned alignment run, 2026-07-28 — dev-clean/dev-other TUNE shards, ≈1,385 (audio, reference) pairs, teacher-forced over real encoder outputs. Supporting analysis for decision 3.</a:t>
+            </a:r>
+            <a:endParaRPr lang="en-US" sz="1100" dirty="0"/>
+          </a:p>
+        </p:txBody>
+      </p:sp>
+      <p:sp>
+        <p:nvSpPr>
+          <p:cNvPr id="8" name="Shape 5"/>
+          <p:cNvSpPr/>
+          <p:nvPr/>
+        </p:nvSpPr>
+        <p:spPr>
+          <a:xfrm>
+            <a:off x="548640" y="2057400"/>
+            <a:ext cx="5394960" cy="1737360"/>
+          </a:xfrm>
+          <a:prstGeom prst="roundRect">
+            <a:avLst>
+              <a:gd name="adj" fmla="val 4737"/>
+            </a:avLst>
+          </a:prstGeom>
+          <a:solidFill>
+            <a:srgbClr val="EEF4FB"/>
+          </a:solidFill>
+          <a:ln/>
+        </p:spPr>
+      </p:sp>
+      <p:sp>
+        <p:nvSpPr>
+          <p:cNvPr id="9" name="Text 6"/>
+          <p:cNvSpPr/>
+          <p:nvPr/>
+        </p:nvSpPr>
+        <p:spPr>
+          <a:xfrm>
+            <a:off x="777240" y="2212848"/>
+            <a:ext cx="4937760" cy="274320"/>
+          </a:xfrm>
+          <a:prstGeom prst="rect">
+            <a:avLst/>
+          </a:prstGeom>
+          <a:noFill/>
+          <a:ln/>
+        </p:spPr>
+        <p:txBody>
+          <a:bodyPr wrap="square" lIns="0" tIns="0" rIns="0" bIns="0" rtlCol="0" anchor="ctr"/>
+          <a:lstStyle/>
+          <a:p>
+            <a:pPr indent="0" marL="0">
+              <a:buNone/>
+            </a:pPr>
+            <a:r>
+              <a:rPr lang="en-US" sz="1250" b="1" dirty="0">
+                <a:solidFill>
+                  <a:srgbClr val="262B38"/>
+                </a:solidFill>
+                <a:latin typeface="Calibri" pitchFamily="34" charset="0"/>
+                <a:ea typeface="Calibri" pitchFamily="34" charset="-122"/>
+                <a:cs typeface="Calibri" pitchFamily="34" charset="-120"/>
+              </a:rPr>
+              <a:t>W_audio — fitted on audio-conditioned states (layer 3)</a:t>
+            </a:r>
+            <a:endParaRPr lang="en-US" sz="1250" dirty="0"/>
+          </a:p>
+        </p:txBody>
+      </p:sp>
+      <p:sp>
+        <p:nvSpPr>
+          <p:cNvPr id="10" name="Text 7"/>
+          <p:cNvSpPr/>
+          <p:nvPr/>
+        </p:nvSpPr>
+        <p:spPr>
+          <a:xfrm>
+            <a:off x="777240" y="2514600"/>
+            <a:ext cx="2194560" cy="685800"/>
+          </a:xfrm>
+          <a:prstGeom prst="rect">
+            <a:avLst/>
+          </a:prstGeom>
+          <a:noFill/>
+          <a:ln/>
+        </p:spPr>
+        <p:txBody>
+          <a:bodyPr wrap="square" lIns="0" tIns="0" rIns="0" bIns="0" rtlCol="0" anchor="ctr"/>
+          <a:lstStyle/>
+          <a:p>
+            <a:pPr indent="0" marL="0">
+              <a:buNone/>
+            </a:pPr>
+            <a:r>
+              <a:rPr lang="en-US" sz="4000" b="1" dirty="0">
+                <a:solidFill>
+                  <a:srgbClr val="2E7D52"/>
                 </a:solidFill>
                 <a:latin typeface="Cambria" pitchFamily="34" charset="0"/>
                 <a:ea typeface="Cambria" pitchFamily="34" charset="-122"/>
                 <a:cs typeface="Cambria" pitchFamily="34" charset="-120"/>
               </a:rPr>
-              <a:t>0</a:t>
-            </a:r>
-            <a:endParaRPr lang="en-US" sz="2000" dirty="0"/>
-          </a:p>
-        </p:txBody>
-      </p:sp>
-      <p:sp>
-        <p:nvSpPr>
-          <p:cNvPr id="9" name="Text 6"/>
-          <p:cNvSpPr/>
-          <p:nvPr/>
-        </p:nvSpPr>
-        <p:spPr>
-          <a:xfrm>
-            <a:off x="640080" y="2834640"/>
-            <a:ext cx="1475232" cy="292608"/>
+              <a:t>1.000</a:t>
+            </a:r>
+            <a:endParaRPr lang="en-US" sz="4000" dirty="0"/>
+          </a:p>
+        </p:txBody>
+      </p:sp>
+      <p:sp>
+        <p:nvSpPr>
+          <p:cNvPr id="11" name="Text 8"/>
+          <p:cNvSpPr/>
+          <p:nvPr/>
+        </p:nvSpPr>
+        <p:spPr>
+          <a:xfrm>
+            <a:off x="3108960" y="2560320"/>
+            <a:ext cx="2651760" cy="1097280"/>
           </a:xfrm>
           <a:prstGeom prst="rect">
             <a:avLst/>
@@ -5786,34 +5955,56 @@
           <a:bodyPr wrap="square" lIns="0" tIns="0" rIns="0" bIns="0" rtlCol="0" anchor="ctr"/>
           <a:lstStyle/>
           <a:p>
-            <a:pPr algn="ctr" indent="0" marL="0">
+            <a:pPr indent="0" marL="0">
               <a:buNone/>
             </a:pPr>
             <a:r>
-              <a:rPr lang="en-US" sz="1300" b="1" dirty="0">
-                <a:solidFill>
-                  <a:srgbClr val="262B38"/>
+              <a:rPr lang="en-US" sz="1100" dirty="0">
+                <a:solidFill>
+                  <a:srgbClr val="5A6272"/>
                 </a:solidFill>
                 <a:latin typeface="Calibri" pitchFamily="34" charset="0"/>
                 <a:ea typeface="Calibri" pitchFamily="34" charset="-122"/>
                 <a:cs typeface="Calibri" pitchFamily="34" charset="-120"/>
               </a:rPr>
-              <a:t>Design</a:t>
-            </a:r>
-            <a:endParaRPr lang="en-US" sz="1300" dirty="0"/>
-          </a:p>
-        </p:txBody>
-      </p:sp>
-      <p:sp>
-        <p:nvSpPr>
-          <p:cNvPr id="10" name="Text 7"/>
-          <p:cNvSpPr/>
-          <p:nvPr/>
-        </p:nvSpPr>
-        <p:spPr>
-          <a:xfrm>
-            <a:off x="640080" y="3127248"/>
-            <a:ext cx="1475232" cy="237744"/>
+              <a:t>held-out top-1 retrieval on BOTH splits (test pools 67 / 71; chance ≈ 1.5%) · paired cosine 0.48–0.51 vs random 0.17–0.19</a:t>
+            </a:r>
+            <a:endParaRPr lang="en-US" sz="1100" dirty="0"/>
+          </a:p>
+        </p:txBody>
+      </p:sp>
+      <p:sp>
+        <p:nvSpPr>
+          <p:cNvPr id="12" name="Shape 9"/>
+          <p:cNvSpPr/>
+          <p:nvPr/>
+        </p:nvSpPr>
+        <p:spPr>
+          <a:xfrm>
+            <a:off x="548640" y="3931920"/>
+            <a:ext cx="5394960" cy="1737360"/>
+          </a:xfrm>
+          <a:prstGeom prst="roundRect">
+            <a:avLst>
+              <a:gd name="adj" fmla="val 4737"/>
+            </a:avLst>
+          </a:prstGeom>
+          <a:solidFill>
+            <a:srgbClr val="EEF4FB"/>
+          </a:solidFill>
+          <a:ln/>
+        </p:spPr>
+      </p:sp>
+      <p:sp>
+        <p:nvSpPr>
+          <p:cNvPr id="13" name="Text 10"/>
+          <p:cNvSpPr/>
+          <p:nvPr/>
+        </p:nvSpPr>
+        <p:spPr>
+          <a:xfrm>
+            <a:off x="777240" y="4087368"/>
+            <a:ext cx="4937760" cy="274320"/>
           </a:xfrm>
           <a:prstGeom prst="rect">
             <a:avLst/>
@@ -5825,34 +6016,34 @@
           <a:bodyPr wrap="square" lIns="0" tIns="0" rIns="0" bIns="0" rtlCol="0" anchor="ctr"/>
           <a:lstStyle/>
           <a:p>
-            <a:pPr algn="ctr" indent="0" marL="0">
+            <a:pPr indent="0" marL="0">
               <a:buNone/>
             </a:pPr>
             <a:r>
-              <a:rPr lang="en-US" sz="900" b="1" spc="100" kern="0" dirty="0">
-                <a:solidFill>
-                  <a:srgbClr val="B07A1E"/>
+              <a:rPr lang="en-US" sz="1250" b="1" dirty="0">
+                <a:solidFill>
+                  <a:srgbClr val="262B38"/>
                 </a:solidFill>
                 <a:latin typeface="Calibri" pitchFamily="34" charset="0"/>
                 <a:ea typeface="Calibri" pitchFamily="34" charset="-122"/>
                 <a:cs typeface="Calibri" pitchFamily="34" charset="-120"/>
               </a:rPr>
-              <a:t>IN REVIEW</a:t>
-            </a:r>
-            <a:endParaRPr lang="en-US" sz="900" dirty="0"/>
-          </a:p>
-        </p:txBody>
-      </p:sp>
-      <p:sp>
-        <p:nvSpPr>
-          <p:cNvPr id="11" name="Text 8"/>
-          <p:cNvSpPr/>
-          <p:nvPr/>
-        </p:nvSpPr>
-        <p:spPr>
-          <a:xfrm>
-            <a:off x="676656" y="3429000"/>
-            <a:ext cx="1402080" cy="1463040"/>
+              <a:t>W_silence (Exp-01) evaluated on the same audio states</a:t>
+            </a:r>
+            <a:endParaRPr lang="en-US" sz="1250" dirty="0"/>
+          </a:p>
+        </p:txBody>
+      </p:sp>
+      <p:sp>
+        <p:nvSpPr>
+          <p:cNvPr id="14" name="Text 11"/>
+          <p:cNvSpPr/>
+          <p:nvPr/>
+        </p:nvSpPr>
+        <p:spPr>
+          <a:xfrm>
+            <a:off x="777240" y="4389120"/>
+            <a:ext cx="2377440" cy="685800"/>
           </a:xfrm>
           <a:prstGeom prst="rect">
             <a:avLst/>
@@ -5864,11 +6055,50 @@
           <a:bodyPr wrap="square" lIns="0" tIns="0" rIns="0" bIns="0" rtlCol="0" anchor="ctr"/>
           <a:lstStyle/>
           <a:p>
-            <a:pPr algn="ctr" indent="0" marL="0">
+            <a:pPr indent="0" marL="0">
               <a:buNone/>
             </a:pPr>
             <a:r>
-              <a:rPr lang="en-US" sz="1000" dirty="0">
+              <a:rPr lang="en-US" sz="3400" b="1" dirty="0">
+                <a:solidFill>
+                  <a:srgbClr val="C94141"/>
+                </a:solidFill>
+                <a:latin typeface="Cambria" pitchFamily="34" charset="0"/>
+                <a:ea typeface="Cambria" pitchFamily="34" charset="-122"/>
+                <a:cs typeface="Cambria" pitchFamily="34" charset="-120"/>
+              </a:rPr>
+              <a:t>0.28 / 0.31</a:t>
+            </a:r>
+            <a:endParaRPr lang="en-US" sz="3400" dirty="0"/>
+          </a:p>
+        </p:txBody>
+      </p:sp>
+      <p:sp>
+        <p:nvSpPr>
+          <p:cNvPr id="15" name="Text 12"/>
+          <p:cNvSpPr/>
+          <p:nvPr/>
+        </p:nvSpPr>
+        <p:spPr>
+          <a:xfrm>
+            <a:off x="3291840" y="4343400"/>
+            <a:ext cx="2468880" cy="1188720"/>
+          </a:xfrm>
+          <a:prstGeom prst="rect">
+            <a:avLst/>
+          </a:prstGeom>
+          <a:noFill/>
+          <a:ln/>
+        </p:spPr>
+        <p:txBody>
+          <a:bodyPr wrap="square" lIns="0" tIns="0" rIns="0" bIns="0" rtlCol="0" anchor="ctr"/>
+          <a:lstStyle/>
+          <a:p>
+            <a:pPr indent="0" marL="0">
+              <a:buNone/>
+            </a:pPr>
+            <a:r>
+              <a:rPr lang="en-US" sz="1100" dirty="0">
                 <a:solidFill>
                   <a:srgbClr val="5A6272"/>
                 </a:solidFill>
@@ -5876,166 +6106,1437 @@
                 <a:ea typeface="Calibri" pitchFamily="34" charset="-122"/>
                 <a:cs typeface="Calibri" pitchFamily="34" charset="-120"/>
               </a:rPr>
-              <a:t>this review — spec v0.1</a:t>
-            </a:r>
-            <a:endParaRPr lang="en-US" sz="1000" dirty="0"/>
-          </a:p>
-        </p:txBody>
-      </p:sp>
-      <p:sp>
-        <p:nvSpPr>
-          <p:cNvPr id="12" name="Shape 9"/>
-          <p:cNvSpPr/>
-          <p:nvPr/>
-        </p:nvSpPr>
-        <p:spPr>
-          <a:xfrm>
-            <a:off x="2206752" y="3474720"/>
-            <a:ext cx="228600" cy="0"/>
-          </a:xfrm>
-          <a:prstGeom prst="line">
+              <a:t>dev-clean / dev-other top-1 at its native layer 4 · paired cosine collapses to ≈ 0.13 — the conditioning mismatch is expensive at deployment</a:t>
+            </a:r>
+            <a:endParaRPr lang="en-US" sz="1100" dirty="0"/>
+          </a:p>
+        </p:txBody>
+      </p:sp>
+      <p:graphicFrame>
+        <p:nvGraphicFramePr>
+          <p:cNvPr id="14" name="Table 0"/>
+          <p:cNvGraphicFramePr>
+            <a:graphicFrameLocks noGrp="1"/>
+          </p:cNvGraphicFramePr>
+          <p:nvPr>
+            <p:extLst>
+              <p:ext uri="{D42A27DB-BD31-4B8C-83A1-F6EECF244321}">
+                <p14:modId xmlns:p14="http://schemas.microsoft.com/office/powerpoint/2010/main" val="1579011935"/>
+              </p:ext>
+            </p:extLst>
+          </p:nvPr>
+        </p:nvGraphicFramePr>
+        <p:xfrm>
+          <a:off x="6309360" y="2057400"/>
+          <a:ext cx="5257800" cy="914400"/>
+        </p:xfrm>
+        <a:graphic>
+          <a:graphicData uri="http://schemas.openxmlformats.org/drawingml/2006/table">
+            <a:tbl>
+              <a:tblPr/>
+              <a:tblGrid>
+                <a:gridCol w="1325880"/>
+                <a:gridCol w="1280160"/>
+                <a:gridCol w="1280160"/>
+                <a:gridCol w="1371600"/>
+              </a:tblGrid>
+              <a:tr h="365760">
+                <a:tc>
+                  <a:txBody>
+                    <a:bodyPr/>
+                    <a:lstStyle/>
+                    <a:p>
+                      <a:pPr algn="ctr" indent="0" marL="0">
+                        <a:buNone/>
+                      </a:pPr>
+                      <a:r>
+                        <a:rPr lang="en-US" sz="1150" b="1" dirty="0">
+                          <a:solidFill>
+                            <a:srgbClr val="FFFFFF"/>
+                          </a:solidFill>
+                          <a:latin typeface="Calibri" pitchFamily="34" charset="0"/>
+                          <a:ea typeface="Calibri" pitchFamily="34" charset="-122"/>
+                          <a:cs typeface="Calibri" pitchFamily="34" charset="-120"/>
+                        </a:rPr>
+                        <a:t>prefix seen</a:t>
+                      </a:r>
+                      <a:endParaRPr lang="en-US" sz="1150" dirty="0">
+                        <a:latin typeface="Calibri" charset="0"/>
+                        <a:ea typeface="Calibri" charset="0"/>
+                        <a:cs typeface="Calibri" charset="0"/>
+                      </a:endParaRPr>
+                    </a:p>
+                  </a:txBody>
+                  <a:tcPr marL="91440" marR="91440" marT="45720" marB="45720" anchor="ctr">
+                    <a:lnL w="12700" cap="flat" cmpd="sng" algn="ctr">
+                      <a:solidFill>
+                        <a:srgbClr val="D8E2F0"/>
+                      </a:solidFill>
+                      <a:prstDash val="solid"/>
+                      <a:round/>
+                      <a:headEnd type="none" w="med" len="med"/>
+                      <a:tailEnd type="none" w="med" len="med"/>
+                    </a:lnL>
+                    <a:lnR w="12700" cap="flat" cmpd="sng" algn="ctr">
+                      <a:solidFill>
+                        <a:srgbClr val="D8E2F0"/>
+                      </a:solidFill>
+                      <a:prstDash val="solid"/>
+                      <a:round/>
+                      <a:headEnd type="none" w="med" len="med"/>
+                      <a:tailEnd type="none" w="med" len="med"/>
+                    </a:lnR>
+                    <a:lnT w="12700" cap="flat" cmpd="sng" algn="ctr">
+                      <a:solidFill>
+                        <a:srgbClr val="D8E2F0"/>
+                      </a:solidFill>
+                      <a:prstDash val="solid"/>
+                      <a:round/>
+                      <a:headEnd type="none" w="med" len="med"/>
+                      <a:tailEnd type="none" w="med" len="med"/>
+                    </a:lnT>
+                    <a:lnB w="12700" cap="flat" cmpd="sng" algn="ctr">
+                      <a:solidFill>
+                        <a:srgbClr val="D8E2F0"/>
+                      </a:solidFill>
+                      <a:prstDash val="solid"/>
+                      <a:round/>
+                      <a:headEnd type="none" w="med" len="med"/>
+                      <a:tailEnd type="none" w="med" len="med"/>
+                    </a:lnB>
+                    <a:solidFill>
+                      <a:srgbClr val="1E2761"/>
+                    </a:solidFill>
+                  </a:tcPr>
+                </a:tc>
+                <a:tc>
+                  <a:txBody>
+                    <a:bodyPr/>
+                    <a:lstStyle/>
+                    <a:p>
+                      <a:pPr algn="ctr" indent="0" marL="0">
+                        <a:buNone/>
+                      </a:pPr>
+                      <a:r>
+                        <a:rPr lang="en-US" sz="1150" b="1" dirty="0">
+                          <a:solidFill>
+                            <a:srgbClr val="FFFFFF"/>
+                          </a:solidFill>
+                          <a:latin typeface="Calibri" pitchFamily="34" charset="0"/>
+                          <a:ea typeface="Calibri" pitchFamily="34" charset="-122"/>
+                          <a:cs typeface="Calibri" pitchFamily="34" charset="-120"/>
+                        </a:rPr>
+                        <a:t>dev-clean</a:t>
+                      </a:r>
+                      <a:endParaRPr lang="en-US" sz="1150" dirty="0">
+                        <a:latin typeface="Calibri" charset="0"/>
+                        <a:ea typeface="Calibri" charset="0"/>
+                        <a:cs typeface="Calibri" charset="0"/>
+                      </a:endParaRPr>
+                    </a:p>
+                  </a:txBody>
+                  <a:tcPr marL="91440" marR="91440" marT="45720" marB="45720" anchor="ctr">
+                    <a:lnL w="12700" cap="flat" cmpd="sng" algn="ctr">
+                      <a:solidFill>
+                        <a:srgbClr val="D8E2F0"/>
+                      </a:solidFill>
+                      <a:prstDash val="solid"/>
+                      <a:round/>
+                      <a:headEnd type="none" w="med" len="med"/>
+                      <a:tailEnd type="none" w="med" len="med"/>
+                    </a:lnL>
+                    <a:lnR w="12700" cap="flat" cmpd="sng" algn="ctr">
+                      <a:solidFill>
+                        <a:srgbClr val="D8E2F0"/>
+                      </a:solidFill>
+                      <a:prstDash val="solid"/>
+                      <a:round/>
+                      <a:headEnd type="none" w="med" len="med"/>
+                      <a:tailEnd type="none" w="med" len="med"/>
+                    </a:lnR>
+                    <a:lnT w="12700" cap="flat" cmpd="sng" algn="ctr">
+                      <a:solidFill>
+                        <a:srgbClr val="D8E2F0"/>
+                      </a:solidFill>
+                      <a:prstDash val="solid"/>
+                      <a:round/>
+                      <a:headEnd type="none" w="med" len="med"/>
+                      <a:tailEnd type="none" w="med" len="med"/>
+                    </a:lnT>
+                    <a:lnB w="12700" cap="flat" cmpd="sng" algn="ctr">
+                      <a:solidFill>
+                        <a:srgbClr val="D8E2F0"/>
+                      </a:solidFill>
+                      <a:prstDash val="solid"/>
+                      <a:round/>
+                      <a:headEnd type="none" w="med" len="med"/>
+                      <a:tailEnd type="none" w="med" len="med"/>
+                    </a:lnB>
+                    <a:solidFill>
+                      <a:srgbClr val="1E2761"/>
+                    </a:solidFill>
+                  </a:tcPr>
+                </a:tc>
+                <a:tc>
+                  <a:txBody>
+                    <a:bodyPr/>
+                    <a:lstStyle/>
+                    <a:p>
+                      <a:pPr algn="ctr" indent="0" marL="0">
+                        <a:buNone/>
+                      </a:pPr>
+                      <a:r>
+                        <a:rPr lang="en-US" sz="1150" b="1" dirty="0">
+                          <a:solidFill>
+                            <a:srgbClr val="FFFFFF"/>
+                          </a:solidFill>
+                          <a:latin typeface="Calibri" pitchFamily="34" charset="0"/>
+                          <a:ea typeface="Calibri" pitchFamily="34" charset="-122"/>
+                          <a:cs typeface="Calibri" pitchFamily="34" charset="-120"/>
+                        </a:rPr>
+                        <a:t>dev-other</a:t>
+                      </a:r>
+                      <a:endParaRPr lang="en-US" sz="1150" dirty="0">
+                        <a:latin typeface="Calibri" charset="0"/>
+                        <a:ea typeface="Calibri" charset="0"/>
+                        <a:cs typeface="Calibri" charset="0"/>
+                      </a:endParaRPr>
+                    </a:p>
+                  </a:txBody>
+                  <a:tcPr marL="91440" marR="91440" marT="45720" marB="45720" anchor="ctr">
+                    <a:lnL w="12700" cap="flat" cmpd="sng" algn="ctr">
+                      <a:solidFill>
+                        <a:srgbClr val="D8E2F0"/>
+                      </a:solidFill>
+                      <a:prstDash val="solid"/>
+                      <a:round/>
+                      <a:headEnd type="none" w="med" len="med"/>
+                      <a:tailEnd type="none" w="med" len="med"/>
+                    </a:lnL>
+                    <a:lnR w="12700" cap="flat" cmpd="sng" algn="ctr">
+                      <a:solidFill>
+                        <a:srgbClr val="D8E2F0"/>
+                      </a:solidFill>
+                      <a:prstDash val="solid"/>
+                      <a:round/>
+                      <a:headEnd type="none" w="med" len="med"/>
+                      <a:tailEnd type="none" w="med" len="med"/>
+                    </a:lnR>
+                    <a:lnT w="12700" cap="flat" cmpd="sng" algn="ctr">
+                      <a:solidFill>
+                        <a:srgbClr val="D8E2F0"/>
+                      </a:solidFill>
+                      <a:prstDash val="solid"/>
+                      <a:round/>
+                      <a:headEnd type="none" w="med" len="med"/>
+                      <a:tailEnd type="none" w="med" len="med"/>
+                    </a:lnT>
+                    <a:lnB w="12700" cap="flat" cmpd="sng" algn="ctr">
+                      <a:solidFill>
+                        <a:srgbClr val="D8E2F0"/>
+                      </a:solidFill>
+                      <a:prstDash val="solid"/>
+                      <a:round/>
+                      <a:headEnd type="none" w="med" len="med"/>
+                      <a:tailEnd type="none" w="med" len="med"/>
+                    </a:lnB>
+                    <a:solidFill>
+                      <a:srgbClr val="1E2761"/>
+                    </a:solidFill>
+                  </a:tcPr>
+                </a:tc>
+                <a:tc>
+                  <a:txBody>
+                    <a:bodyPr/>
+                    <a:lstStyle/>
+                    <a:p>
+                      <a:pPr algn="ctr" indent="0" marL="0">
+                        <a:buNone/>
+                      </a:pPr>
+                      <a:r>
+                        <a:rPr lang="en-US" sz="1150" b="1" dirty="0">
+                          <a:solidFill>
+                            <a:srgbClr val="FFFFFF"/>
+                          </a:solidFill>
+                          <a:latin typeface="Calibri" pitchFamily="34" charset="0"/>
+                          <a:ea typeface="Calibri" pitchFamily="34" charset="-122"/>
+                          <a:cs typeface="Calibri" pitchFamily="34" charset="-120"/>
+                        </a:rPr>
+                        <a:t>Exp-01 (silence)</a:t>
+                      </a:r>
+                      <a:endParaRPr lang="en-US" sz="1150" dirty="0">
+                        <a:latin typeface="Calibri" charset="0"/>
+                        <a:ea typeface="Calibri" charset="0"/>
+                        <a:cs typeface="Calibri" charset="0"/>
+                      </a:endParaRPr>
+                    </a:p>
+                  </a:txBody>
+                  <a:tcPr marL="91440" marR="91440" marT="45720" marB="45720" anchor="ctr">
+                    <a:lnL w="12700" cap="flat" cmpd="sng" algn="ctr">
+                      <a:solidFill>
+                        <a:srgbClr val="D8E2F0"/>
+                      </a:solidFill>
+                      <a:prstDash val="solid"/>
+                      <a:round/>
+                      <a:headEnd type="none" w="med" len="med"/>
+                      <a:tailEnd type="none" w="med" len="med"/>
+                    </a:lnL>
+                    <a:lnR w="12700" cap="flat" cmpd="sng" algn="ctr">
+                      <a:solidFill>
+                        <a:srgbClr val="D8E2F0"/>
+                      </a:solidFill>
+                      <a:prstDash val="solid"/>
+                      <a:round/>
+                      <a:headEnd type="none" w="med" len="med"/>
+                      <a:tailEnd type="none" w="med" len="med"/>
+                    </a:lnR>
+                    <a:lnT w="12700" cap="flat" cmpd="sng" algn="ctr">
+                      <a:solidFill>
+                        <a:srgbClr val="D8E2F0"/>
+                      </a:solidFill>
+                      <a:prstDash val="solid"/>
+                      <a:round/>
+                      <a:headEnd type="none" w="med" len="med"/>
+                      <a:tailEnd type="none" w="med" len="med"/>
+                    </a:lnT>
+                    <a:lnB w="12700" cap="flat" cmpd="sng" algn="ctr">
+                      <a:solidFill>
+                        <a:srgbClr val="D8E2F0"/>
+                      </a:solidFill>
+                      <a:prstDash val="solid"/>
+                      <a:round/>
+                      <a:headEnd type="none" w="med" len="med"/>
+                      <a:tailEnd type="none" w="med" len="med"/>
+                    </a:lnB>
+                    <a:solidFill>
+                      <a:srgbClr val="1E2761"/>
+                    </a:solidFill>
+                  </a:tcPr>
+                </a:tc>
+              </a:tr>
+              <a:tr h="365760">
+                <a:tc>
+                  <a:txBody>
+                    <a:bodyPr/>
+                    <a:lstStyle/>
+                    <a:p>
+                      <a:pPr algn="ctr" indent="0" marL="0">
+                        <a:buNone/>
+                      </a:pPr>
+                      <a:r>
+                        <a:rPr lang="en-US" sz="1150" dirty="0">
+                          <a:solidFill>
+                            <a:srgbClr val="262B38"/>
+                          </a:solidFill>
+                          <a:latin typeface="Calibri" pitchFamily="34" charset="0"/>
+                          <a:ea typeface="Calibri" pitchFamily="34" charset="-122"/>
+                          <a:cs typeface="Calibri" pitchFamily="34" charset="-120"/>
+                        </a:rPr>
+                        <a:t>25%</a:t>
+                      </a:r>
+                      <a:endParaRPr lang="en-US" sz="1150" dirty="0">
+                        <a:latin typeface="Calibri" charset="0"/>
+                        <a:ea typeface="Calibri" charset="0"/>
+                        <a:cs typeface="Calibri" charset="0"/>
+                      </a:endParaRPr>
+                    </a:p>
+                  </a:txBody>
+                  <a:tcPr marL="91440" marR="91440" marT="45720" marB="45720" anchor="ctr">
+                    <a:lnL w="12700" cap="flat" cmpd="sng" algn="ctr">
+                      <a:solidFill>
+                        <a:srgbClr val="D8E2F0"/>
+                      </a:solidFill>
+                      <a:prstDash val="solid"/>
+                      <a:round/>
+                      <a:headEnd type="none" w="med" len="med"/>
+                      <a:tailEnd type="none" w="med" len="med"/>
+                    </a:lnL>
+                    <a:lnR w="12700" cap="flat" cmpd="sng" algn="ctr">
+                      <a:solidFill>
+                        <a:srgbClr val="D8E2F0"/>
+                      </a:solidFill>
+                      <a:prstDash val="solid"/>
+                      <a:round/>
+                      <a:headEnd type="none" w="med" len="med"/>
+                      <a:tailEnd type="none" w="med" len="med"/>
+                    </a:lnR>
+                    <a:lnT w="12700" cap="flat" cmpd="sng" algn="ctr">
+                      <a:solidFill>
+                        <a:srgbClr val="D8E2F0"/>
+                      </a:solidFill>
+                      <a:prstDash val="solid"/>
+                      <a:round/>
+                      <a:headEnd type="none" w="med" len="med"/>
+                      <a:tailEnd type="none" w="med" len="med"/>
+                    </a:lnT>
+                    <a:lnB w="12700" cap="flat" cmpd="sng" algn="ctr">
+                      <a:solidFill>
+                        <a:srgbClr val="D8E2F0"/>
+                      </a:solidFill>
+                      <a:prstDash val="solid"/>
+                      <a:round/>
+                      <a:headEnd type="none" w="med" len="med"/>
+                      <a:tailEnd type="none" w="med" len="med"/>
+                    </a:lnB>
+                  </a:tcPr>
+                </a:tc>
+                <a:tc>
+                  <a:txBody>
+                    <a:bodyPr/>
+                    <a:lstStyle/>
+                    <a:p>
+                      <a:pPr algn="ctr" indent="0" marL="0">
+                        <a:buNone/>
+                      </a:pPr>
+                      <a:r>
+                        <a:rPr lang="en-US" sz="1150" b="1" dirty="0">
+                          <a:solidFill>
+                            <a:srgbClr val="2E7D52"/>
+                          </a:solidFill>
+                          <a:latin typeface="Calibri" pitchFamily="34" charset="0"/>
+                          <a:ea typeface="Calibri" pitchFamily="34" charset="-122"/>
+                          <a:cs typeface="Calibri" pitchFamily="34" charset="-120"/>
+                        </a:rPr>
+                        <a:t>0.388</a:t>
+                      </a:r>
+                      <a:endParaRPr lang="en-US" sz="1150" dirty="0">
+                        <a:latin typeface="Calibri" charset="0"/>
+                        <a:ea typeface="Calibri" charset="0"/>
+                        <a:cs typeface="Calibri" charset="0"/>
+                      </a:endParaRPr>
+                    </a:p>
+                  </a:txBody>
+                  <a:tcPr marL="91440" marR="91440" marT="45720" marB="45720" anchor="ctr">
+                    <a:lnL w="12700" cap="flat" cmpd="sng" algn="ctr">
+                      <a:solidFill>
+                        <a:srgbClr val="D8E2F0"/>
+                      </a:solidFill>
+                      <a:prstDash val="solid"/>
+                      <a:round/>
+                      <a:headEnd type="none" w="med" len="med"/>
+                      <a:tailEnd type="none" w="med" len="med"/>
+                    </a:lnL>
+                    <a:lnR w="12700" cap="flat" cmpd="sng" algn="ctr">
+                      <a:solidFill>
+                        <a:srgbClr val="D8E2F0"/>
+                      </a:solidFill>
+                      <a:prstDash val="solid"/>
+                      <a:round/>
+                      <a:headEnd type="none" w="med" len="med"/>
+                      <a:tailEnd type="none" w="med" len="med"/>
+                    </a:lnR>
+                    <a:lnT w="12700" cap="flat" cmpd="sng" algn="ctr">
+                      <a:solidFill>
+                        <a:srgbClr val="D8E2F0"/>
+                      </a:solidFill>
+                      <a:prstDash val="solid"/>
+                      <a:round/>
+                      <a:headEnd type="none" w="med" len="med"/>
+                      <a:tailEnd type="none" w="med" len="med"/>
+                    </a:lnT>
+                    <a:lnB w="12700" cap="flat" cmpd="sng" algn="ctr">
+                      <a:solidFill>
+                        <a:srgbClr val="D8E2F0"/>
+                      </a:solidFill>
+                      <a:prstDash val="solid"/>
+                      <a:round/>
+                      <a:headEnd type="none" w="med" len="med"/>
+                      <a:tailEnd type="none" w="med" len="med"/>
+                    </a:lnB>
+                  </a:tcPr>
+                </a:tc>
+                <a:tc>
+                  <a:txBody>
+                    <a:bodyPr/>
+                    <a:lstStyle/>
+                    <a:p>
+                      <a:pPr algn="ctr" indent="0" marL="0">
+                        <a:buNone/>
+                      </a:pPr>
+                      <a:r>
+                        <a:rPr lang="en-US" sz="1150" b="1" dirty="0">
+                          <a:solidFill>
+                            <a:srgbClr val="2E7D52"/>
+                          </a:solidFill>
+                          <a:latin typeface="Calibri" pitchFamily="34" charset="0"/>
+                          <a:ea typeface="Calibri" pitchFamily="34" charset="-122"/>
+                          <a:cs typeface="Calibri" pitchFamily="34" charset="-120"/>
+                        </a:rPr>
+                        <a:t>0.409</a:t>
+                      </a:r>
+                      <a:endParaRPr lang="en-US" sz="1150" dirty="0">
+                        <a:latin typeface="Calibri" charset="0"/>
+                        <a:ea typeface="Calibri" charset="0"/>
+                        <a:cs typeface="Calibri" charset="0"/>
+                      </a:endParaRPr>
+                    </a:p>
+                  </a:txBody>
+                  <a:tcPr marL="91440" marR="91440" marT="45720" marB="45720" anchor="ctr">
+                    <a:lnL w="12700" cap="flat" cmpd="sng" algn="ctr">
+                      <a:solidFill>
+                        <a:srgbClr val="D8E2F0"/>
+                      </a:solidFill>
+                      <a:prstDash val="solid"/>
+                      <a:round/>
+                      <a:headEnd type="none" w="med" len="med"/>
+                      <a:tailEnd type="none" w="med" len="med"/>
+                    </a:lnL>
+                    <a:lnR w="12700" cap="flat" cmpd="sng" algn="ctr">
+                      <a:solidFill>
+                        <a:srgbClr val="D8E2F0"/>
+                      </a:solidFill>
+                      <a:prstDash val="solid"/>
+                      <a:round/>
+                      <a:headEnd type="none" w="med" len="med"/>
+                      <a:tailEnd type="none" w="med" len="med"/>
+                    </a:lnR>
+                    <a:lnT w="12700" cap="flat" cmpd="sng" algn="ctr">
+                      <a:solidFill>
+                        <a:srgbClr val="D8E2F0"/>
+                      </a:solidFill>
+                      <a:prstDash val="solid"/>
+                      <a:round/>
+                      <a:headEnd type="none" w="med" len="med"/>
+                      <a:tailEnd type="none" w="med" len="med"/>
+                    </a:lnT>
+                    <a:lnB w="12700" cap="flat" cmpd="sng" algn="ctr">
+                      <a:solidFill>
+                        <a:srgbClr val="D8E2F0"/>
+                      </a:solidFill>
+                      <a:prstDash val="solid"/>
+                      <a:round/>
+                      <a:headEnd type="none" w="med" len="med"/>
+                      <a:tailEnd type="none" w="med" len="med"/>
+                    </a:lnB>
+                  </a:tcPr>
+                </a:tc>
+                <a:tc>
+                  <a:txBody>
+                    <a:bodyPr/>
+                    <a:lstStyle/>
+                    <a:p>
+                      <a:pPr algn="ctr" indent="0" marL="0">
+                        <a:buNone/>
+                      </a:pPr>
+                      <a:r>
+                        <a:rPr lang="en-US" sz="1150" dirty="0">
+                          <a:solidFill>
+                            <a:srgbClr val="262B38"/>
+                          </a:solidFill>
+                          <a:latin typeface="Calibri" pitchFamily="34" charset="0"/>
+                          <a:ea typeface="Calibri" pitchFamily="34" charset="-122"/>
+                          <a:cs typeface="Calibri" pitchFamily="34" charset="-120"/>
+                        </a:rPr>
+                        <a:t>0.290</a:t>
+                      </a:r>
+                      <a:endParaRPr lang="en-US" sz="1150" dirty="0">
+                        <a:latin typeface="Calibri" charset="0"/>
+                        <a:ea typeface="Calibri" charset="0"/>
+                        <a:cs typeface="Calibri" charset="0"/>
+                      </a:endParaRPr>
+                    </a:p>
+                  </a:txBody>
+                  <a:tcPr marL="91440" marR="91440" marT="45720" marB="45720" anchor="ctr">
+                    <a:lnL w="12700" cap="flat" cmpd="sng" algn="ctr">
+                      <a:solidFill>
+                        <a:srgbClr val="D8E2F0"/>
+                      </a:solidFill>
+                      <a:prstDash val="solid"/>
+                      <a:round/>
+                      <a:headEnd type="none" w="med" len="med"/>
+                      <a:tailEnd type="none" w="med" len="med"/>
+                    </a:lnL>
+                    <a:lnR w="12700" cap="flat" cmpd="sng" algn="ctr">
+                      <a:solidFill>
+                        <a:srgbClr val="D8E2F0"/>
+                      </a:solidFill>
+                      <a:prstDash val="solid"/>
+                      <a:round/>
+                      <a:headEnd type="none" w="med" len="med"/>
+                      <a:tailEnd type="none" w="med" len="med"/>
+                    </a:lnR>
+                    <a:lnT w="12700" cap="flat" cmpd="sng" algn="ctr">
+                      <a:solidFill>
+                        <a:srgbClr val="D8E2F0"/>
+                      </a:solidFill>
+                      <a:prstDash val="solid"/>
+                      <a:round/>
+                      <a:headEnd type="none" w="med" len="med"/>
+                      <a:tailEnd type="none" w="med" len="med"/>
+                    </a:lnT>
+                    <a:lnB w="12700" cap="flat" cmpd="sng" algn="ctr">
+                      <a:solidFill>
+                        <a:srgbClr val="D8E2F0"/>
+                      </a:solidFill>
+                      <a:prstDash val="solid"/>
+                      <a:round/>
+                      <a:headEnd type="none" w="med" len="med"/>
+                      <a:tailEnd type="none" w="med" len="med"/>
+                    </a:lnB>
+                  </a:tcPr>
+                </a:tc>
+              </a:tr>
+              <a:tr h="365760">
+                <a:tc>
+                  <a:txBody>
+                    <a:bodyPr/>
+                    <a:lstStyle/>
+                    <a:p>
+                      <a:pPr algn="ctr" indent="0" marL="0">
+                        <a:buNone/>
+                      </a:pPr>
+                      <a:r>
+                        <a:rPr lang="en-US" sz="1150" dirty="0">
+                          <a:solidFill>
+                            <a:srgbClr val="262B38"/>
+                          </a:solidFill>
+                          <a:latin typeface="Calibri" pitchFamily="34" charset="0"/>
+                          <a:ea typeface="Calibri" pitchFamily="34" charset="-122"/>
+                          <a:cs typeface="Calibri" pitchFamily="34" charset="-120"/>
+                        </a:rPr>
+                        <a:t>50%</a:t>
+                      </a:r>
+                      <a:endParaRPr lang="en-US" sz="1150" dirty="0">
+                        <a:latin typeface="Calibri" charset="0"/>
+                        <a:ea typeface="Calibri" charset="0"/>
+                        <a:cs typeface="Calibri" charset="0"/>
+                      </a:endParaRPr>
+                    </a:p>
+                  </a:txBody>
+                  <a:tcPr marL="91440" marR="91440" marT="45720" marB="45720" anchor="ctr">
+                    <a:lnL w="12700" cap="flat" cmpd="sng" algn="ctr">
+                      <a:solidFill>
+                        <a:srgbClr val="D8E2F0"/>
+                      </a:solidFill>
+                      <a:prstDash val="solid"/>
+                      <a:round/>
+                      <a:headEnd type="none" w="med" len="med"/>
+                      <a:tailEnd type="none" w="med" len="med"/>
+                    </a:lnL>
+                    <a:lnR w="12700" cap="flat" cmpd="sng" algn="ctr">
+                      <a:solidFill>
+                        <a:srgbClr val="D8E2F0"/>
+                      </a:solidFill>
+                      <a:prstDash val="solid"/>
+                      <a:round/>
+                      <a:headEnd type="none" w="med" len="med"/>
+                      <a:tailEnd type="none" w="med" len="med"/>
+                    </a:lnR>
+                    <a:lnT w="12700" cap="flat" cmpd="sng" algn="ctr">
+                      <a:solidFill>
+                        <a:srgbClr val="D8E2F0"/>
+                      </a:solidFill>
+                      <a:prstDash val="solid"/>
+                      <a:round/>
+                      <a:headEnd type="none" w="med" len="med"/>
+                      <a:tailEnd type="none" w="med" len="med"/>
+                    </a:lnT>
+                    <a:lnB w="12700" cap="flat" cmpd="sng" algn="ctr">
+                      <a:solidFill>
+                        <a:srgbClr val="D8E2F0"/>
+                      </a:solidFill>
+                      <a:prstDash val="solid"/>
+                      <a:round/>
+                      <a:headEnd type="none" w="med" len="med"/>
+                      <a:tailEnd type="none" w="med" len="med"/>
+                    </a:lnB>
+                  </a:tcPr>
+                </a:tc>
+                <a:tc>
+                  <a:txBody>
+                    <a:bodyPr/>
+                    <a:lstStyle/>
+                    <a:p>
+                      <a:pPr algn="ctr" indent="0" marL="0">
+                        <a:buNone/>
+                      </a:pPr>
+                      <a:r>
+                        <a:rPr lang="en-US" sz="1150" dirty="0">
+                          <a:solidFill>
+                            <a:srgbClr val="262B38"/>
+                          </a:solidFill>
+                          <a:latin typeface="Calibri" pitchFamily="34" charset="0"/>
+                          <a:ea typeface="Calibri" pitchFamily="34" charset="-122"/>
+                          <a:cs typeface="Calibri" pitchFamily="34" charset="-120"/>
+                        </a:rPr>
+                        <a:t>0.836</a:t>
+                      </a:r>
+                      <a:endParaRPr lang="en-US" sz="1150" dirty="0">
+                        <a:latin typeface="Calibri" charset="0"/>
+                        <a:ea typeface="Calibri" charset="0"/>
+                        <a:cs typeface="Calibri" charset="0"/>
+                      </a:endParaRPr>
+                    </a:p>
+                  </a:txBody>
+                  <a:tcPr marL="91440" marR="91440" marT="45720" marB="45720" anchor="ctr">
+                    <a:lnL w="12700" cap="flat" cmpd="sng" algn="ctr">
+                      <a:solidFill>
+                        <a:srgbClr val="D8E2F0"/>
+                      </a:solidFill>
+                      <a:prstDash val="solid"/>
+                      <a:round/>
+                      <a:headEnd type="none" w="med" len="med"/>
+                      <a:tailEnd type="none" w="med" len="med"/>
+                    </a:lnL>
+                    <a:lnR w="12700" cap="flat" cmpd="sng" algn="ctr">
+                      <a:solidFill>
+                        <a:srgbClr val="D8E2F0"/>
+                      </a:solidFill>
+                      <a:prstDash val="solid"/>
+                      <a:round/>
+                      <a:headEnd type="none" w="med" len="med"/>
+                      <a:tailEnd type="none" w="med" len="med"/>
+                    </a:lnR>
+                    <a:lnT w="12700" cap="flat" cmpd="sng" algn="ctr">
+                      <a:solidFill>
+                        <a:srgbClr val="D8E2F0"/>
+                      </a:solidFill>
+                      <a:prstDash val="solid"/>
+                      <a:round/>
+                      <a:headEnd type="none" w="med" len="med"/>
+                      <a:tailEnd type="none" w="med" len="med"/>
+                    </a:lnT>
+                    <a:lnB w="12700" cap="flat" cmpd="sng" algn="ctr">
+                      <a:solidFill>
+                        <a:srgbClr val="D8E2F0"/>
+                      </a:solidFill>
+                      <a:prstDash val="solid"/>
+                      <a:round/>
+                      <a:headEnd type="none" w="med" len="med"/>
+                      <a:tailEnd type="none" w="med" len="med"/>
+                    </a:lnB>
+                  </a:tcPr>
+                </a:tc>
+                <a:tc>
+                  <a:txBody>
+                    <a:bodyPr/>
+                    <a:lstStyle/>
+                    <a:p>
+                      <a:pPr algn="ctr" indent="0" marL="0">
+                        <a:buNone/>
+                      </a:pPr>
+                      <a:r>
+                        <a:rPr lang="en-US" sz="1150" dirty="0">
+                          <a:solidFill>
+                            <a:srgbClr val="262B38"/>
+                          </a:solidFill>
+                          <a:latin typeface="Calibri" pitchFamily="34" charset="0"/>
+                          <a:ea typeface="Calibri" pitchFamily="34" charset="-122"/>
+                          <a:cs typeface="Calibri" pitchFamily="34" charset="-120"/>
+                        </a:rPr>
+                        <a:t>0.775</a:t>
+                      </a:r>
+                      <a:endParaRPr lang="en-US" sz="1150" dirty="0">
+                        <a:latin typeface="Calibri" charset="0"/>
+                        <a:ea typeface="Calibri" charset="0"/>
+                        <a:cs typeface="Calibri" charset="0"/>
+                      </a:endParaRPr>
+                    </a:p>
+                  </a:txBody>
+                  <a:tcPr marL="91440" marR="91440" marT="45720" marB="45720" anchor="ctr">
+                    <a:lnL w="12700" cap="flat" cmpd="sng" algn="ctr">
+                      <a:solidFill>
+                        <a:srgbClr val="D8E2F0"/>
+                      </a:solidFill>
+                      <a:prstDash val="solid"/>
+                      <a:round/>
+                      <a:headEnd type="none" w="med" len="med"/>
+                      <a:tailEnd type="none" w="med" len="med"/>
+                    </a:lnL>
+                    <a:lnR w="12700" cap="flat" cmpd="sng" algn="ctr">
+                      <a:solidFill>
+                        <a:srgbClr val="D8E2F0"/>
+                      </a:solidFill>
+                      <a:prstDash val="solid"/>
+                      <a:round/>
+                      <a:headEnd type="none" w="med" len="med"/>
+                      <a:tailEnd type="none" w="med" len="med"/>
+                    </a:lnR>
+                    <a:lnT w="12700" cap="flat" cmpd="sng" algn="ctr">
+                      <a:solidFill>
+                        <a:srgbClr val="D8E2F0"/>
+                      </a:solidFill>
+                      <a:prstDash val="solid"/>
+                      <a:round/>
+                      <a:headEnd type="none" w="med" len="med"/>
+                      <a:tailEnd type="none" w="med" len="med"/>
+                    </a:lnT>
+                    <a:lnB w="12700" cap="flat" cmpd="sng" algn="ctr">
+                      <a:solidFill>
+                        <a:srgbClr val="D8E2F0"/>
+                      </a:solidFill>
+                      <a:prstDash val="solid"/>
+                      <a:round/>
+                      <a:headEnd type="none" w="med" len="med"/>
+                      <a:tailEnd type="none" w="med" len="med"/>
+                    </a:lnB>
+                  </a:tcPr>
+                </a:tc>
+                <a:tc>
+                  <a:txBody>
+                    <a:bodyPr/>
+                    <a:lstStyle/>
+                    <a:p>
+                      <a:pPr algn="ctr" indent="0" marL="0">
+                        <a:buNone/>
+                      </a:pPr>
+                      <a:r>
+                        <a:rPr lang="en-US" sz="1150" dirty="0">
+                          <a:solidFill>
+                            <a:srgbClr val="262B38"/>
+                          </a:solidFill>
+                          <a:latin typeface="Calibri" pitchFamily="34" charset="0"/>
+                          <a:ea typeface="Calibri" pitchFamily="34" charset="-122"/>
+                          <a:cs typeface="Calibri" pitchFamily="34" charset="-120"/>
+                        </a:rPr>
+                        <a:t>0.765</a:t>
+                      </a:r>
+                      <a:endParaRPr lang="en-US" sz="1150" dirty="0">
+                        <a:latin typeface="Calibri" charset="0"/>
+                        <a:ea typeface="Calibri" charset="0"/>
+                        <a:cs typeface="Calibri" charset="0"/>
+                      </a:endParaRPr>
+                    </a:p>
+                  </a:txBody>
+                  <a:tcPr marL="91440" marR="91440" marT="45720" marB="45720" anchor="ctr">
+                    <a:lnL w="12700" cap="flat" cmpd="sng" algn="ctr">
+                      <a:solidFill>
+                        <a:srgbClr val="D8E2F0"/>
+                      </a:solidFill>
+                      <a:prstDash val="solid"/>
+                      <a:round/>
+                      <a:headEnd type="none" w="med" len="med"/>
+                      <a:tailEnd type="none" w="med" len="med"/>
+                    </a:lnL>
+                    <a:lnR w="12700" cap="flat" cmpd="sng" algn="ctr">
+                      <a:solidFill>
+                        <a:srgbClr val="D8E2F0"/>
+                      </a:solidFill>
+                      <a:prstDash val="solid"/>
+                      <a:round/>
+                      <a:headEnd type="none" w="med" len="med"/>
+                      <a:tailEnd type="none" w="med" len="med"/>
+                    </a:lnR>
+                    <a:lnT w="12700" cap="flat" cmpd="sng" algn="ctr">
+                      <a:solidFill>
+                        <a:srgbClr val="D8E2F0"/>
+                      </a:solidFill>
+                      <a:prstDash val="solid"/>
+                      <a:round/>
+                      <a:headEnd type="none" w="med" len="med"/>
+                      <a:tailEnd type="none" w="med" len="med"/>
+                    </a:lnT>
+                    <a:lnB w="12700" cap="flat" cmpd="sng" algn="ctr">
+                      <a:solidFill>
+                        <a:srgbClr val="D8E2F0"/>
+                      </a:solidFill>
+                      <a:prstDash val="solid"/>
+                      <a:round/>
+                      <a:headEnd type="none" w="med" len="med"/>
+                      <a:tailEnd type="none" w="med" len="med"/>
+                    </a:lnB>
+                  </a:tcPr>
+                </a:tc>
+              </a:tr>
+              <a:tr h="365760">
+                <a:tc>
+                  <a:txBody>
+                    <a:bodyPr/>
+                    <a:lstStyle/>
+                    <a:p>
+                      <a:pPr algn="ctr" indent="0" marL="0">
+                        <a:buNone/>
+                      </a:pPr>
+                      <a:r>
+                        <a:rPr lang="en-US" sz="1150" dirty="0">
+                          <a:solidFill>
+                            <a:srgbClr val="262B38"/>
+                          </a:solidFill>
+                          <a:latin typeface="Calibri" pitchFamily="34" charset="0"/>
+                          <a:ea typeface="Calibri" pitchFamily="34" charset="-122"/>
+                          <a:cs typeface="Calibri" pitchFamily="34" charset="-120"/>
+                        </a:rPr>
+                        <a:t>75%</a:t>
+                      </a:r>
+                      <a:endParaRPr lang="en-US" sz="1150" dirty="0">
+                        <a:latin typeface="Calibri" charset="0"/>
+                        <a:ea typeface="Calibri" charset="0"/>
+                        <a:cs typeface="Calibri" charset="0"/>
+                      </a:endParaRPr>
+                    </a:p>
+                  </a:txBody>
+                  <a:tcPr marL="91440" marR="91440" marT="45720" marB="45720" anchor="ctr">
+                    <a:lnL w="12700" cap="flat" cmpd="sng" algn="ctr">
+                      <a:solidFill>
+                        <a:srgbClr val="D8E2F0"/>
+                      </a:solidFill>
+                      <a:prstDash val="solid"/>
+                      <a:round/>
+                      <a:headEnd type="none" w="med" len="med"/>
+                      <a:tailEnd type="none" w="med" len="med"/>
+                    </a:lnL>
+                    <a:lnR w="12700" cap="flat" cmpd="sng" algn="ctr">
+                      <a:solidFill>
+                        <a:srgbClr val="D8E2F0"/>
+                      </a:solidFill>
+                      <a:prstDash val="solid"/>
+                      <a:round/>
+                      <a:headEnd type="none" w="med" len="med"/>
+                      <a:tailEnd type="none" w="med" len="med"/>
+                    </a:lnR>
+                    <a:lnT w="12700" cap="flat" cmpd="sng" algn="ctr">
+                      <a:solidFill>
+                        <a:srgbClr val="D8E2F0"/>
+                      </a:solidFill>
+                      <a:prstDash val="solid"/>
+                      <a:round/>
+                      <a:headEnd type="none" w="med" len="med"/>
+                      <a:tailEnd type="none" w="med" len="med"/>
+                    </a:lnT>
+                    <a:lnB w="12700" cap="flat" cmpd="sng" algn="ctr">
+                      <a:solidFill>
+                        <a:srgbClr val="D8E2F0"/>
+                      </a:solidFill>
+                      <a:prstDash val="solid"/>
+                      <a:round/>
+                      <a:headEnd type="none" w="med" len="med"/>
+                      <a:tailEnd type="none" w="med" len="med"/>
+                    </a:lnB>
+                  </a:tcPr>
+                </a:tc>
+                <a:tc>
+                  <a:txBody>
+                    <a:bodyPr/>
+                    <a:lstStyle/>
+                    <a:p>
+                      <a:pPr algn="ctr" indent="0" marL="0">
+                        <a:buNone/>
+                      </a:pPr>
+                      <a:r>
+                        <a:rPr lang="en-US" sz="1150" dirty="0">
+                          <a:solidFill>
+                            <a:srgbClr val="262B38"/>
+                          </a:solidFill>
+                          <a:latin typeface="Calibri" pitchFamily="34" charset="0"/>
+                          <a:ea typeface="Calibri" pitchFamily="34" charset="-122"/>
+                          <a:cs typeface="Calibri" pitchFamily="34" charset="-120"/>
+                        </a:rPr>
+                        <a:t>0.970</a:t>
+                      </a:r>
+                      <a:endParaRPr lang="en-US" sz="1150" dirty="0">
+                        <a:latin typeface="Calibri" charset="0"/>
+                        <a:ea typeface="Calibri" charset="0"/>
+                        <a:cs typeface="Calibri" charset="0"/>
+                      </a:endParaRPr>
+                    </a:p>
+                  </a:txBody>
+                  <a:tcPr marL="91440" marR="91440" marT="45720" marB="45720" anchor="ctr">
+                    <a:lnL w="12700" cap="flat" cmpd="sng" algn="ctr">
+                      <a:solidFill>
+                        <a:srgbClr val="D8E2F0"/>
+                      </a:solidFill>
+                      <a:prstDash val="solid"/>
+                      <a:round/>
+                      <a:headEnd type="none" w="med" len="med"/>
+                      <a:tailEnd type="none" w="med" len="med"/>
+                    </a:lnL>
+                    <a:lnR w="12700" cap="flat" cmpd="sng" algn="ctr">
+                      <a:solidFill>
+                        <a:srgbClr val="D8E2F0"/>
+                      </a:solidFill>
+                      <a:prstDash val="solid"/>
+                      <a:round/>
+                      <a:headEnd type="none" w="med" len="med"/>
+                      <a:tailEnd type="none" w="med" len="med"/>
+                    </a:lnR>
+                    <a:lnT w="12700" cap="flat" cmpd="sng" algn="ctr">
+                      <a:solidFill>
+                        <a:srgbClr val="D8E2F0"/>
+                      </a:solidFill>
+                      <a:prstDash val="solid"/>
+                      <a:round/>
+                      <a:headEnd type="none" w="med" len="med"/>
+                      <a:tailEnd type="none" w="med" len="med"/>
+                    </a:lnT>
+                    <a:lnB w="12700" cap="flat" cmpd="sng" algn="ctr">
+                      <a:solidFill>
+                        <a:srgbClr val="D8E2F0"/>
+                      </a:solidFill>
+                      <a:prstDash val="solid"/>
+                      <a:round/>
+                      <a:headEnd type="none" w="med" len="med"/>
+                      <a:tailEnd type="none" w="med" len="med"/>
+                    </a:lnB>
+                  </a:tcPr>
+                </a:tc>
+                <a:tc>
+                  <a:txBody>
+                    <a:bodyPr/>
+                    <a:lstStyle/>
+                    <a:p>
+                      <a:pPr algn="ctr" indent="0" marL="0">
+                        <a:buNone/>
+                      </a:pPr>
+                      <a:r>
+                        <a:rPr lang="en-US" sz="1150" dirty="0">
+                          <a:solidFill>
+                            <a:srgbClr val="262B38"/>
+                          </a:solidFill>
+                          <a:latin typeface="Calibri" pitchFamily="34" charset="0"/>
+                          <a:ea typeface="Calibri" pitchFamily="34" charset="-122"/>
+                          <a:cs typeface="Calibri" pitchFamily="34" charset="-120"/>
+                        </a:rPr>
+                        <a:t>0.958</a:t>
+                      </a:r>
+                      <a:endParaRPr lang="en-US" sz="1150" dirty="0">
+                        <a:latin typeface="Calibri" charset="0"/>
+                        <a:ea typeface="Calibri" charset="0"/>
+                        <a:cs typeface="Calibri" charset="0"/>
+                      </a:endParaRPr>
+                    </a:p>
+                  </a:txBody>
+                  <a:tcPr marL="91440" marR="91440" marT="45720" marB="45720" anchor="ctr">
+                    <a:lnL w="12700" cap="flat" cmpd="sng" algn="ctr">
+                      <a:solidFill>
+                        <a:srgbClr val="D8E2F0"/>
+                      </a:solidFill>
+                      <a:prstDash val="solid"/>
+                      <a:round/>
+                      <a:headEnd type="none" w="med" len="med"/>
+                      <a:tailEnd type="none" w="med" len="med"/>
+                    </a:lnL>
+                    <a:lnR w="12700" cap="flat" cmpd="sng" algn="ctr">
+                      <a:solidFill>
+                        <a:srgbClr val="D8E2F0"/>
+                      </a:solidFill>
+                      <a:prstDash val="solid"/>
+                      <a:round/>
+                      <a:headEnd type="none" w="med" len="med"/>
+                      <a:tailEnd type="none" w="med" len="med"/>
+                    </a:lnR>
+                    <a:lnT w="12700" cap="flat" cmpd="sng" algn="ctr">
+                      <a:solidFill>
+                        <a:srgbClr val="D8E2F0"/>
+                      </a:solidFill>
+                      <a:prstDash val="solid"/>
+                      <a:round/>
+                      <a:headEnd type="none" w="med" len="med"/>
+                      <a:tailEnd type="none" w="med" len="med"/>
+                    </a:lnT>
+                    <a:lnB w="12700" cap="flat" cmpd="sng" algn="ctr">
+                      <a:solidFill>
+                        <a:srgbClr val="D8E2F0"/>
+                      </a:solidFill>
+                      <a:prstDash val="solid"/>
+                      <a:round/>
+                      <a:headEnd type="none" w="med" len="med"/>
+                      <a:tailEnd type="none" w="med" len="med"/>
+                    </a:lnB>
+                  </a:tcPr>
+                </a:tc>
+                <a:tc>
+                  <a:txBody>
+                    <a:bodyPr/>
+                    <a:lstStyle/>
+                    <a:p>
+                      <a:pPr algn="ctr" indent="0" marL="0">
+                        <a:buNone/>
+                      </a:pPr>
+                      <a:r>
+                        <a:rPr lang="en-US" sz="1150" dirty="0">
+                          <a:solidFill>
+                            <a:srgbClr val="262B38"/>
+                          </a:solidFill>
+                          <a:latin typeface="Calibri" pitchFamily="34" charset="0"/>
+                          <a:ea typeface="Calibri" pitchFamily="34" charset="-122"/>
+                          <a:cs typeface="Calibri" pitchFamily="34" charset="-120"/>
+                        </a:rPr>
+                        <a:t>0.975</a:t>
+                      </a:r>
+                      <a:endParaRPr lang="en-US" sz="1150" dirty="0">
+                        <a:latin typeface="Calibri" charset="0"/>
+                        <a:ea typeface="Calibri" charset="0"/>
+                        <a:cs typeface="Calibri" charset="0"/>
+                      </a:endParaRPr>
+                    </a:p>
+                  </a:txBody>
+                  <a:tcPr marL="91440" marR="91440" marT="45720" marB="45720" anchor="ctr">
+                    <a:lnL w="12700" cap="flat" cmpd="sng" algn="ctr">
+                      <a:solidFill>
+                        <a:srgbClr val="D8E2F0"/>
+                      </a:solidFill>
+                      <a:prstDash val="solid"/>
+                      <a:round/>
+                      <a:headEnd type="none" w="med" len="med"/>
+                      <a:tailEnd type="none" w="med" len="med"/>
+                    </a:lnL>
+                    <a:lnR w="12700" cap="flat" cmpd="sng" algn="ctr">
+                      <a:solidFill>
+                        <a:srgbClr val="D8E2F0"/>
+                      </a:solidFill>
+                      <a:prstDash val="solid"/>
+                      <a:round/>
+                      <a:headEnd type="none" w="med" len="med"/>
+                      <a:tailEnd type="none" w="med" len="med"/>
+                    </a:lnR>
+                    <a:lnT w="12700" cap="flat" cmpd="sng" algn="ctr">
+                      <a:solidFill>
+                        <a:srgbClr val="D8E2F0"/>
+                      </a:solidFill>
+                      <a:prstDash val="solid"/>
+                      <a:round/>
+                      <a:headEnd type="none" w="med" len="med"/>
+                      <a:tailEnd type="none" w="med" len="med"/>
+                    </a:lnT>
+                    <a:lnB w="12700" cap="flat" cmpd="sng" algn="ctr">
+                      <a:solidFill>
+                        <a:srgbClr val="D8E2F0"/>
+                      </a:solidFill>
+                      <a:prstDash val="solid"/>
+                      <a:round/>
+                      <a:headEnd type="none" w="med" len="med"/>
+                      <a:tailEnd type="none" w="med" len="med"/>
+                    </a:lnB>
+                  </a:tcPr>
+                </a:tc>
+              </a:tr>
+              <a:tr h="365760">
+                <a:tc>
+                  <a:txBody>
+                    <a:bodyPr/>
+                    <a:lstStyle/>
+                    <a:p>
+                      <a:pPr algn="ctr" indent="0" marL="0">
+                        <a:buNone/>
+                      </a:pPr>
+                      <a:r>
+                        <a:rPr lang="en-US" sz="1150" dirty="0">
+                          <a:solidFill>
+                            <a:srgbClr val="262B38"/>
+                          </a:solidFill>
+                          <a:latin typeface="Calibri" pitchFamily="34" charset="0"/>
+                          <a:ea typeface="Calibri" pitchFamily="34" charset="-122"/>
+                          <a:cs typeface="Calibri" pitchFamily="34" charset="-120"/>
+                        </a:rPr>
+                        <a:t>100%</a:t>
+                      </a:r>
+                      <a:endParaRPr lang="en-US" sz="1150" dirty="0">
+                        <a:latin typeface="Calibri" charset="0"/>
+                        <a:ea typeface="Calibri" charset="0"/>
+                        <a:cs typeface="Calibri" charset="0"/>
+                      </a:endParaRPr>
+                    </a:p>
+                  </a:txBody>
+                  <a:tcPr marL="91440" marR="91440" marT="45720" marB="45720" anchor="ctr">
+                    <a:lnL w="12700" cap="flat" cmpd="sng" algn="ctr">
+                      <a:solidFill>
+                        <a:srgbClr val="D8E2F0"/>
+                      </a:solidFill>
+                      <a:prstDash val="solid"/>
+                      <a:round/>
+                      <a:headEnd type="none" w="med" len="med"/>
+                      <a:tailEnd type="none" w="med" len="med"/>
+                    </a:lnL>
+                    <a:lnR w="12700" cap="flat" cmpd="sng" algn="ctr">
+                      <a:solidFill>
+                        <a:srgbClr val="D8E2F0"/>
+                      </a:solidFill>
+                      <a:prstDash val="solid"/>
+                      <a:round/>
+                      <a:headEnd type="none" w="med" len="med"/>
+                      <a:tailEnd type="none" w="med" len="med"/>
+                    </a:lnR>
+                    <a:lnT w="12700" cap="flat" cmpd="sng" algn="ctr">
+                      <a:solidFill>
+                        <a:srgbClr val="D8E2F0"/>
+                      </a:solidFill>
+                      <a:prstDash val="solid"/>
+                      <a:round/>
+                      <a:headEnd type="none" w="med" len="med"/>
+                      <a:tailEnd type="none" w="med" len="med"/>
+                    </a:lnT>
+                    <a:lnB w="12700" cap="flat" cmpd="sng" algn="ctr">
+                      <a:solidFill>
+                        <a:srgbClr val="D8E2F0"/>
+                      </a:solidFill>
+                      <a:prstDash val="solid"/>
+                      <a:round/>
+                      <a:headEnd type="none" w="med" len="med"/>
+                      <a:tailEnd type="none" w="med" len="med"/>
+                    </a:lnB>
+                  </a:tcPr>
+                </a:tc>
+                <a:tc>
+                  <a:txBody>
+                    <a:bodyPr/>
+                    <a:lstStyle/>
+                    <a:p>
+                      <a:pPr algn="ctr" indent="0" marL="0">
+                        <a:buNone/>
+                      </a:pPr>
+                      <a:r>
+                        <a:rPr lang="en-US" sz="1150" dirty="0">
+                          <a:solidFill>
+                            <a:srgbClr val="262B38"/>
+                          </a:solidFill>
+                          <a:latin typeface="Calibri" pitchFamily="34" charset="0"/>
+                          <a:ea typeface="Calibri" pitchFamily="34" charset="-122"/>
+                          <a:cs typeface="Calibri" pitchFamily="34" charset="-120"/>
+                        </a:rPr>
+                        <a:t>1.000</a:t>
+                      </a:r>
+                      <a:endParaRPr lang="en-US" sz="1150" dirty="0">
+                        <a:latin typeface="Calibri" charset="0"/>
+                        <a:ea typeface="Calibri" charset="0"/>
+                        <a:cs typeface="Calibri" charset="0"/>
+                      </a:endParaRPr>
+                    </a:p>
+                  </a:txBody>
+                  <a:tcPr marL="91440" marR="91440" marT="45720" marB="45720" anchor="ctr">
+                    <a:lnL w="12700" cap="flat" cmpd="sng" algn="ctr">
+                      <a:solidFill>
+                        <a:srgbClr val="D8E2F0"/>
+                      </a:solidFill>
+                      <a:prstDash val="solid"/>
+                      <a:round/>
+                      <a:headEnd type="none" w="med" len="med"/>
+                      <a:tailEnd type="none" w="med" len="med"/>
+                    </a:lnL>
+                    <a:lnR w="12700" cap="flat" cmpd="sng" algn="ctr">
+                      <a:solidFill>
+                        <a:srgbClr val="D8E2F0"/>
+                      </a:solidFill>
+                      <a:prstDash val="solid"/>
+                      <a:round/>
+                      <a:headEnd type="none" w="med" len="med"/>
+                      <a:tailEnd type="none" w="med" len="med"/>
+                    </a:lnR>
+                    <a:lnT w="12700" cap="flat" cmpd="sng" algn="ctr">
+                      <a:solidFill>
+                        <a:srgbClr val="D8E2F0"/>
+                      </a:solidFill>
+                      <a:prstDash val="solid"/>
+                      <a:round/>
+                      <a:headEnd type="none" w="med" len="med"/>
+                      <a:tailEnd type="none" w="med" len="med"/>
+                    </a:lnT>
+                    <a:lnB w="12700" cap="flat" cmpd="sng" algn="ctr">
+                      <a:solidFill>
+                        <a:srgbClr val="D8E2F0"/>
+                      </a:solidFill>
+                      <a:prstDash val="solid"/>
+                      <a:round/>
+                      <a:headEnd type="none" w="med" len="med"/>
+                      <a:tailEnd type="none" w="med" len="med"/>
+                    </a:lnB>
+                  </a:tcPr>
+                </a:tc>
+                <a:tc>
+                  <a:txBody>
+                    <a:bodyPr/>
+                    <a:lstStyle/>
+                    <a:p>
+                      <a:pPr algn="ctr" indent="0" marL="0">
+                        <a:buNone/>
+                      </a:pPr>
+                      <a:r>
+                        <a:rPr lang="en-US" sz="1150" dirty="0">
+                          <a:solidFill>
+                            <a:srgbClr val="262B38"/>
+                          </a:solidFill>
+                          <a:latin typeface="Calibri" pitchFamily="34" charset="0"/>
+                          <a:ea typeface="Calibri" pitchFamily="34" charset="-122"/>
+                          <a:cs typeface="Calibri" pitchFamily="34" charset="-120"/>
+                        </a:rPr>
+                        <a:t>1.000</a:t>
+                      </a:r>
+                      <a:endParaRPr lang="en-US" sz="1150" dirty="0">
+                        <a:latin typeface="Calibri" charset="0"/>
+                        <a:ea typeface="Calibri" charset="0"/>
+                        <a:cs typeface="Calibri" charset="0"/>
+                      </a:endParaRPr>
+                    </a:p>
+                  </a:txBody>
+                  <a:tcPr marL="91440" marR="91440" marT="45720" marB="45720" anchor="ctr">
+                    <a:lnL w="12700" cap="flat" cmpd="sng" algn="ctr">
+                      <a:solidFill>
+                        <a:srgbClr val="D8E2F0"/>
+                      </a:solidFill>
+                      <a:prstDash val="solid"/>
+                      <a:round/>
+                      <a:headEnd type="none" w="med" len="med"/>
+                      <a:tailEnd type="none" w="med" len="med"/>
+                    </a:lnL>
+                    <a:lnR w="12700" cap="flat" cmpd="sng" algn="ctr">
+                      <a:solidFill>
+                        <a:srgbClr val="D8E2F0"/>
+                      </a:solidFill>
+                      <a:prstDash val="solid"/>
+                      <a:round/>
+                      <a:headEnd type="none" w="med" len="med"/>
+                      <a:tailEnd type="none" w="med" len="med"/>
+                    </a:lnR>
+                    <a:lnT w="12700" cap="flat" cmpd="sng" algn="ctr">
+                      <a:solidFill>
+                        <a:srgbClr val="D8E2F0"/>
+                      </a:solidFill>
+                      <a:prstDash val="solid"/>
+                      <a:round/>
+                      <a:headEnd type="none" w="med" len="med"/>
+                      <a:tailEnd type="none" w="med" len="med"/>
+                    </a:lnT>
+                    <a:lnB w="12700" cap="flat" cmpd="sng" algn="ctr">
+                      <a:solidFill>
+                        <a:srgbClr val="D8E2F0"/>
+                      </a:solidFill>
+                      <a:prstDash val="solid"/>
+                      <a:round/>
+                      <a:headEnd type="none" w="med" len="med"/>
+                      <a:tailEnd type="none" w="med" len="med"/>
+                    </a:lnB>
+                  </a:tcPr>
+                </a:tc>
+                <a:tc>
+                  <a:txBody>
+                    <a:bodyPr/>
+                    <a:lstStyle/>
+                    <a:p>
+                      <a:pPr algn="ctr" indent="0" marL="0">
+                        <a:buNone/>
+                      </a:pPr>
+                      <a:r>
+                        <a:rPr lang="en-US" sz="1150" dirty="0">
+                          <a:solidFill>
+                            <a:srgbClr val="262B38"/>
+                          </a:solidFill>
+                          <a:latin typeface="Calibri" pitchFamily="34" charset="0"/>
+                          <a:ea typeface="Calibri" pitchFamily="34" charset="-122"/>
+                          <a:cs typeface="Calibri" pitchFamily="34" charset="-120"/>
+                        </a:rPr>
+                        <a:t>1.000</a:t>
+                      </a:r>
+                      <a:endParaRPr lang="en-US" sz="1150" dirty="0">
+                        <a:latin typeface="Calibri" charset="0"/>
+                        <a:ea typeface="Calibri" charset="0"/>
+                        <a:cs typeface="Calibri" charset="0"/>
+                      </a:endParaRPr>
+                    </a:p>
+                  </a:txBody>
+                  <a:tcPr marL="91440" marR="91440" marT="45720" marB="45720" anchor="ctr">
+                    <a:lnL w="12700" cap="flat" cmpd="sng" algn="ctr">
+                      <a:solidFill>
+                        <a:srgbClr val="D8E2F0"/>
+                      </a:solidFill>
+                      <a:prstDash val="solid"/>
+                      <a:round/>
+                      <a:headEnd type="none" w="med" len="med"/>
+                      <a:tailEnd type="none" w="med" len="med"/>
+                    </a:lnL>
+                    <a:lnR w="12700" cap="flat" cmpd="sng" algn="ctr">
+                      <a:solidFill>
+                        <a:srgbClr val="D8E2F0"/>
+                      </a:solidFill>
+                      <a:prstDash val="solid"/>
+                      <a:round/>
+                      <a:headEnd type="none" w="med" len="med"/>
+                      <a:tailEnd type="none" w="med" len="med"/>
+                    </a:lnR>
+                    <a:lnT w="12700" cap="flat" cmpd="sng" algn="ctr">
+                      <a:solidFill>
+                        <a:srgbClr val="D8E2F0"/>
+                      </a:solidFill>
+                      <a:prstDash val="solid"/>
+                      <a:round/>
+                      <a:headEnd type="none" w="med" len="med"/>
+                      <a:tailEnd type="none" w="med" len="med"/>
+                    </a:lnT>
+                    <a:lnB w="12700" cap="flat" cmpd="sng" algn="ctr">
+                      <a:solidFill>
+                        <a:srgbClr val="D8E2F0"/>
+                      </a:solidFill>
+                      <a:prstDash val="solid"/>
+                      <a:round/>
+                      <a:headEnd type="none" w="med" len="med"/>
+                      <a:tailEnd type="none" w="med" len="med"/>
+                    </a:lnB>
+                  </a:tcPr>
+                </a:tc>
+              </a:tr>
+            </a:tbl>
+          </a:graphicData>
+        </a:graphic>
+      </p:graphicFrame>
+      <p:sp>
+        <p:nvSpPr>
+          <p:cNvPr id="17" name="Text 13"/>
+          <p:cNvSpPr/>
+          <p:nvPr/>
+        </p:nvSpPr>
+        <p:spPr>
+          <a:xfrm>
+            <a:off x="6309360" y="4069080"/>
+            <a:ext cx="5257800" cy="1005840"/>
+          </a:xfrm>
+          <a:prstGeom prst="rect">
             <a:avLst/>
           </a:prstGeom>
           <a:noFill/>
-          <a:ln w="22225">
-            <a:solidFill>
-              <a:srgbClr val="1E2761"/>
-            </a:solidFill>
-            <a:prstDash val="solid"/>
-            <a:tailEnd type="arrow"/>
-          </a:ln>
-        </p:spPr>
-      </p:sp>
-      <p:sp>
-        <p:nvSpPr>
-          <p:cNvPr id="13" name="Shape 10"/>
-          <p:cNvSpPr/>
-          <p:nvPr/>
-        </p:nvSpPr>
-        <p:spPr>
-          <a:xfrm>
-            <a:off x="2435352" y="1920240"/>
-            <a:ext cx="1658112" cy="3108960"/>
-          </a:xfrm>
-          <a:prstGeom prst="roundRect">
-            <a:avLst>
-              <a:gd name="adj" fmla="val 4963"/>
-            </a:avLst>
-          </a:prstGeom>
-          <a:solidFill>
-            <a:srgbClr val="EEF4FB"/>
-          </a:solidFill>
-          <a:ln/>
-        </p:spPr>
-      </p:sp>
-      <p:sp>
-        <p:nvSpPr>
-          <p:cNvPr id="14" name="Shape 11"/>
-          <p:cNvSpPr/>
-          <p:nvPr/>
-        </p:nvSpPr>
-        <p:spPr>
-          <a:xfrm>
-            <a:off x="2990088" y="2148840"/>
-            <a:ext cx="548640" cy="548640"/>
-          </a:xfrm>
-          <a:prstGeom prst="ellipse">
-            <a:avLst/>
-          </a:prstGeom>
-          <a:solidFill>
-            <a:srgbClr val="1E2761"/>
-          </a:solidFill>
-          <a:ln/>
-        </p:spPr>
-      </p:sp>
-      <p:sp>
-        <p:nvSpPr>
-          <p:cNvPr id="15" name="Text 12"/>
-          <p:cNvSpPr/>
-          <p:nvPr/>
-        </p:nvSpPr>
-        <p:spPr>
-          <a:xfrm>
-            <a:off x="2990088" y="2176272"/>
-            <a:ext cx="548640" cy="502920"/>
-          </a:xfrm>
-          <a:prstGeom prst="rect">
-            <a:avLst/>
-          </a:prstGeom>
-          <a:noFill/>
           <a:ln/>
         </p:spPr>
         <p:txBody>
           <a:bodyPr wrap="square" lIns="0" tIns="0" rIns="0" bIns="0" rtlCol="0" anchor="ctr"/>
           <a:lstStyle/>
           <a:p>
-            <a:pPr algn="ctr" indent="0" marL="0">
+            <a:pPr indent="0" marL="0">
               <a:buNone/>
             </a:pPr>
             <a:r>
-              <a:rPr lang="en-US" sz="2000" b="1" dirty="0">
-                <a:solidFill>
-                  <a:srgbClr val="FFFFFF"/>
-                </a:solidFill>
-                <a:latin typeface="Cambria" pitchFamily="34" charset="0"/>
-                <a:ea typeface="Cambria" pitchFamily="34" charset="-122"/>
-                <a:cs typeface="Cambria" pitchFamily="34" charset="-120"/>
-              </a:rPr>
-              <a:t>1</a:t>
-            </a:r>
-            <a:endParaRPr lang="en-US" sz="2000" dirty="0"/>
-          </a:p>
-        </p:txBody>
-      </p:sp>
-      <p:sp>
-        <p:nvSpPr>
-          <p:cNvPr id="16" name="Text 13"/>
-          <p:cNvSpPr/>
-          <p:nvPr/>
-        </p:nvSpPr>
-        <p:spPr>
-          <a:xfrm>
-            <a:off x="2526792" y="2834640"/>
-            <a:ext cx="1475232" cy="292608"/>
-          </a:xfrm>
-          <a:prstGeom prst="rect">
-            <a:avLst/>
-          </a:prstGeom>
-          <a:noFill/>
-          <a:ln/>
-        </p:spPr>
-        <p:txBody>
-          <a:bodyPr wrap="square" lIns="0" tIns="0" rIns="0" bIns="0" rtlCol="0" anchor="ctr"/>
-          <a:lstStyle/>
-          <a:p>
-            <a:pPr algn="ctr" indent="0" marL="0">
-              <a:buNone/>
-            </a:pPr>
-            <a:r>
-              <a:rPr lang="en-US" sz="1300" b="1" dirty="0">
-                <a:solidFill>
-                  <a:srgbClr val="262B38"/>
+              <a:rPr lang="en-US" sz="1150" i="1" dirty="0">
+                <a:solidFill>
+                  <a:srgbClr val="5A6272"/>
                 </a:solidFill>
                 <a:latin typeface="Calibri" pitchFamily="34" charset="0"/>
                 <a:ea typeface="Calibri" pitchFamily="34" charset="-122"/>
                 <a:cs typeface="Calibri" pitchFamily="34" charset="-120"/>
               </a:rPr>
-              <a:t>Baseline</a:t>
-            </a:r>
-            <a:endParaRPr lang="en-US" sz="1300" dirty="0"/>
-          </a:p>
-        </p:txBody>
-      </p:sp>
-      <p:sp>
-        <p:nvSpPr>
-          <p:cNvPr id="17" name="Text 14"/>
-          <p:cNvSpPr/>
-          <p:nvPr/>
-        </p:nvSpPr>
-        <p:spPr>
-          <a:xfrm>
-            <a:off x="2526792" y="3127248"/>
-            <a:ext cx="1475232" cy="237744"/>
+              <a:t>Prefix probe (top-1, W_audio): the early-decode regime — 25% of the sentence, where biasing decisions actually fire — gains ~10 points under audio conditioning. Cross-attention gives the decoder whole-utterance acoustic evidence from step one.</a:t>
+            </a:r>
+            <a:endParaRPr lang="en-US" sz="1150" dirty="0"/>
+          </a:p>
+        </p:txBody>
+      </p:sp>
+      <p:sp>
+        <p:nvSpPr>
+          <p:cNvPr id="18" name="Shape 14"/>
+          <p:cNvSpPr/>
+          <p:nvPr/>
+        </p:nvSpPr>
+        <p:spPr>
+          <a:xfrm>
+            <a:off x="548640" y="5806440"/>
+            <a:ext cx="11091672" cy="777240"/>
+          </a:xfrm>
+          <a:prstGeom prst="roundRect">
+            <a:avLst>
+              <a:gd name="adj" fmla="val 10588"/>
+            </a:avLst>
+          </a:prstGeom>
+          <a:solidFill>
+            <a:srgbClr val="E7F3EC"/>
+          </a:solidFill>
+          <a:ln/>
+        </p:spPr>
+      </p:sp>
+      <p:sp>
+        <p:nvSpPr>
+          <p:cNvPr id="19" name="Text 15"/>
+          <p:cNvSpPr/>
+          <p:nvPr/>
+        </p:nvSpPr>
+        <p:spPr>
+          <a:xfrm>
+            <a:off x="822960" y="5925312"/>
+            <a:ext cx="10543032" cy="594360"/>
           </a:xfrm>
           <a:prstGeom prst="rect">
             <a:avLst/>
@@ -6047,987 +7548,35 @@
           <a:bodyPr wrap="square" lIns="0" tIns="0" rIns="0" bIns="0" rtlCol="0" anchor="ctr"/>
           <a:lstStyle/>
           <a:p>
-            <a:pPr algn="ctr" indent="0" marL="0">
+            <a:pPr indent="0" marL="0">
               <a:buNone/>
             </a:pPr>
             <a:r>
-              <a:rPr lang="en-US" sz="900" b="1" spc="100" kern="0" dirty="0">
-                <a:solidFill>
-                  <a:srgbClr val="1E2761"/>
+              <a:rPr lang="en-US" sz="1150" b="1" dirty="0">
+                <a:solidFill>
+                  <a:srgbClr val="2E7D52"/>
                 </a:solidFill>
                 <a:latin typeface="Calibri" pitchFamily="34" charset="0"/>
                 <a:ea typeface="Calibri" pitchFamily="34" charset="-122"/>
                 <a:cs typeface="Calibri" pitchFamily="34" charset="-120"/>
               </a:rPr>
-              <a:t>READY</a:t>
-            </a:r>
-            <a:endParaRPr lang="en-US" sz="900" dirty="0"/>
-          </a:p>
-        </p:txBody>
-      </p:sp>
-      <p:sp>
-        <p:nvSpPr>
-          <p:cNvPr id="18" name="Text 15"/>
-          <p:cNvSpPr/>
-          <p:nvPr/>
-        </p:nvSpPr>
-        <p:spPr>
-          <a:xfrm>
-            <a:off x="2563368" y="3429000"/>
-            <a:ext cx="1402080" cy="1463040"/>
-          </a:xfrm>
-          <a:prstGeom prst="rect">
-            <a:avLst/>
-          </a:prstGeom>
-          <a:noFill/>
-          <a:ln/>
-        </p:spPr>
-        <p:txBody>
-          <a:bodyPr wrap="square" lIns="0" tIns="0" rIns="0" bIns="0" rtlCol="0" anchor="ctr"/>
-          <a:lstStyle/>
-          <a:p>
-            <a:pPr algn="ctr" indent="0" marL="0">
+              <a:t>Proposal (decision 3):  </a:t>
+            </a:r>
+            <a:pPr indent="0" marL="0">
               <a:buNone/>
             </a:pPr>
             <a:r>
-              <a:rPr lang="en-US" sz="1000" dirty="0">
-                <a:solidFill>
-                  <a:srgbClr val="5A6272"/>
+              <a:rPr lang="en-US" sz="1150" dirty="0">
+                <a:solidFill>
+                  <a:srgbClr val="262B38"/>
                 </a:solidFill>
                 <a:latin typeface="Calibri" pitchFamily="34" charset="0"/>
                 <a:ea typeface="Calibri" pitchFamily="34" charset="-122"/>
                 <a:cs typeface="Calibri" pitchFamily="34" charset="-120"/>
               </a:rPr>
-              <a:t>notebook ready; needs assigned reviewer</a:t>
-            </a:r>
-            <a:endParaRPr lang="en-US" sz="1000" dirty="0"/>
-          </a:p>
-        </p:txBody>
-      </p:sp>
-      <p:sp>
-        <p:nvSpPr>
-          <p:cNvPr id="19" name="Shape 16"/>
-          <p:cNvSpPr/>
-          <p:nvPr/>
-        </p:nvSpPr>
-        <p:spPr>
-          <a:xfrm>
-            <a:off x="4093464" y="3474720"/>
-            <a:ext cx="228600" cy="0"/>
-          </a:xfrm>
-          <a:prstGeom prst="line">
-            <a:avLst/>
-          </a:prstGeom>
-          <a:noFill/>
-          <a:ln w="22225">
-            <a:solidFill>
-              <a:srgbClr val="1E2761"/>
-            </a:solidFill>
-            <a:prstDash val="solid"/>
-            <a:tailEnd type="arrow"/>
-          </a:ln>
-        </p:spPr>
-      </p:sp>
-      <p:sp>
-        <p:nvSpPr>
-          <p:cNvPr id="20" name="Shape 17"/>
-          <p:cNvSpPr/>
-          <p:nvPr/>
-        </p:nvSpPr>
-        <p:spPr>
-          <a:xfrm>
-            <a:off x="4322064" y="1920240"/>
-            <a:ext cx="1658112" cy="3108960"/>
-          </a:xfrm>
-          <a:prstGeom prst="roundRect">
-            <a:avLst>
-              <a:gd name="adj" fmla="val 4963"/>
-            </a:avLst>
-          </a:prstGeom>
-          <a:solidFill>
-            <a:srgbClr val="EEF4FB"/>
-          </a:solidFill>
-          <a:ln/>
-        </p:spPr>
-      </p:sp>
-      <p:sp>
-        <p:nvSpPr>
-          <p:cNvPr id="21" name="Shape 18"/>
-          <p:cNvSpPr/>
-          <p:nvPr/>
-        </p:nvSpPr>
-        <p:spPr>
-          <a:xfrm>
-            <a:off x="4876800" y="2148840"/>
-            <a:ext cx="548640" cy="548640"/>
-          </a:xfrm>
-          <a:prstGeom prst="ellipse">
-            <a:avLst/>
-          </a:prstGeom>
-          <a:solidFill>
-            <a:srgbClr val="1E2761"/>
-          </a:solidFill>
-          <a:ln/>
-        </p:spPr>
-      </p:sp>
-      <p:sp>
-        <p:nvSpPr>
-          <p:cNvPr id="22" name="Text 19"/>
-          <p:cNvSpPr/>
-          <p:nvPr/>
-        </p:nvSpPr>
-        <p:spPr>
-          <a:xfrm>
-            <a:off x="4876800" y="2176272"/>
-            <a:ext cx="548640" cy="502920"/>
-          </a:xfrm>
-          <a:prstGeom prst="rect">
-            <a:avLst/>
-          </a:prstGeom>
-          <a:noFill/>
-          <a:ln/>
-        </p:spPr>
-        <p:txBody>
-          <a:bodyPr wrap="square" lIns="0" tIns="0" rIns="0" bIns="0" rtlCol="0" anchor="ctr"/>
-          <a:lstStyle/>
-          <a:p>
-            <a:pPr algn="ctr" indent="0" marL="0">
-              <a:buNone/>
-            </a:pPr>
-            <a:r>
-              <a:rPr lang="en-US" sz="2000" b="1" dirty="0">
-                <a:solidFill>
-                  <a:srgbClr val="FFFFFF"/>
-                </a:solidFill>
-                <a:latin typeface="Cambria" pitchFamily="34" charset="0"/>
-                <a:ea typeface="Cambria" pitchFamily="34" charset="-122"/>
-                <a:cs typeface="Cambria" pitchFamily="34" charset="-120"/>
-              </a:rPr>
-              <a:t>2</a:t>
-            </a:r>
-            <a:endParaRPr lang="en-US" sz="2000" dirty="0"/>
-          </a:p>
-        </p:txBody>
-      </p:sp>
-      <p:sp>
-        <p:nvSpPr>
-          <p:cNvPr id="23" name="Text 20"/>
-          <p:cNvSpPr/>
-          <p:nvPr/>
-        </p:nvSpPr>
-        <p:spPr>
-          <a:xfrm>
-            <a:off x="4413504" y="2834640"/>
-            <a:ext cx="1475232" cy="292608"/>
-          </a:xfrm>
-          <a:prstGeom prst="rect">
-            <a:avLst/>
-          </a:prstGeom>
-          <a:noFill/>
-          <a:ln/>
-        </p:spPr>
-        <p:txBody>
-          <a:bodyPr wrap="square" lIns="0" tIns="0" rIns="0" bIns="0" rtlCol="0" anchor="ctr"/>
-          <a:lstStyle/>
-          <a:p>
-            <a:pPr algn="ctr" indent="0" marL="0">
-              <a:buNone/>
-            </a:pPr>
-            <a:r>
-              <a:rPr lang="en-US" sz="1300" b="1" dirty="0">
-                <a:solidFill>
-                  <a:srgbClr val="262B38"/>
-                </a:solidFill>
-                <a:latin typeface="Calibri" pitchFamily="34" charset="0"/>
-                <a:ea typeface="Calibri" pitchFamily="34" charset="-122"/>
-                <a:cs typeface="Calibri" pitchFamily="34" charset="-120"/>
-              </a:rPr>
-              <a:t>Implement</a:t>
-            </a:r>
-            <a:endParaRPr lang="en-US" sz="1300" dirty="0"/>
-          </a:p>
-        </p:txBody>
-      </p:sp>
-      <p:sp>
-        <p:nvSpPr>
-          <p:cNvPr id="24" name="Text 21"/>
-          <p:cNvSpPr/>
-          <p:nvPr/>
-        </p:nvSpPr>
-        <p:spPr>
-          <a:xfrm>
-            <a:off x="4413504" y="3127248"/>
-            <a:ext cx="1475232" cy="237744"/>
-          </a:xfrm>
-          <a:prstGeom prst="rect">
-            <a:avLst/>
-          </a:prstGeom>
-          <a:noFill/>
-          <a:ln/>
-        </p:spPr>
-        <p:txBody>
-          <a:bodyPr wrap="square" lIns="0" tIns="0" rIns="0" bIns="0" rtlCol="0" anchor="ctr"/>
-          <a:lstStyle/>
-          <a:p>
-            <a:pPr algn="ctr" indent="0" marL="0">
-              <a:buNone/>
-            </a:pPr>
-            <a:r>
-              <a:rPr lang="en-US" sz="900" b="1" spc="100" kern="0" dirty="0">
-                <a:solidFill>
-                  <a:srgbClr val="1E2761"/>
-                </a:solidFill>
-                <a:latin typeface="Calibri" pitchFamily="34" charset="0"/>
-                <a:ea typeface="Calibri" pitchFamily="34" charset="-122"/>
-                <a:cs typeface="Calibri" pitchFamily="34" charset="-120"/>
-              </a:rPr>
-              <a:t>PREPPED</a:t>
-            </a:r>
-            <a:endParaRPr lang="en-US" sz="900" dirty="0"/>
-          </a:p>
-        </p:txBody>
-      </p:sp>
-      <p:sp>
-        <p:nvSpPr>
-          <p:cNvPr id="25" name="Text 22"/>
-          <p:cNvSpPr/>
-          <p:nvPr/>
-        </p:nvSpPr>
-        <p:spPr>
-          <a:xfrm>
-            <a:off x="4450080" y="3429000"/>
-            <a:ext cx="1402080" cy="1463040"/>
-          </a:xfrm>
-          <a:prstGeom prst="rect">
-            <a:avLst/>
-          </a:prstGeom>
-          <a:noFill/>
-          <a:ln/>
-        </p:spPr>
-        <p:txBody>
-          <a:bodyPr wrap="square" lIns="0" tIns="0" rIns="0" bIns="0" rtlCol="0" anchor="ctr"/>
-          <a:lstStyle/>
-          <a:p>
-            <a:pPr algn="ctr" indent="0" marL="0">
-              <a:buNone/>
-            </a:pPr>
-            <a:r>
-              <a:rPr lang="en-US" sz="1000" dirty="0">
-                <a:solidFill>
-                  <a:srgbClr val="5A6272"/>
-                </a:solidFill>
-                <a:latin typeface="Calibri" pitchFamily="34" charset="0"/>
-                <a:ea typeface="Calibri" pitchFamily="34" charset="-122"/>
-                <a:cs typeface="Calibri" pitchFamily="34" charset="-120"/>
-              </a:rPr>
-              <a:t>V1 pipeline + V2 variant prepped for code review</a:t>
-            </a:r>
-            <a:endParaRPr lang="en-US" sz="1000" dirty="0"/>
-          </a:p>
-        </p:txBody>
-      </p:sp>
-      <p:sp>
-        <p:nvSpPr>
-          <p:cNvPr id="26" name="Shape 23"/>
-          <p:cNvSpPr/>
-          <p:nvPr/>
-        </p:nvSpPr>
-        <p:spPr>
-          <a:xfrm>
-            <a:off x="5980176" y="3474720"/>
-            <a:ext cx="228600" cy="0"/>
-          </a:xfrm>
-          <a:prstGeom prst="line">
-            <a:avLst/>
-          </a:prstGeom>
-          <a:noFill/>
-          <a:ln w="22225">
-            <a:solidFill>
-              <a:srgbClr val="1E2761"/>
-            </a:solidFill>
-            <a:prstDash val="solid"/>
-            <a:tailEnd type="arrow"/>
-          </a:ln>
-        </p:spPr>
-      </p:sp>
-      <p:sp>
-        <p:nvSpPr>
-          <p:cNvPr id="27" name="Shape 24"/>
-          <p:cNvSpPr/>
-          <p:nvPr/>
-        </p:nvSpPr>
-        <p:spPr>
-          <a:xfrm>
-            <a:off x="6208776" y="1920240"/>
-            <a:ext cx="1658112" cy="3108960"/>
-          </a:xfrm>
-          <a:prstGeom prst="roundRect">
-            <a:avLst>
-              <a:gd name="adj" fmla="val 4963"/>
-            </a:avLst>
-          </a:prstGeom>
-          <a:solidFill>
-            <a:srgbClr val="EEF4FB"/>
-          </a:solidFill>
-          <a:ln/>
-        </p:spPr>
-      </p:sp>
-      <p:sp>
-        <p:nvSpPr>
-          <p:cNvPr id="28" name="Shape 25"/>
-          <p:cNvSpPr/>
-          <p:nvPr/>
-        </p:nvSpPr>
-        <p:spPr>
-          <a:xfrm>
-            <a:off x="6763512" y="2148840"/>
-            <a:ext cx="548640" cy="548640"/>
-          </a:xfrm>
-          <a:prstGeom prst="ellipse">
-            <a:avLst/>
-          </a:prstGeom>
-          <a:solidFill>
-            <a:srgbClr val="1E2761"/>
-          </a:solidFill>
-          <a:ln/>
-        </p:spPr>
-      </p:sp>
-      <p:sp>
-        <p:nvSpPr>
-          <p:cNvPr id="29" name="Text 26"/>
-          <p:cNvSpPr/>
-          <p:nvPr/>
-        </p:nvSpPr>
-        <p:spPr>
-          <a:xfrm>
-            <a:off x="6763512" y="2176272"/>
-            <a:ext cx="548640" cy="502920"/>
-          </a:xfrm>
-          <a:prstGeom prst="rect">
-            <a:avLst/>
-          </a:prstGeom>
-          <a:noFill/>
-          <a:ln/>
-        </p:spPr>
-        <p:txBody>
-          <a:bodyPr wrap="square" lIns="0" tIns="0" rIns="0" bIns="0" rtlCol="0" anchor="ctr"/>
-          <a:lstStyle/>
-          <a:p>
-            <a:pPr algn="ctr" indent="0" marL="0">
-              <a:buNone/>
-            </a:pPr>
-            <a:r>
-              <a:rPr lang="en-US" sz="2000" b="1" dirty="0">
-                <a:solidFill>
-                  <a:srgbClr val="FFFFFF"/>
-                </a:solidFill>
-                <a:latin typeface="Cambria" pitchFamily="34" charset="0"/>
-                <a:ea typeface="Cambria" pitchFamily="34" charset="-122"/>
-                <a:cs typeface="Cambria" pitchFamily="34" charset="-120"/>
-              </a:rPr>
-              <a:t>3</a:t>
-            </a:r>
-            <a:endParaRPr lang="en-US" sz="2000" dirty="0"/>
-          </a:p>
-        </p:txBody>
-      </p:sp>
-      <p:sp>
-        <p:nvSpPr>
-          <p:cNvPr id="30" name="Text 27"/>
-          <p:cNvSpPr/>
-          <p:nvPr/>
-        </p:nvSpPr>
-        <p:spPr>
-          <a:xfrm>
-            <a:off x="6300216" y="2834640"/>
-            <a:ext cx="1475232" cy="292608"/>
-          </a:xfrm>
-          <a:prstGeom prst="rect">
-            <a:avLst/>
-          </a:prstGeom>
-          <a:noFill/>
-          <a:ln/>
-        </p:spPr>
-        <p:txBody>
-          <a:bodyPr wrap="square" lIns="0" tIns="0" rIns="0" bIns="0" rtlCol="0" anchor="ctr"/>
-          <a:lstStyle/>
-          <a:p>
-            <a:pPr algn="ctr" indent="0" marL="0">
-              <a:buNone/>
-            </a:pPr>
-            <a:r>
-              <a:rPr lang="en-US" sz="1300" b="1" dirty="0">
-                <a:solidFill>
-                  <a:srgbClr val="262B38"/>
-                </a:solidFill>
-                <a:latin typeface="Calibri" pitchFamily="34" charset="0"/>
-                <a:ea typeface="Calibri" pitchFamily="34" charset="-122"/>
-                <a:cs typeface="Calibri" pitchFamily="34" charset="-120"/>
-              </a:rPr>
-              <a:t>Smoke</a:t>
-            </a:r>
-            <a:endParaRPr lang="en-US" sz="1300" dirty="0"/>
-          </a:p>
-        </p:txBody>
-      </p:sp>
-      <p:sp>
-        <p:nvSpPr>
-          <p:cNvPr id="31" name="Text 28"/>
-          <p:cNvSpPr/>
-          <p:nvPr/>
-        </p:nvSpPr>
-        <p:spPr>
-          <a:xfrm>
-            <a:off x="6300216" y="3127248"/>
-            <a:ext cx="1475232" cy="237744"/>
-          </a:xfrm>
-          <a:prstGeom prst="rect">
-            <a:avLst/>
-          </a:prstGeom>
-          <a:noFill/>
-          <a:ln/>
-        </p:spPr>
-        <p:txBody>
-          <a:bodyPr wrap="square" lIns="0" tIns="0" rIns="0" bIns="0" rtlCol="0" anchor="ctr"/>
-          <a:lstStyle/>
-          <a:p>
-            <a:pPr algn="ctr" indent="0" marL="0">
-              <a:buNone/>
-            </a:pPr>
-            <a:r>
-              <a:rPr lang="en-US" sz="900" b="1" spc="100" kern="0" dirty="0">
-                <a:solidFill>
-                  <a:srgbClr val="1E2761"/>
-                </a:solidFill>
-                <a:latin typeface="Calibri" pitchFamily="34" charset="0"/>
-                <a:ea typeface="Calibri" pitchFamily="34" charset="-122"/>
-                <a:cs typeface="Calibri" pitchFamily="34" charset="-120"/>
-              </a:rPr>
-              <a:t>BUILT-IN</a:t>
-            </a:r>
-            <a:endParaRPr lang="en-US" sz="900" dirty="0"/>
-          </a:p>
-        </p:txBody>
-      </p:sp>
-      <p:sp>
-        <p:nvSpPr>
-          <p:cNvPr id="32" name="Text 29"/>
-          <p:cNvSpPr/>
-          <p:nvPr/>
-        </p:nvSpPr>
-        <p:spPr>
-          <a:xfrm>
-            <a:off x="6336792" y="3429000"/>
-            <a:ext cx="1402080" cy="1463040"/>
-          </a:xfrm>
-          <a:prstGeom prst="rect">
-            <a:avLst/>
-          </a:prstGeom>
-          <a:noFill/>
-          <a:ln/>
-        </p:spPr>
-        <p:txBody>
-          <a:bodyPr wrap="square" lIns="0" tIns="0" rIns="0" bIns="0" rtlCol="0" anchor="ctr"/>
-          <a:lstStyle/>
-          <a:p>
-            <a:pPr algn="ctr" indent="0" marL="0">
-              <a:buNone/>
-            </a:pPr>
-            <a:r>
-              <a:rPr lang="en-US" sz="1000" dirty="0">
-                <a:solidFill>
-                  <a:srgbClr val="5A6272"/>
-                </a:solidFill>
-                <a:latin typeface="Calibri" pitchFamily="34" charset="0"/>
-                <a:ea typeface="Calibri" pitchFamily="34" charset="-122"/>
-                <a:cs typeface="Calibri" pitchFamily="34" charset="-120"/>
-              </a:rPr>
-              <a:t>FAST mode built into every notebook</a:t>
-            </a:r>
-            <a:endParaRPr lang="en-US" sz="1000" dirty="0"/>
-          </a:p>
-        </p:txBody>
-      </p:sp>
-      <p:sp>
-        <p:nvSpPr>
-          <p:cNvPr id="33" name="Shape 30"/>
-          <p:cNvSpPr/>
-          <p:nvPr/>
-        </p:nvSpPr>
-        <p:spPr>
-          <a:xfrm>
-            <a:off x="7866888" y="3474720"/>
-            <a:ext cx="228600" cy="0"/>
-          </a:xfrm>
-          <a:prstGeom prst="line">
-            <a:avLst/>
-          </a:prstGeom>
-          <a:noFill/>
-          <a:ln w="22225">
-            <a:solidFill>
-              <a:srgbClr val="1E2761"/>
-            </a:solidFill>
-            <a:prstDash val="solid"/>
-            <a:tailEnd type="arrow"/>
-          </a:ln>
-        </p:spPr>
-      </p:sp>
-      <p:sp>
-        <p:nvSpPr>
-          <p:cNvPr id="34" name="Shape 31"/>
-          <p:cNvSpPr/>
-          <p:nvPr/>
-        </p:nvSpPr>
-        <p:spPr>
-          <a:xfrm>
-            <a:off x="8095488" y="1920240"/>
-            <a:ext cx="1658112" cy="3108960"/>
-          </a:xfrm>
-          <a:prstGeom prst="roundRect">
-            <a:avLst>
-              <a:gd name="adj" fmla="val 4963"/>
-            </a:avLst>
-          </a:prstGeom>
-          <a:solidFill>
-            <a:srgbClr val="EEF4FB"/>
-          </a:solidFill>
-          <a:ln/>
-        </p:spPr>
-      </p:sp>
-      <p:sp>
-        <p:nvSpPr>
-          <p:cNvPr id="35" name="Shape 32"/>
-          <p:cNvSpPr/>
-          <p:nvPr/>
-        </p:nvSpPr>
-        <p:spPr>
-          <a:xfrm>
-            <a:off x="8650224" y="2148840"/>
-            <a:ext cx="548640" cy="548640"/>
-          </a:xfrm>
-          <a:prstGeom prst="ellipse">
-            <a:avLst/>
-          </a:prstGeom>
-          <a:solidFill>
-            <a:srgbClr val="5A6272"/>
-          </a:solidFill>
-          <a:ln/>
-        </p:spPr>
-      </p:sp>
-      <p:sp>
-        <p:nvSpPr>
-          <p:cNvPr id="36" name="Text 33"/>
-          <p:cNvSpPr/>
-          <p:nvPr/>
-        </p:nvSpPr>
-        <p:spPr>
-          <a:xfrm>
-            <a:off x="8650224" y="2176272"/>
-            <a:ext cx="548640" cy="502920"/>
-          </a:xfrm>
-          <a:prstGeom prst="rect">
-            <a:avLst/>
-          </a:prstGeom>
-          <a:noFill/>
-          <a:ln/>
-        </p:spPr>
-        <p:txBody>
-          <a:bodyPr wrap="square" lIns="0" tIns="0" rIns="0" bIns="0" rtlCol="0" anchor="ctr"/>
-          <a:lstStyle/>
-          <a:p>
-            <a:pPr algn="ctr" indent="0" marL="0">
-              <a:buNone/>
-            </a:pPr>
-            <a:r>
-              <a:rPr lang="en-US" sz="2000" b="1" dirty="0">
-                <a:solidFill>
-                  <a:srgbClr val="FFFFFF"/>
-                </a:solidFill>
-                <a:latin typeface="Cambria" pitchFamily="34" charset="0"/>
-                <a:ea typeface="Cambria" pitchFamily="34" charset="-122"/>
-                <a:cs typeface="Cambria" pitchFamily="34" charset="-120"/>
-              </a:rPr>
-              <a:t>4</a:t>
-            </a:r>
-            <a:endParaRPr lang="en-US" sz="2000" dirty="0"/>
-          </a:p>
-        </p:txBody>
-      </p:sp>
-      <p:sp>
-        <p:nvSpPr>
-          <p:cNvPr id="37" name="Text 34"/>
-          <p:cNvSpPr/>
-          <p:nvPr/>
-        </p:nvSpPr>
-        <p:spPr>
-          <a:xfrm>
-            <a:off x="8186928" y="2834640"/>
-            <a:ext cx="1475232" cy="292608"/>
-          </a:xfrm>
-          <a:prstGeom prst="rect">
-            <a:avLst/>
-          </a:prstGeom>
-          <a:noFill/>
-          <a:ln/>
-        </p:spPr>
-        <p:txBody>
-          <a:bodyPr wrap="square" lIns="0" tIns="0" rIns="0" bIns="0" rtlCol="0" anchor="ctr"/>
-          <a:lstStyle/>
-          <a:p>
-            <a:pPr algn="ctr" indent="0" marL="0">
-              <a:buNone/>
-            </a:pPr>
-            <a:r>
-              <a:rPr lang="en-US" sz="1300" b="1" dirty="0">
-                <a:solidFill>
-                  <a:srgbClr val="262B38"/>
-                </a:solidFill>
-                <a:latin typeface="Calibri" pitchFamily="34" charset="0"/>
-                <a:ea typeface="Calibri" pitchFamily="34" charset="-122"/>
-                <a:cs typeface="Calibri" pitchFamily="34" charset="-120"/>
-              </a:rPr>
-              <a:t>Full run</a:t>
-            </a:r>
-            <a:endParaRPr lang="en-US" sz="1300" dirty="0"/>
-          </a:p>
-        </p:txBody>
-      </p:sp>
-      <p:sp>
-        <p:nvSpPr>
-          <p:cNvPr id="38" name="Text 35"/>
-          <p:cNvSpPr/>
-          <p:nvPr/>
-        </p:nvSpPr>
-        <p:spPr>
-          <a:xfrm>
-            <a:off x="8186928" y="3127248"/>
-            <a:ext cx="1475232" cy="237744"/>
-          </a:xfrm>
-          <a:prstGeom prst="rect">
-            <a:avLst/>
-          </a:prstGeom>
-          <a:noFill/>
-          <a:ln/>
-        </p:spPr>
-        <p:txBody>
-          <a:bodyPr wrap="square" lIns="0" tIns="0" rIns="0" bIns="0" rtlCol="0" anchor="ctr"/>
-          <a:lstStyle/>
-          <a:p>
-            <a:pPr algn="ctr" indent="0" marL="0">
-              <a:buNone/>
-            </a:pPr>
-            <a:r>
-              <a:rPr lang="en-US" sz="900" b="1" spc="100" kern="0" dirty="0">
-                <a:solidFill>
-                  <a:srgbClr val="5A6272"/>
-                </a:solidFill>
-                <a:latin typeface="Calibri" pitchFamily="34" charset="0"/>
-                <a:ea typeface="Calibri" pitchFamily="34" charset="-122"/>
-                <a:cs typeface="Calibri" pitchFamily="34" charset="-120"/>
-              </a:rPr>
-              <a:t>AWAITS 0–3</a:t>
-            </a:r>
-            <a:endParaRPr lang="en-US" sz="900" dirty="0"/>
-          </a:p>
-        </p:txBody>
-      </p:sp>
-      <p:sp>
-        <p:nvSpPr>
-          <p:cNvPr id="39" name="Text 36"/>
-          <p:cNvSpPr/>
-          <p:nvPr/>
-        </p:nvSpPr>
-        <p:spPr>
-          <a:xfrm>
-            <a:off x="8223504" y="3429000"/>
-            <a:ext cx="1402080" cy="1463040"/>
-          </a:xfrm>
-          <a:prstGeom prst="rect">
-            <a:avLst/>
-          </a:prstGeom>
-          <a:noFill/>
-          <a:ln/>
-        </p:spPr>
-        <p:txBody>
-          <a:bodyPr wrap="square" lIns="0" tIns="0" rIns="0" bIns="0" rtlCol="0" anchor="ctr"/>
-          <a:lstStyle/>
-          <a:p>
-            <a:pPr algn="ctr" indent="0" marL="0">
-              <a:buNone/>
-            </a:pPr>
-            <a:r>
-              <a:rPr lang="en-US" sz="1000" dirty="0">
-                <a:solidFill>
-                  <a:srgbClr val="5A6272"/>
-                </a:solidFill>
-                <a:latin typeface="Calibri" pitchFamily="34" charset="0"/>
-                <a:ea typeface="Calibri" pitchFamily="34" charset="-122"/>
-                <a:cs typeface="Calibri" pitchFamily="34" charset="-120"/>
-              </a:rPr>
-              <a:t>frozen config, TUNE→DEVTEST protocol</a:t>
-            </a:r>
-            <a:endParaRPr lang="en-US" sz="1000" dirty="0"/>
-          </a:p>
-        </p:txBody>
-      </p:sp>
-      <p:sp>
-        <p:nvSpPr>
-          <p:cNvPr id="40" name="Shape 37"/>
-          <p:cNvSpPr/>
-          <p:nvPr/>
-        </p:nvSpPr>
-        <p:spPr>
-          <a:xfrm>
-            <a:off x="9753600" y="3474720"/>
-            <a:ext cx="228600" cy="0"/>
-          </a:xfrm>
-          <a:prstGeom prst="line">
-            <a:avLst/>
-          </a:prstGeom>
-          <a:noFill/>
-          <a:ln w="22225">
-            <a:solidFill>
-              <a:srgbClr val="1E2761"/>
-            </a:solidFill>
-            <a:prstDash val="solid"/>
-            <a:tailEnd type="arrow"/>
-          </a:ln>
-        </p:spPr>
-      </p:sp>
-      <p:sp>
-        <p:nvSpPr>
-          <p:cNvPr id="41" name="Shape 38"/>
-          <p:cNvSpPr/>
-          <p:nvPr/>
-        </p:nvSpPr>
-        <p:spPr>
-          <a:xfrm>
-            <a:off x="9982200" y="1920240"/>
-            <a:ext cx="1658112" cy="3108960"/>
-          </a:xfrm>
-          <a:prstGeom prst="roundRect">
-            <a:avLst>
-              <a:gd name="adj" fmla="val 4963"/>
-            </a:avLst>
-          </a:prstGeom>
-          <a:solidFill>
-            <a:srgbClr val="EEF4FB"/>
-          </a:solidFill>
-          <a:ln/>
-        </p:spPr>
-      </p:sp>
-      <p:sp>
-        <p:nvSpPr>
-          <p:cNvPr id="42" name="Shape 39"/>
-          <p:cNvSpPr/>
-          <p:nvPr/>
-        </p:nvSpPr>
-        <p:spPr>
-          <a:xfrm>
-            <a:off x="10536936" y="2148840"/>
-            <a:ext cx="548640" cy="548640"/>
-          </a:xfrm>
-          <a:prstGeom prst="ellipse">
-            <a:avLst/>
-          </a:prstGeom>
-          <a:solidFill>
-            <a:srgbClr val="5A6272"/>
-          </a:solidFill>
-          <a:ln/>
-        </p:spPr>
-      </p:sp>
-      <p:sp>
-        <p:nvSpPr>
-          <p:cNvPr id="43" name="Text 40"/>
-          <p:cNvSpPr/>
-          <p:nvPr/>
-        </p:nvSpPr>
-        <p:spPr>
-          <a:xfrm>
-            <a:off x="10536936" y="2176272"/>
-            <a:ext cx="548640" cy="502920"/>
-          </a:xfrm>
-          <a:prstGeom prst="rect">
-            <a:avLst/>
-          </a:prstGeom>
-          <a:noFill/>
-          <a:ln/>
-        </p:spPr>
-        <p:txBody>
-          <a:bodyPr wrap="square" lIns="0" tIns="0" rIns="0" bIns="0" rtlCol="0" anchor="ctr"/>
-          <a:lstStyle/>
-          <a:p>
-            <a:pPr algn="ctr" indent="0" marL="0">
-              <a:buNone/>
-            </a:pPr>
-            <a:r>
-              <a:rPr lang="en-US" sz="2000" b="1" dirty="0">
-                <a:solidFill>
-                  <a:srgbClr val="FFFFFF"/>
-                </a:solidFill>
-                <a:latin typeface="Cambria" pitchFamily="34" charset="0"/>
-                <a:ea typeface="Cambria" pitchFamily="34" charset="-122"/>
-                <a:cs typeface="Cambria" pitchFamily="34" charset="-120"/>
-              </a:rPr>
-              <a:t>5</a:t>
-            </a:r>
-            <a:endParaRPr lang="en-US" sz="2000" dirty="0"/>
-          </a:p>
-        </p:txBody>
-      </p:sp>
-      <p:sp>
-        <p:nvSpPr>
-          <p:cNvPr id="44" name="Text 41"/>
-          <p:cNvSpPr/>
-          <p:nvPr/>
-        </p:nvSpPr>
-        <p:spPr>
-          <a:xfrm>
-            <a:off x="10073640" y="2834640"/>
-            <a:ext cx="1475232" cy="292608"/>
-          </a:xfrm>
-          <a:prstGeom prst="rect">
-            <a:avLst/>
-          </a:prstGeom>
-          <a:noFill/>
-          <a:ln/>
-        </p:spPr>
-        <p:txBody>
-          <a:bodyPr wrap="square" lIns="0" tIns="0" rIns="0" bIns="0" rtlCol="0" anchor="ctr"/>
-          <a:lstStyle/>
-          <a:p>
-            <a:pPr algn="ctr" indent="0" marL="0">
-              <a:buNone/>
-            </a:pPr>
-            <a:r>
-              <a:rPr lang="en-US" sz="1300" b="1" dirty="0">
-                <a:solidFill>
-                  <a:srgbClr val="262B38"/>
-                </a:solidFill>
-                <a:latin typeface="Calibri" pitchFamily="34" charset="0"/>
-                <a:ea typeface="Calibri" pitchFamily="34" charset="-122"/>
-                <a:cs typeface="Calibri" pitchFamily="34" charset="-120"/>
-              </a:rPr>
-              <a:t>Audit</a:t>
-            </a:r>
-            <a:endParaRPr lang="en-US" sz="1300" dirty="0"/>
-          </a:p>
-        </p:txBody>
-      </p:sp>
-      <p:sp>
-        <p:nvSpPr>
-          <p:cNvPr id="45" name="Text 42"/>
-          <p:cNvSpPr/>
-          <p:nvPr/>
-        </p:nvSpPr>
-        <p:spPr>
-          <a:xfrm>
-            <a:off x="10073640" y="3127248"/>
-            <a:ext cx="1475232" cy="237744"/>
-          </a:xfrm>
-          <a:prstGeom prst="rect">
-            <a:avLst/>
-          </a:prstGeom>
-          <a:noFill/>
-          <a:ln/>
-        </p:spPr>
-        <p:txBody>
-          <a:bodyPr wrap="square" lIns="0" tIns="0" rIns="0" bIns="0" rtlCol="0" anchor="ctr"/>
-          <a:lstStyle/>
-          <a:p>
-            <a:pPr algn="ctr" indent="0" marL="0">
-              <a:buNone/>
-            </a:pPr>
-            <a:r>
-              <a:rPr lang="en-US" sz="900" b="1" spc="100" kern="0" dirty="0">
-                <a:solidFill>
-                  <a:srgbClr val="5A6272"/>
-                </a:solidFill>
-                <a:latin typeface="Calibri" pitchFamily="34" charset="0"/>
-                <a:ea typeface="Calibri" pitchFamily="34" charset="-122"/>
-                <a:cs typeface="Calibri" pitchFamily="34" charset="-120"/>
-              </a:rPr>
-              <a:t>CONVENTIONS SET</a:t>
-            </a:r>
-            <a:endParaRPr lang="en-US" sz="900" dirty="0"/>
-          </a:p>
-        </p:txBody>
-      </p:sp>
-      <p:sp>
-        <p:nvSpPr>
-          <p:cNvPr id="46" name="Text 43"/>
-          <p:cNvSpPr/>
-          <p:nvPr/>
-        </p:nvSpPr>
-        <p:spPr>
-          <a:xfrm>
-            <a:off x="10110216" y="3429000"/>
-            <a:ext cx="1402080" cy="1463040"/>
-          </a:xfrm>
-          <a:prstGeom prst="rect">
-            <a:avLst/>
-          </a:prstGeom>
-          <a:noFill/>
-          <a:ln/>
-        </p:spPr>
-        <p:txBody>
-          <a:bodyPr wrap="square" lIns="0" tIns="0" rIns="0" bIns="0" rtlCol="0" anchor="ctr"/>
-          <a:lstStyle/>
-          <a:p>
-            <a:pPr algn="ctr" indent="0" marL="0">
-              <a:buNone/>
-            </a:pPr>
-            <a:r>
-              <a:rPr lang="en-US" sz="1000" dirty="0">
-                <a:solidFill>
-                  <a:srgbClr val="5A6272"/>
-                </a:solidFill>
-                <a:latin typeface="Calibri" pitchFamily="34" charset="0"/>
-                <a:ea typeface="Calibri" pitchFamily="34" charset="-122"/>
-                <a:cs typeface="Calibri" pitchFamily="34" charset="-120"/>
-              </a:rPr>
-              <a:t>SHA-256 artifacts, configs, transcripts committed</a:t>
-            </a:r>
-            <a:endParaRPr lang="en-US" sz="1000" dirty="0"/>
-          </a:p>
-        </p:txBody>
-      </p:sp>
-      <p:sp>
-        <p:nvSpPr>
-          <p:cNvPr id="47" name="Text 44"/>
-          <p:cNvSpPr/>
-          <p:nvPr/>
-        </p:nvSpPr>
-        <p:spPr>
-          <a:xfrm>
-            <a:off x="548640" y="5394960"/>
-            <a:ext cx="11091672" cy="320040"/>
-          </a:xfrm>
-          <a:prstGeom prst="rect">
-            <a:avLst/>
-          </a:prstGeom>
-          <a:noFill/>
-          <a:ln/>
-        </p:spPr>
-        <p:txBody>
-          <a:bodyPr wrap="square" lIns="0" tIns="0" rIns="0" bIns="0" rtlCol="0" anchor="ctr"/>
-          <a:lstStyle/>
-          <a:p>
-            <a:pPr algn="ctr" indent="0" marL="0">
-              <a:buNone/>
-            </a:pPr>
-            <a:r>
-              <a:rPr lang="en-US" sz="1250" i="1" dirty="0">
-                <a:solidFill>
-                  <a:srgbClr val="5A6272"/>
-                </a:solidFill>
-                <a:latin typeface="Calibri" pitchFamily="34" charset="0"/>
-                <a:ea typeface="Calibri" pitchFamily="34" charset="-122"/>
-                <a:cs typeface="Calibri" pitchFamily="34" charset="-120"/>
-              </a:rPr>
-              <a:t>Policy guarantee honored: no proposed-method implementation runs as an experiment until Phases 0 and 1 are approved.</a:t>
-            </a:r>
-            <a:endParaRPr lang="en-US" sz="1250" dirty="0"/>
+              <a:t>freeze whisper_to_sonar_W_audio.pt — audio-conditioned, best layer 3 (shifted from silence-conditioned layer 4) — as the calibration artifact. Caveat: 67/71-utterance pools saturate full-sentence retrieval; the W_audio-vs-W_silence contrast is like-for-like on identical pools.</a:t>
+            </a:r>
+            <a:endParaRPr lang="en-US" sz="1150" dirty="0"/>
           </a:p>
         </p:txBody>
       </p:sp>
@@ -7042,6 +7591,1507 @@
 <file path=ppt/slides/slide14.xml><?xml version="1.0" encoding="utf-8"?>
 <p:sld xmlns:a="http://schemas.openxmlformats.org/drawingml/2006/main" xmlns:r="http://schemas.openxmlformats.org/officeDocument/2006/relationships" xmlns:p="http://schemas.openxmlformats.org/presentationml/2006/main">
   <p:cSld name="Slide 14">
+    <p:bg>
+      <p:bgPr>
+        <a:solidFill>
+          <a:srgbClr val="FFFFFF"/>
+        </a:solidFill>
+      </p:bgPr>
+    </p:bg>
+    <p:spTree>
+      <p:nvGrpSpPr>
+        <p:cNvPr id="1" name=""/>
+        <p:cNvGrpSpPr/>
+        <p:nvPr/>
+      </p:nvGrpSpPr>
+      <p:grpSpPr>
+        <a:xfrm>
+          <a:off x="0" y="0"/>
+          <a:ext cx="0" cy="0"/>
+          <a:chOff x="0" y="0"/>
+          <a:chExt cx="0" cy="0"/>
+        </a:xfrm>
+      </p:grpSpPr>
+      <p:sp>
+        <p:nvSpPr>
+          <p:cNvPr id="2" name="Shape 0"/>
+          <p:cNvSpPr/>
+          <p:nvPr/>
+        </p:nvSpPr>
+        <p:spPr>
+          <a:xfrm>
+            <a:off x="548640" y="475488"/>
+            <a:ext cx="512064" cy="512064"/>
+          </a:xfrm>
+          <a:prstGeom prst="ellipse">
+            <a:avLst/>
+          </a:prstGeom>
+          <a:solidFill>
+            <a:srgbClr val="1E2761"/>
+          </a:solidFill>
+          <a:ln/>
+        </p:spPr>
+      </p:sp>
+      <p:pic>
+        <p:nvPicPr>
+          <p:cNvPr id="3" name="Image 0" descr="preencoded.png">    </p:cNvPr>
+          <p:cNvPicPr>
+            <a:picLocks noChangeAspect="1"/>
+          </p:cNvPicPr>
+          <p:nvPr/>
+        </p:nvPicPr>
+        <p:blipFill>
+          <a:blip r:embed="rId1"/>
+          <a:stretch>
+            <a:fillRect/>
+          </a:stretch>
+        </p:blipFill>
+        <p:spPr>
+          <a:xfrm>
+            <a:off x="667512" y="594360"/>
+            <a:ext cx="274320" cy="274320"/>
+          </a:xfrm>
+          <a:prstGeom prst="rect">
+            <a:avLst/>
+          </a:prstGeom>
+        </p:spPr>
+      </p:pic>
+      <p:sp>
+        <p:nvSpPr>
+          <p:cNvPr id="4" name="Text 1"/>
+          <p:cNvSpPr/>
+          <p:nvPr/>
+        </p:nvSpPr>
+        <p:spPr>
+          <a:xfrm>
+            <a:off x="1234440" y="457200"/>
+            <a:ext cx="10405872" cy="237744"/>
+          </a:xfrm>
+          <a:prstGeom prst="rect">
+            <a:avLst/>
+          </a:prstGeom>
+          <a:noFill/>
+          <a:ln/>
+        </p:spPr>
+        <p:txBody>
+          <a:bodyPr wrap="square" lIns="0" tIns="0" rIns="0" bIns="0" rtlCol="0" anchor="ctr"/>
+          <a:lstStyle/>
+          <a:p>
+            <a:pPr indent="0" marL="0">
+              <a:buNone/>
+            </a:pPr>
+            <a:r>
+              <a:rPr lang="en-US" sz="1100" b="1" spc="200" kern="0" dirty="0">
+                <a:solidFill>
+                  <a:srgbClr val="5A6272"/>
+                </a:solidFill>
+                <a:latin typeface="Calibri" pitchFamily="34" charset="0"/>
+                <a:ea typeface="Calibri" pitchFamily="34" charset="-122"/>
+                <a:cs typeface="Calibri" pitchFamily="34" charset="-120"/>
+              </a:rPr>
+              <a:t>PROCESS</a:t>
+            </a:r>
+            <a:endParaRPr lang="en-US" sz="1100" dirty="0"/>
+          </a:p>
+        </p:txBody>
+      </p:sp>
+      <p:sp>
+        <p:nvSpPr>
+          <p:cNvPr id="5" name="Text 2"/>
+          <p:cNvSpPr/>
+          <p:nvPr/>
+        </p:nvSpPr>
+        <p:spPr>
+          <a:xfrm>
+            <a:off x="1234440" y="676656"/>
+            <a:ext cx="10405872" cy="457200"/>
+          </a:xfrm>
+          <a:prstGeom prst="rect">
+            <a:avLst/>
+          </a:prstGeom>
+          <a:noFill/>
+          <a:ln/>
+        </p:spPr>
+        <p:txBody>
+          <a:bodyPr wrap="square" lIns="0" tIns="0" rIns="0" bIns="0" rtlCol="0" anchor="ctr"/>
+          <a:lstStyle/>
+          <a:p>
+            <a:pPr indent="0" marL="0">
+              <a:buNone/>
+            </a:pPr>
+            <a:r>
+              <a:rPr lang="en-US" sz="2700" b="1" dirty="0">
+                <a:solidFill>
+                  <a:srgbClr val="262B38"/>
+                </a:solidFill>
+                <a:latin typeface="Cambria" pitchFamily="34" charset="0"/>
+                <a:ea typeface="Cambria" pitchFamily="34" charset="-122"/>
+                <a:cs typeface="Cambria" pitchFamily="34" charset="-120"/>
+              </a:rPr>
+              <a:t>Where we are in the approval flow</a:t>
+            </a:r>
+            <a:endParaRPr lang="en-US" sz="2700" dirty="0"/>
+          </a:p>
+        </p:txBody>
+      </p:sp>
+      <p:sp>
+        <p:nvSpPr>
+          <p:cNvPr id="6" name="Shape 3"/>
+          <p:cNvSpPr/>
+          <p:nvPr/>
+        </p:nvSpPr>
+        <p:spPr>
+          <a:xfrm>
+            <a:off x="548640" y="1920240"/>
+            <a:ext cx="1658112" cy="3108960"/>
+          </a:xfrm>
+          <a:prstGeom prst="roundRect">
+            <a:avLst>
+              <a:gd name="adj" fmla="val 4963"/>
+            </a:avLst>
+          </a:prstGeom>
+          <a:solidFill>
+            <a:srgbClr val="FBF3DE"/>
+          </a:solidFill>
+          <a:ln/>
+        </p:spPr>
+      </p:sp>
+      <p:sp>
+        <p:nvSpPr>
+          <p:cNvPr id="7" name="Shape 4"/>
+          <p:cNvSpPr/>
+          <p:nvPr/>
+        </p:nvSpPr>
+        <p:spPr>
+          <a:xfrm>
+            <a:off x="1103376" y="2148840"/>
+            <a:ext cx="548640" cy="548640"/>
+          </a:xfrm>
+          <a:prstGeom prst="ellipse">
+            <a:avLst/>
+          </a:prstGeom>
+          <a:solidFill>
+            <a:srgbClr val="B07A1E"/>
+          </a:solidFill>
+          <a:ln/>
+        </p:spPr>
+      </p:sp>
+      <p:sp>
+        <p:nvSpPr>
+          <p:cNvPr id="8" name="Text 5"/>
+          <p:cNvSpPr/>
+          <p:nvPr/>
+        </p:nvSpPr>
+        <p:spPr>
+          <a:xfrm>
+            <a:off x="1103376" y="2176272"/>
+            <a:ext cx="548640" cy="502920"/>
+          </a:xfrm>
+          <a:prstGeom prst="rect">
+            <a:avLst/>
+          </a:prstGeom>
+          <a:noFill/>
+          <a:ln/>
+        </p:spPr>
+        <p:txBody>
+          <a:bodyPr wrap="square" lIns="0" tIns="0" rIns="0" bIns="0" rtlCol="0" anchor="ctr"/>
+          <a:lstStyle/>
+          <a:p>
+            <a:pPr algn="ctr" indent="0" marL="0">
+              <a:buNone/>
+            </a:pPr>
+            <a:r>
+              <a:rPr lang="en-US" sz="2000" b="1" dirty="0">
+                <a:solidFill>
+                  <a:srgbClr val="FFFFFF"/>
+                </a:solidFill>
+                <a:latin typeface="Cambria" pitchFamily="34" charset="0"/>
+                <a:ea typeface="Cambria" pitchFamily="34" charset="-122"/>
+                <a:cs typeface="Cambria" pitchFamily="34" charset="-120"/>
+              </a:rPr>
+              <a:t>0</a:t>
+            </a:r>
+            <a:endParaRPr lang="en-US" sz="2000" dirty="0"/>
+          </a:p>
+        </p:txBody>
+      </p:sp>
+      <p:sp>
+        <p:nvSpPr>
+          <p:cNvPr id="9" name="Text 6"/>
+          <p:cNvSpPr/>
+          <p:nvPr/>
+        </p:nvSpPr>
+        <p:spPr>
+          <a:xfrm>
+            <a:off x="640080" y="2834640"/>
+            <a:ext cx="1475232" cy="292608"/>
+          </a:xfrm>
+          <a:prstGeom prst="rect">
+            <a:avLst/>
+          </a:prstGeom>
+          <a:noFill/>
+          <a:ln/>
+        </p:spPr>
+        <p:txBody>
+          <a:bodyPr wrap="square" lIns="0" tIns="0" rIns="0" bIns="0" rtlCol="0" anchor="ctr"/>
+          <a:lstStyle/>
+          <a:p>
+            <a:pPr algn="ctr" indent="0" marL="0">
+              <a:buNone/>
+            </a:pPr>
+            <a:r>
+              <a:rPr lang="en-US" sz="1300" b="1" dirty="0">
+                <a:solidFill>
+                  <a:srgbClr val="262B38"/>
+                </a:solidFill>
+                <a:latin typeface="Calibri" pitchFamily="34" charset="0"/>
+                <a:ea typeface="Calibri" pitchFamily="34" charset="-122"/>
+                <a:cs typeface="Calibri" pitchFamily="34" charset="-120"/>
+              </a:rPr>
+              <a:t>Design</a:t>
+            </a:r>
+            <a:endParaRPr lang="en-US" sz="1300" dirty="0"/>
+          </a:p>
+        </p:txBody>
+      </p:sp>
+      <p:sp>
+        <p:nvSpPr>
+          <p:cNvPr id="10" name="Text 7"/>
+          <p:cNvSpPr/>
+          <p:nvPr/>
+        </p:nvSpPr>
+        <p:spPr>
+          <a:xfrm>
+            <a:off x="640080" y="3127248"/>
+            <a:ext cx="1475232" cy="237744"/>
+          </a:xfrm>
+          <a:prstGeom prst="rect">
+            <a:avLst/>
+          </a:prstGeom>
+          <a:noFill/>
+          <a:ln/>
+        </p:spPr>
+        <p:txBody>
+          <a:bodyPr wrap="square" lIns="0" tIns="0" rIns="0" bIns="0" rtlCol="0" anchor="ctr"/>
+          <a:lstStyle/>
+          <a:p>
+            <a:pPr algn="ctr" indent="0" marL="0">
+              <a:buNone/>
+            </a:pPr>
+            <a:r>
+              <a:rPr lang="en-US" sz="900" b="1" spc="100" kern="0" dirty="0">
+                <a:solidFill>
+                  <a:srgbClr val="B07A1E"/>
+                </a:solidFill>
+                <a:latin typeface="Calibri" pitchFamily="34" charset="0"/>
+                <a:ea typeface="Calibri" pitchFamily="34" charset="-122"/>
+                <a:cs typeface="Calibri" pitchFamily="34" charset="-120"/>
+              </a:rPr>
+              <a:t>IN REVIEW</a:t>
+            </a:r>
+            <a:endParaRPr lang="en-US" sz="900" dirty="0"/>
+          </a:p>
+        </p:txBody>
+      </p:sp>
+      <p:sp>
+        <p:nvSpPr>
+          <p:cNvPr id="11" name="Text 8"/>
+          <p:cNvSpPr/>
+          <p:nvPr/>
+        </p:nvSpPr>
+        <p:spPr>
+          <a:xfrm>
+            <a:off x="676656" y="3429000"/>
+            <a:ext cx="1402080" cy="1463040"/>
+          </a:xfrm>
+          <a:prstGeom prst="rect">
+            <a:avLst/>
+          </a:prstGeom>
+          <a:noFill/>
+          <a:ln/>
+        </p:spPr>
+        <p:txBody>
+          <a:bodyPr wrap="square" lIns="0" tIns="0" rIns="0" bIns="0" rtlCol="0" anchor="ctr"/>
+          <a:lstStyle/>
+          <a:p>
+            <a:pPr algn="ctr" indent="0" marL="0">
+              <a:buNone/>
+            </a:pPr>
+            <a:r>
+              <a:rPr lang="en-US" sz="1000" dirty="0">
+                <a:solidFill>
+                  <a:srgbClr val="5A6272"/>
+                </a:solidFill>
+                <a:latin typeface="Calibri" pitchFamily="34" charset="0"/>
+                <a:ea typeface="Calibri" pitchFamily="34" charset="-122"/>
+                <a:cs typeface="Calibri" pitchFamily="34" charset="-120"/>
+              </a:rPr>
+              <a:t>this review — spec v0.1</a:t>
+            </a:r>
+            <a:endParaRPr lang="en-US" sz="1000" dirty="0"/>
+          </a:p>
+        </p:txBody>
+      </p:sp>
+      <p:sp>
+        <p:nvSpPr>
+          <p:cNvPr id="12" name="Shape 9"/>
+          <p:cNvSpPr/>
+          <p:nvPr/>
+        </p:nvSpPr>
+        <p:spPr>
+          <a:xfrm>
+            <a:off x="2206752" y="3474720"/>
+            <a:ext cx="228600" cy="0"/>
+          </a:xfrm>
+          <a:prstGeom prst="line">
+            <a:avLst/>
+          </a:prstGeom>
+          <a:noFill/>
+          <a:ln w="22225">
+            <a:solidFill>
+              <a:srgbClr val="1E2761"/>
+            </a:solidFill>
+            <a:prstDash val="solid"/>
+            <a:tailEnd type="arrow"/>
+          </a:ln>
+        </p:spPr>
+      </p:sp>
+      <p:sp>
+        <p:nvSpPr>
+          <p:cNvPr id="13" name="Shape 10"/>
+          <p:cNvSpPr/>
+          <p:nvPr/>
+        </p:nvSpPr>
+        <p:spPr>
+          <a:xfrm>
+            <a:off x="2435352" y="1920240"/>
+            <a:ext cx="1658112" cy="3108960"/>
+          </a:xfrm>
+          <a:prstGeom prst="roundRect">
+            <a:avLst>
+              <a:gd name="adj" fmla="val 4963"/>
+            </a:avLst>
+          </a:prstGeom>
+          <a:solidFill>
+            <a:srgbClr val="EEF4FB"/>
+          </a:solidFill>
+          <a:ln/>
+        </p:spPr>
+      </p:sp>
+      <p:sp>
+        <p:nvSpPr>
+          <p:cNvPr id="14" name="Shape 11"/>
+          <p:cNvSpPr/>
+          <p:nvPr/>
+        </p:nvSpPr>
+        <p:spPr>
+          <a:xfrm>
+            <a:off x="2990088" y="2148840"/>
+            <a:ext cx="548640" cy="548640"/>
+          </a:xfrm>
+          <a:prstGeom prst="ellipse">
+            <a:avLst/>
+          </a:prstGeom>
+          <a:solidFill>
+            <a:srgbClr val="1E2761"/>
+          </a:solidFill>
+          <a:ln/>
+        </p:spPr>
+      </p:sp>
+      <p:sp>
+        <p:nvSpPr>
+          <p:cNvPr id="15" name="Text 12"/>
+          <p:cNvSpPr/>
+          <p:nvPr/>
+        </p:nvSpPr>
+        <p:spPr>
+          <a:xfrm>
+            <a:off x="2990088" y="2176272"/>
+            <a:ext cx="548640" cy="502920"/>
+          </a:xfrm>
+          <a:prstGeom prst="rect">
+            <a:avLst/>
+          </a:prstGeom>
+          <a:noFill/>
+          <a:ln/>
+        </p:spPr>
+        <p:txBody>
+          <a:bodyPr wrap="square" lIns="0" tIns="0" rIns="0" bIns="0" rtlCol="0" anchor="ctr"/>
+          <a:lstStyle/>
+          <a:p>
+            <a:pPr algn="ctr" indent="0" marL="0">
+              <a:buNone/>
+            </a:pPr>
+            <a:r>
+              <a:rPr lang="en-US" sz="2000" b="1" dirty="0">
+                <a:solidFill>
+                  <a:srgbClr val="FFFFFF"/>
+                </a:solidFill>
+                <a:latin typeface="Cambria" pitchFamily="34" charset="0"/>
+                <a:ea typeface="Cambria" pitchFamily="34" charset="-122"/>
+                <a:cs typeface="Cambria" pitchFamily="34" charset="-120"/>
+              </a:rPr>
+              <a:t>1</a:t>
+            </a:r>
+            <a:endParaRPr lang="en-US" sz="2000" dirty="0"/>
+          </a:p>
+        </p:txBody>
+      </p:sp>
+      <p:sp>
+        <p:nvSpPr>
+          <p:cNvPr id="16" name="Text 13"/>
+          <p:cNvSpPr/>
+          <p:nvPr/>
+        </p:nvSpPr>
+        <p:spPr>
+          <a:xfrm>
+            <a:off x="2526792" y="2834640"/>
+            <a:ext cx="1475232" cy="292608"/>
+          </a:xfrm>
+          <a:prstGeom prst="rect">
+            <a:avLst/>
+          </a:prstGeom>
+          <a:noFill/>
+          <a:ln/>
+        </p:spPr>
+        <p:txBody>
+          <a:bodyPr wrap="square" lIns="0" tIns="0" rIns="0" bIns="0" rtlCol="0" anchor="ctr"/>
+          <a:lstStyle/>
+          <a:p>
+            <a:pPr algn="ctr" indent="0" marL="0">
+              <a:buNone/>
+            </a:pPr>
+            <a:r>
+              <a:rPr lang="en-US" sz="1300" b="1" dirty="0">
+                <a:solidFill>
+                  <a:srgbClr val="262B38"/>
+                </a:solidFill>
+                <a:latin typeface="Calibri" pitchFamily="34" charset="0"/>
+                <a:ea typeface="Calibri" pitchFamily="34" charset="-122"/>
+                <a:cs typeface="Calibri" pitchFamily="34" charset="-120"/>
+              </a:rPr>
+              <a:t>Baseline</a:t>
+            </a:r>
+            <a:endParaRPr lang="en-US" sz="1300" dirty="0"/>
+          </a:p>
+        </p:txBody>
+      </p:sp>
+      <p:sp>
+        <p:nvSpPr>
+          <p:cNvPr id="17" name="Text 14"/>
+          <p:cNvSpPr/>
+          <p:nvPr/>
+        </p:nvSpPr>
+        <p:spPr>
+          <a:xfrm>
+            <a:off x="2526792" y="3127248"/>
+            <a:ext cx="1475232" cy="237744"/>
+          </a:xfrm>
+          <a:prstGeom prst="rect">
+            <a:avLst/>
+          </a:prstGeom>
+          <a:noFill/>
+          <a:ln/>
+        </p:spPr>
+        <p:txBody>
+          <a:bodyPr wrap="square" lIns="0" tIns="0" rIns="0" bIns="0" rtlCol="0" anchor="ctr"/>
+          <a:lstStyle/>
+          <a:p>
+            <a:pPr algn="ctr" indent="0" marL="0">
+              <a:buNone/>
+            </a:pPr>
+            <a:r>
+              <a:rPr lang="en-US" sz="900" b="1" spc="100" kern="0" dirty="0">
+                <a:solidFill>
+                  <a:srgbClr val="1E2761"/>
+                </a:solidFill>
+                <a:latin typeface="Calibri" pitchFamily="34" charset="0"/>
+                <a:ea typeface="Calibri" pitchFamily="34" charset="-122"/>
+                <a:cs typeface="Calibri" pitchFamily="34" charset="-120"/>
+              </a:rPr>
+              <a:t>READY</a:t>
+            </a:r>
+            <a:endParaRPr lang="en-US" sz="900" dirty="0"/>
+          </a:p>
+        </p:txBody>
+      </p:sp>
+      <p:sp>
+        <p:nvSpPr>
+          <p:cNvPr id="18" name="Text 15"/>
+          <p:cNvSpPr/>
+          <p:nvPr/>
+        </p:nvSpPr>
+        <p:spPr>
+          <a:xfrm>
+            <a:off x="2563368" y="3429000"/>
+            <a:ext cx="1402080" cy="1463040"/>
+          </a:xfrm>
+          <a:prstGeom prst="rect">
+            <a:avLst/>
+          </a:prstGeom>
+          <a:noFill/>
+          <a:ln/>
+        </p:spPr>
+        <p:txBody>
+          <a:bodyPr wrap="square" lIns="0" tIns="0" rIns="0" bIns="0" rtlCol="0" anchor="ctr"/>
+          <a:lstStyle/>
+          <a:p>
+            <a:pPr algn="ctr" indent="0" marL="0">
+              <a:buNone/>
+            </a:pPr>
+            <a:r>
+              <a:rPr lang="en-US" sz="1000" dirty="0">
+                <a:solidFill>
+                  <a:srgbClr val="5A6272"/>
+                </a:solidFill>
+                <a:latin typeface="Calibri" pitchFamily="34" charset="0"/>
+                <a:ea typeface="Calibri" pitchFamily="34" charset="-122"/>
+                <a:cs typeface="Calibri" pitchFamily="34" charset="-120"/>
+              </a:rPr>
+              <a:t>notebook ready; needs assigned reviewer</a:t>
+            </a:r>
+            <a:endParaRPr lang="en-US" sz="1000" dirty="0"/>
+          </a:p>
+        </p:txBody>
+      </p:sp>
+      <p:sp>
+        <p:nvSpPr>
+          <p:cNvPr id="19" name="Shape 16"/>
+          <p:cNvSpPr/>
+          <p:nvPr/>
+        </p:nvSpPr>
+        <p:spPr>
+          <a:xfrm>
+            <a:off x="4093464" y="3474720"/>
+            <a:ext cx="228600" cy="0"/>
+          </a:xfrm>
+          <a:prstGeom prst="line">
+            <a:avLst/>
+          </a:prstGeom>
+          <a:noFill/>
+          <a:ln w="22225">
+            <a:solidFill>
+              <a:srgbClr val="1E2761"/>
+            </a:solidFill>
+            <a:prstDash val="solid"/>
+            <a:tailEnd type="arrow"/>
+          </a:ln>
+        </p:spPr>
+      </p:sp>
+      <p:sp>
+        <p:nvSpPr>
+          <p:cNvPr id="20" name="Shape 17"/>
+          <p:cNvSpPr/>
+          <p:nvPr/>
+        </p:nvSpPr>
+        <p:spPr>
+          <a:xfrm>
+            <a:off x="4322064" y="1920240"/>
+            <a:ext cx="1658112" cy="3108960"/>
+          </a:xfrm>
+          <a:prstGeom prst="roundRect">
+            <a:avLst>
+              <a:gd name="adj" fmla="val 4963"/>
+            </a:avLst>
+          </a:prstGeom>
+          <a:solidFill>
+            <a:srgbClr val="EEF4FB"/>
+          </a:solidFill>
+          <a:ln/>
+        </p:spPr>
+      </p:sp>
+      <p:sp>
+        <p:nvSpPr>
+          <p:cNvPr id="21" name="Shape 18"/>
+          <p:cNvSpPr/>
+          <p:nvPr/>
+        </p:nvSpPr>
+        <p:spPr>
+          <a:xfrm>
+            <a:off x="4876800" y="2148840"/>
+            <a:ext cx="548640" cy="548640"/>
+          </a:xfrm>
+          <a:prstGeom prst="ellipse">
+            <a:avLst/>
+          </a:prstGeom>
+          <a:solidFill>
+            <a:srgbClr val="1E2761"/>
+          </a:solidFill>
+          <a:ln/>
+        </p:spPr>
+      </p:sp>
+      <p:sp>
+        <p:nvSpPr>
+          <p:cNvPr id="22" name="Text 19"/>
+          <p:cNvSpPr/>
+          <p:nvPr/>
+        </p:nvSpPr>
+        <p:spPr>
+          <a:xfrm>
+            <a:off x="4876800" y="2176272"/>
+            <a:ext cx="548640" cy="502920"/>
+          </a:xfrm>
+          <a:prstGeom prst="rect">
+            <a:avLst/>
+          </a:prstGeom>
+          <a:noFill/>
+          <a:ln/>
+        </p:spPr>
+        <p:txBody>
+          <a:bodyPr wrap="square" lIns="0" tIns="0" rIns="0" bIns="0" rtlCol="0" anchor="ctr"/>
+          <a:lstStyle/>
+          <a:p>
+            <a:pPr algn="ctr" indent="0" marL="0">
+              <a:buNone/>
+            </a:pPr>
+            <a:r>
+              <a:rPr lang="en-US" sz="2000" b="1" dirty="0">
+                <a:solidFill>
+                  <a:srgbClr val="FFFFFF"/>
+                </a:solidFill>
+                <a:latin typeface="Cambria" pitchFamily="34" charset="0"/>
+                <a:ea typeface="Cambria" pitchFamily="34" charset="-122"/>
+                <a:cs typeface="Cambria" pitchFamily="34" charset="-120"/>
+              </a:rPr>
+              <a:t>2</a:t>
+            </a:r>
+            <a:endParaRPr lang="en-US" sz="2000" dirty="0"/>
+          </a:p>
+        </p:txBody>
+      </p:sp>
+      <p:sp>
+        <p:nvSpPr>
+          <p:cNvPr id="23" name="Text 20"/>
+          <p:cNvSpPr/>
+          <p:nvPr/>
+        </p:nvSpPr>
+        <p:spPr>
+          <a:xfrm>
+            <a:off x="4413504" y="2834640"/>
+            <a:ext cx="1475232" cy="292608"/>
+          </a:xfrm>
+          <a:prstGeom prst="rect">
+            <a:avLst/>
+          </a:prstGeom>
+          <a:noFill/>
+          <a:ln/>
+        </p:spPr>
+        <p:txBody>
+          <a:bodyPr wrap="square" lIns="0" tIns="0" rIns="0" bIns="0" rtlCol="0" anchor="ctr"/>
+          <a:lstStyle/>
+          <a:p>
+            <a:pPr algn="ctr" indent="0" marL="0">
+              <a:buNone/>
+            </a:pPr>
+            <a:r>
+              <a:rPr lang="en-US" sz="1300" b="1" dirty="0">
+                <a:solidFill>
+                  <a:srgbClr val="262B38"/>
+                </a:solidFill>
+                <a:latin typeface="Calibri" pitchFamily="34" charset="0"/>
+                <a:ea typeface="Calibri" pitchFamily="34" charset="-122"/>
+                <a:cs typeface="Calibri" pitchFamily="34" charset="-120"/>
+              </a:rPr>
+              <a:t>Implement</a:t>
+            </a:r>
+            <a:endParaRPr lang="en-US" sz="1300" dirty="0"/>
+          </a:p>
+        </p:txBody>
+      </p:sp>
+      <p:sp>
+        <p:nvSpPr>
+          <p:cNvPr id="24" name="Text 21"/>
+          <p:cNvSpPr/>
+          <p:nvPr/>
+        </p:nvSpPr>
+        <p:spPr>
+          <a:xfrm>
+            <a:off x="4413504" y="3127248"/>
+            <a:ext cx="1475232" cy="237744"/>
+          </a:xfrm>
+          <a:prstGeom prst="rect">
+            <a:avLst/>
+          </a:prstGeom>
+          <a:noFill/>
+          <a:ln/>
+        </p:spPr>
+        <p:txBody>
+          <a:bodyPr wrap="square" lIns="0" tIns="0" rIns="0" bIns="0" rtlCol="0" anchor="ctr"/>
+          <a:lstStyle/>
+          <a:p>
+            <a:pPr algn="ctr" indent="0" marL="0">
+              <a:buNone/>
+            </a:pPr>
+            <a:r>
+              <a:rPr lang="en-US" sz="900" b="1" spc="100" kern="0" dirty="0">
+                <a:solidFill>
+                  <a:srgbClr val="1E2761"/>
+                </a:solidFill>
+                <a:latin typeface="Calibri" pitchFamily="34" charset="0"/>
+                <a:ea typeface="Calibri" pitchFamily="34" charset="-122"/>
+                <a:cs typeface="Calibri" pitchFamily="34" charset="-120"/>
+              </a:rPr>
+              <a:t>PREPPED</a:t>
+            </a:r>
+            <a:endParaRPr lang="en-US" sz="900" dirty="0"/>
+          </a:p>
+        </p:txBody>
+      </p:sp>
+      <p:sp>
+        <p:nvSpPr>
+          <p:cNvPr id="25" name="Text 22"/>
+          <p:cNvSpPr/>
+          <p:nvPr/>
+        </p:nvSpPr>
+        <p:spPr>
+          <a:xfrm>
+            <a:off x="4450080" y="3429000"/>
+            <a:ext cx="1402080" cy="1463040"/>
+          </a:xfrm>
+          <a:prstGeom prst="rect">
+            <a:avLst/>
+          </a:prstGeom>
+          <a:noFill/>
+          <a:ln/>
+        </p:spPr>
+        <p:txBody>
+          <a:bodyPr wrap="square" lIns="0" tIns="0" rIns="0" bIns="0" rtlCol="0" anchor="ctr"/>
+          <a:lstStyle/>
+          <a:p>
+            <a:pPr algn="ctr" indent="0" marL="0">
+              <a:buNone/>
+            </a:pPr>
+            <a:r>
+              <a:rPr lang="en-US" sz="1000" dirty="0">
+                <a:solidFill>
+                  <a:srgbClr val="5A6272"/>
+                </a:solidFill>
+                <a:latin typeface="Calibri" pitchFamily="34" charset="0"/>
+                <a:ea typeface="Calibri" pitchFamily="34" charset="-122"/>
+                <a:cs typeface="Calibri" pitchFamily="34" charset="-120"/>
+              </a:rPr>
+              <a:t>V1 pipeline + V2 variant prepped for code review</a:t>
+            </a:r>
+            <a:endParaRPr lang="en-US" sz="1000" dirty="0"/>
+          </a:p>
+        </p:txBody>
+      </p:sp>
+      <p:sp>
+        <p:nvSpPr>
+          <p:cNvPr id="26" name="Shape 23"/>
+          <p:cNvSpPr/>
+          <p:nvPr/>
+        </p:nvSpPr>
+        <p:spPr>
+          <a:xfrm>
+            <a:off x="5980176" y="3474720"/>
+            <a:ext cx="228600" cy="0"/>
+          </a:xfrm>
+          <a:prstGeom prst="line">
+            <a:avLst/>
+          </a:prstGeom>
+          <a:noFill/>
+          <a:ln w="22225">
+            <a:solidFill>
+              <a:srgbClr val="1E2761"/>
+            </a:solidFill>
+            <a:prstDash val="solid"/>
+            <a:tailEnd type="arrow"/>
+          </a:ln>
+        </p:spPr>
+      </p:sp>
+      <p:sp>
+        <p:nvSpPr>
+          <p:cNvPr id="27" name="Shape 24"/>
+          <p:cNvSpPr/>
+          <p:nvPr/>
+        </p:nvSpPr>
+        <p:spPr>
+          <a:xfrm>
+            <a:off x="6208776" y="1920240"/>
+            <a:ext cx="1658112" cy="3108960"/>
+          </a:xfrm>
+          <a:prstGeom prst="roundRect">
+            <a:avLst>
+              <a:gd name="adj" fmla="val 4963"/>
+            </a:avLst>
+          </a:prstGeom>
+          <a:solidFill>
+            <a:srgbClr val="EEF4FB"/>
+          </a:solidFill>
+          <a:ln/>
+        </p:spPr>
+      </p:sp>
+      <p:sp>
+        <p:nvSpPr>
+          <p:cNvPr id="28" name="Shape 25"/>
+          <p:cNvSpPr/>
+          <p:nvPr/>
+        </p:nvSpPr>
+        <p:spPr>
+          <a:xfrm>
+            <a:off x="6763512" y="2148840"/>
+            <a:ext cx="548640" cy="548640"/>
+          </a:xfrm>
+          <a:prstGeom prst="ellipse">
+            <a:avLst/>
+          </a:prstGeom>
+          <a:solidFill>
+            <a:srgbClr val="1E2761"/>
+          </a:solidFill>
+          <a:ln/>
+        </p:spPr>
+      </p:sp>
+      <p:sp>
+        <p:nvSpPr>
+          <p:cNvPr id="29" name="Text 26"/>
+          <p:cNvSpPr/>
+          <p:nvPr/>
+        </p:nvSpPr>
+        <p:spPr>
+          <a:xfrm>
+            <a:off x="6763512" y="2176272"/>
+            <a:ext cx="548640" cy="502920"/>
+          </a:xfrm>
+          <a:prstGeom prst="rect">
+            <a:avLst/>
+          </a:prstGeom>
+          <a:noFill/>
+          <a:ln/>
+        </p:spPr>
+        <p:txBody>
+          <a:bodyPr wrap="square" lIns="0" tIns="0" rIns="0" bIns="0" rtlCol="0" anchor="ctr"/>
+          <a:lstStyle/>
+          <a:p>
+            <a:pPr algn="ctr" indent="0" marL="0">
+              <a:buNone/>
+            </a:pPr>
+            <a:r>
+              <a:rPr lang="en-US" sz="2000" b="1" dirty="0">
+                <a:solidFill>
+                  <a:srgbClr val="FFFFFF"/>
+                </a:solidFill>
+                <a:latin typeface="Cambria" pitchFamily="34" charset="0"/>
+                <a:ea typeface="Cambria" pitchFamily="34" charset="-122"/>
+                <a:cs typeface="Cambria" pitchFamily="34" charset="-120"/>
+              </a:rPr>
+              <a:t>3</a:t>
+            </a:r>
+            <a:endParaRPr lang="en-US" sz="2000" dirty="0"/>
+          </a:p>
+        </p:txBody>
+      </p:sp>
+      <p:sp>
+        <p:nvSpPr>
+          <p:cNvPr id="30" name="Text 27"/>
+          <p:cNvSpPr/>
+          <p:nvPr/>
+        </p:nvSpPr>
+        <p:spPr>
+          <a:xfrm>
+            <a:off x="6300216" y="2834640"/>
+            <a:ext cx="1475232" cy="292608"/>
+          </a:xfrm>
+          <a:prstGeom prst="rect">
+            <a:avLst/>
+          </a:prstGeom>
+          <a:noFill/>
+          <a:ln/>
+        </p:spPr>
+        <p:txBody>
+          <a:bodyPr wrap="square" lIns="0" tIns="0" rIns="0" bIns="0" rtlCol="0" anchor="ctr"/>
+          <a:lstStyle/>
+          <a:p>
+            <a:pPr algn="ctr" indent="0" marL="0">
+              <a:buNone/>
+            </a:pPr>
+            <a:r>
+              <a:rPr lang="en-US" sz="1300" b="1" dirty="0">
+                <a:solidFill>
+                  <a:srgbClr val="262B38"/>
+                </a:solidFill>
+                <a:latin typeface="Calibri" pitchFamily="34" charset="0"/>
+                <a:ea typeface="Calibri" pitchFamily="34" charset="-122"/>
+                <a:cs typeface="Calibri" pitchFamily="34" charset="-120"/>
+              </a:rPr>
+              <a:t>Smoke</a:t>
+            </a:r>
+            <a:endParaRPr lang="en-US" sz="1300" dirty="0"/>
+          </a:p>
+        </p:txBody>
+      </p:sp>
+      <p:sp>
+        <p:nvSpPr>
+          <p:cNvPr id="31" name="Text 28"/>
+          <p:cNvSpPr/>
+          <p:nvPr/>
+        </p:nvSpPr>
+        <p:spPr>
+          <a:xfrm>
+            <a:off x="6300216" y="3127248"/>
+            <a:ext cx="1475232" cy="237744"/>
+          </a:xfrm>
+          <a:prstGeom prst="rect">
+            <a:avLst/>
+          </a:prstGeom>
+          <a:noFill/>
+          <a:ln/>
+        </p:spPr>
+        <p:txBody>
+          <a:bodyPr wrap="square" lIns="0" tIns="0" rIns="0" bIns="0" rtlCol="0" anchor="ctr"/>
+          <a:lstStyle/>
+          <a:p>
+            <a:pPr algn="ctr" indent="0" marL="0">
+              <a:buNone/>
+            </a:pPr>
+            <a:r>
+              <a:rPr lang="en-US" sz="900" b="1" spc="100" kern="0" dirty="0">
+                <a:solidFill>
+                  <a:srgbClr val="1E2761"/>
+                </a:solidFill>
+                <a:latin typeface="Calibri" pitchFamily="34" charset="0"/>
+                <a:ea typeface="Calibri" pitchFamily="34" charset="-122"/>
+                <a:cs typeface="Calibri" pitchFamily="34" charset="-120"/>
+              </a:rPr>
+              <a:t>BUILT-IN</a:t>
+            </a:r>
+            <a:endParaRPr lang="en-US" sz="900" dirty="0"/>
+          </a:p>
+        </p:txBody>
+      </p:sp>
+      <p:sp>
+        <p:nvSpPr>
+          <p:cNvPr id="32" name="Text 29"/>
+          <p:cNvSpPr/>
+          <p:nvPr/>
+        </p:nvSpPr>
+        <p:spPr>
+          <a:xfrm>
+            <a:off x="6336792" y="3429000"/>
+            <a:ext cx="1402080" cy="1463040"/>
+          </a:xfrm>
+          <a:prstGeom prst="rect">
+            <a:avLst/>
+          </a:prstGeom>
+          <a:noFill/>
+          <a:ln/>
+        </p:spPr>
+        <p:txBody>
+          <a:bodyPr wrap="square" lIns="0" tIns="0" rIns="0" bIns="0" rtlCol="0" anchor="ctr"/>
+          <a:lstStyle/>
+          <a:p>
+            <a:pPr algn="ctr" indent="0" marL="0">
+              <a:buNone/>
+            </a:pPr>
+            <a:r>
+              <a:rPr lang="en-US" sz="1000" dirty="0">
+                <a:solidFill>
+                  <a:srgbClr val="5A6272"/>
+                </a:solidFill>
+                <a:latin typeface="Calibri" pitchFamily="34" charset="0"/>
+                <a:ea typeface="Calibri" pitchFamily="34" charset="-122"/>
+                <a:cs typeface="Calibri" pitchFamily="34" charset="-120"/>
+              </a:rPr>
+              <a:t>FAST mode built into every notebook</a:t>
+            </a:r>
+            <a:endParaRPr lang="en-US" sz="1000" dirty="0"/>
+          </a:p>
+        </p:txBody>
+      </p:sp>
+      <p:sp>
+        <p:nvSpPr>
+          <p:cNvPr id="33" name="Shape 30"/>
+          <p:cNvSpPr/>
+          <p:nvPr/>
+        </p:nvSpPr>
+        <p:spPr>
+          <a:xfrm>
+            <a:off x="7866888" y="3474720"/>
+            <a:ext cx="228600" cy="0"/>
+          </a:xfrm>
+          <a:prstGeom prst="line">
+            <a:avLst/>
+          </a:prstGeom>
+          <a:noFill/>
+          <a:ln w="22225">
+            <a:solidFill>
+              <a:srgbClr val="1E2761"/>
+            </a:solidFill>
+            <a:prstDash val="solid"/>
+            <a:tailEnd type="arrow"/>
+          </a:ln>
+        </p:spPr>
+      </p:sp>
+      <p:sp>
+        <p:nvSpPr>
+          <p:cNvPr id="34" name="Shape 31"/>
+          <p:cNvSpPr/>
+          <p:nvPr/>
+        </p:nvSpPr>
+        <p:spPr>
+          <a:xfrm>
+            <a:off x="8095488" y="1920240"/>
+            <a:ext cx="1658112" cy="3108960"/>
+          </a:xfrm>
+          <a:prstGeom prst="roundRect">
+            <a:avLst>
+              <a:gd name="adj" fmla="val 4963"/>
+            </a:avLst>
+          </a:prstGeom>
+          <a:solidFill>
+            <a:srgbClr val="EEF4FB"/>
+          </a:solidFill>
+          <a:ln/>
+        </p:spPr>
+      </p:sp>
+      <p:sp>
+        <p:nvSpPr>
+          <p:cNvPr id="35" name="Shape 32"/>
+          <p:cNvSpPr/>
+          <p:nvPr/>
+        </p:nvSpPr>
+        <p:spPr>
+          <a:xfrm>
+            <a:off x="8650224" y="2148840"/>
+            <a:ext cx="548640" cy="548640"/>
+          </a:xfrm>
+          <a:prstGeom prst="ellipse">
+            <a:avLst/>
+          </a:prstGeom>
+          <a:solidFill>
+            <a:srgbClr val="5A6272"/>
+          </a:solidFill>
+          <a:ln/>
+        </p:spPr>
+      </p:sp>
+      <p:sp>
+        <p:nvSpPr>
+          <p:cNvPr id="36" name="Text 33"/>
+          <p:cNvSpPr/>
+          <p:nvPr/>
+        </p:nvSpPr>
+        <p:spPr>
+          <a:xfrm>
+            <a:off x="8650224" y="2176272"/>
+            <a:ext cx="548640" cy="502920"/>
+          </a:xfrm>
+          <a:prstGeom prst="rect">
+            <a:avLst/>
+          </a:prstGeom>
+          <a:noFill/>
+          <a:ln/>
+        </p:spPr>
+        <p:txBody>
+          <a:bodyPr wrap="square" lIns="0" tIns="0" rIns="0" bIns="0" rtlCol="0" anchor="ctr"/>
+          <a:lstStyle/>
+          <a:p>
+            <a:pPr algn="ctr" indent="0" marL="0">
+              <a:buNone/>
+            </a:pPr>
+            <a:r>
+              <a:rPr lang="en-US" sz="2000" b="1" dirty="0">
+                <a:solidFill>
+                  <a:srgbClr val="FFFFFF"/>
+                </a:solidFill>
+                <a:latin typeface="Cambria" pitchFamily="34" charset="0"/>
+                <a:ea typeface="Cambria" pitchFamily="34" charset="-122"/>
+                <a:cs typeface="Cambria" pitchFamily="34" charset="-120"/>
+              </a:rPr>
+              <a:t>4</a:t>
+            </a:r>
+            <a:endParaRPr lang="en-US" sz="2000" dirty="0"/>
+          </a:p>
+        </p:txBody>
+      </p:sp>
+      <p:sp>
+        <p:nvSpPr>
+          <p:cNvPr id="37" name="Text 34"/>
+          <p:cNvSpPr/>
+          <p:nvPr/>
+        </p:nvSpPr>
+        <p:spPr>
+          <a:xfrm>
+            <a:off x="8186928" y="2834640"/>
+            <a:ext cx="1475232" cy="292608"/>
+          </a:xfrm>
+          <a:prstGeom prst="rect">
+            <a:avLst/>
+          </a:prstGeom>
+          <a:noFill/>
+          <a:ln/>
+        </p:spPr>
+        <p:txBody>
+          <a:bodyPr wrap="square" lIns="0" tIns="0" rIns="0" bIns="0" rtlCol="0" anchor="ctr"/>
+          <a:lstStyle/>
+          <a:p>
+            <a:pPr algn="ctr" indent="0" marL="0">
+              <a:buNone/>
+            </a:pPr>
+            <a:r>
+              <a:rPr lang="en-US" sz="1300" b="1" dirty="0">
+                <a:solidFill>
+                  <a:srgbClr val="262B38"/>
+                </a:solidFill>
+                <a:latin typeface="Calibri" pitchFamily="34" charset="0"/>
+                <a:ea typeface="Calibri" pitchFamily="34" charset="-122"/>
+                <a:cs typeface="Calibri" pitchFamily="34" charset="-120"/>
+              </a:rPr>
+              <a:t>Full run</a:t>
+            </a:r>
+            <a:endParaRPr lang="en-US" sz="1300" dirty="0"/>
+          </a:p>
+        </p:txBody>
+      </p:sp>
+      <p:sp>
+        <p:nvSpPr>
+          <p:cNvPr id="38" name="Text 35"/>
+          <p:cNvSpPr/>
+          <p:nvPr/>
+        </p:nvSpPr>
+        <p:spPr>
+          <a:xfrm>
+            <a:off x="8186928" y="3127248"/>
+            <a:ext cx="1475232" cy="237744"/>
+          </a:xfrm>
+          <a:prstGeom prst="rect">
+            <a:avLst/>
+          </a:prstGeom>
+          <a:noFill/>
+          <a:ln/>
+        </p:spPr>
+        <p:txBody>
+          <a:bodyPr wrap="square" lIns="0" tIns="0" rIns="0" bIns="0" rtlCol="0" anchor="ctr"/>
+          <a:lstStyle/>
+          <a:p>
+            <a:pPr algn="ctr" indent="0" marL="0">
+              <a:buNone/>
+            </a:pPr>
+            <a:r>
+              <a:rPr lang="en-US" sz="900" b="1" spc="100" kern="0" dirty="0">
+                <a:solidFill>
+                  <a:srgbClr val="5A6272"/>
+                </a:solidFill>
+                <a:latin typeface="Calibri" pitchFamily="34" charset="0"/>
+                <a:ea typeface="Calibri" pitchFamily="34" charset="-122"/>
+                <a:cs typeface="Calibri" pitchFamily="34" charset="-120"/>
+              </a:rPr>
+              <a:t>AWAITS 0–3</a:t>
+            </a:r>
+            <a:endParaRPr lang="en-US" sz="900" dirty="0"/>
+          </a:p>
+        </p:txBody>
+      </p:sp>
+      <p:sp>
+        <p:nvSpPr>
+          <p:cNvPr id="39" name="Text 36"/>
+          <p:cNvSpPr/>
+          <p:nvPr/>
+        </p:nvSpPr>
+        <p:spPr>
+          <a:xfrm>
+            <a:off x="8223504" y="3429000"/>
+            <a:ext cx="1402080" cy="1463040"/>
+          </a:xfrm>
+          <a:prstGeom prst="rect">
+            <a:avLst/>
+          </a:prstGeom>
+          <a:noFill/>
+          <a:ln/>
+        </p:spPr>
+        <p:txBody>
+          <a:bodyPr wrap="square" lIns="0" tIns="0" rIns="0" bIns="0" rtlCol="0" anchor="ctr"/>
+          <a:lstStyle/>
+          <a:p>
+            <a:pPr algn="ctr" indent="0" marL="0">
+              <a:buNone/>
+            </a:pPr>
+            <a:r>
+              <a:rPr lang="en-US" sz="1000" dirty="0">
+                <a:solidFill>
+                  <a:srgbClr val="5A6272"/>
+                </a:solidFill>
+                <a:latin typeface="Calibri" pitchFamily="34" charset="0"/>
+                <a:ea typeface="Calibri" pitchFamily="34" charset="-122"/>
+                <a:cs typeface="Calibri" pitchFamily="34" charset="-120"/>
+              </a:rPr>
+              <a:t>frozen config, TUNE→DEVTEST protocol</a:t>
+            </a:r>
+            <a:endParaRPr lang="en-US" sz="1000" dirty="0"/>
+          </a:p>
+        </p:txBody>
+      </p:sp>
+      <p:sp>
+        <p:nvSpPr>
+          <p:cNvPr id="40" name="Shape 37"/>
+          <p:cNvSpPr/>
+          <p:nvPr/>
+        </p:nvSpPr>
+        <p:spPr>
+          <a:xfrm>
+            <a:off x="9753600" y="3474720"/>
+            <a:ext cx="228600" cy="0"/>
+          </a:xfrm>
+          <a:prstGeom prst="line">
+            <a:avLst/>
+          </a:prstGeom>
+          <a:noFill/>
+          <a:ln w="22225">
+            <a:solidFill>
+              <a:srgbClr val="1E2761"/>
+            </a:solidFill>
+            <a:prstDash val="solid"/>
+            <a:tailEnd type="arrow"/>
+          </a:ln>
+        </p:spPr>
+      </p:sp>
+      <p:sp>
+        <p:nvSpPr>
+          <p:cNvPr id="41" name="Shape 38"/>
+          <p:cNvSpPr/>
+          <p:nvPr/>
+        </p:nvSpPr>
+        <p:spPr>
+          <a:xfrm>
+            <a:off x="9982200" y="1920240"/>
+            <a:ext cx="1658112" cy="3108960"/>
+          </a:xfrm>
+          <a:prstGeom prst="roundRect">
+            <a:avLst>
+              <a:gd name="adj" fmla="val 4963"/>
+            </a:avLst>
+          </a:prstGeom>
+          <a:solidFill>
+            <a:srgbClr val="EEF4FB"/>
+          </a:solidFill>
+          <a:ln/>
+        </p:spPr>
+      </p:sp>
+      <p:sp>
+        <p:nvSpPr>
+          <p:cNvPr id="42" name="Shape 39"/>
+          <p:cNvSpPr/>
+          <p:nvPr/>
+        </p:nvSpPr>
+        <p:spPr>
+          <a:xfrm>
+            <a:off x="10536936" y="2148840"/>
+            <a:ext cx="548640" cy="548640"/>
+          </a:xfrm>
+          <a:prstGeom prst="ellipse">
+            <a:avLst/>
+          </a:prstGeom>
+          <a:solidFill>
+            <a:srgbClr val="5A6272"/>
+          </a:solidFill>
+          <a:ln/>
+        </p:spPr>
+      </p:sp>
+      <p:sp>
+        <p:nvSpPr>
+          <p:cNvPr id="43" name="Text 40"/>
+          <p:cNvSpPr/>
+          <p:nvPr/>
+        </p:nvSpPr>
+        <p:spPr>
+          <a:xfrm>
+            <a:off x="10536936" y="2176272"/>
+            <a:ext cx="548640" cy="502920"/>
+          </a:xfrm>
+          <a:prstGeom prst="rect">
+            <a:avLst/>
+          </a:prstGeom>
+          <a:noFill/>
+          <a:ln/>
+        </p:spPr>
+        <p:txBody>
+          <a:bodyPr wrap="square" lIns="0" tIns="0" rIns="0" bIns="0" rtlCol="0" anchor="ctr"/>
+          <a:lstStyle/>
+          <a:p>
+            <a:pPr algn="ctr" indent="0" marL="0">
+              <a:buNone/>
+            </a:pPr>
+            <a:r>
+              <a:rPr lang="en-US" sz="2000" b="1" dirty="0">
+                <a:solidFill>
+                  <a:srgbClr val="FFFFFF"/>
+                </a:solidFill>
+                <a:latin typeface="Cambria" pitchFamily="34" charset="0"/>
+                <a:ea typeface="Cambria" pitchFamily="34" charset="-122"/>
+                <a:cs typeface="Cambria" pitchFamily="34" charset="-120"/>
+              </a:rPr>
+              <a:t>5</a:t>
+            </a:r>
+            <a:endParaRPr lang="en-US" sz="2000" dirty="0"/>
+          </a:p>
+        </p:txBody>
+      </p:sp>
+      <p:sp>
+        <p:nvSpPr>
+          <p:cNvPr id="44" name="Text 41"/>
+          <p:cNvSpPr/>
+          <p:nvPr/>
+        </p:nvSpPr>
+        <p:spPr>
+          <a:xfrm>
+            <a:off x="10073640" y="2834640"/>
+            <a:ext cx="1475232" cy="292608"/>
+          </a:xfrm>
+          <a:prstGeom prst="rect">
+            <a:avLst/>
+          </a:prstGeom>
+          <a:noFill/>
+          <a:ln/>
+        </p:spPr>
+        <p:txBody>
+          <a:bodyPr wrap="square" lIns="0" tIns="0" rIns="0" bIns="0" rtlCol="0" anchor="ctr"/>
+          <a:lstStyle/>
+          <a:p>
+            <a:pPr algn="ctr" indent="0" marL="0">
+              <a:buNone/>
+            </a:pPr>
+            <a:r>
+              <a:rPr lang="en-US" sz="1300" b="1" dirty="0">
+                <a:solidFill>
+                  <a:srgbClr val="262B38"/>
+                </a:solidFill>
+                <a:latin typeface="Calibri" pitchFamily="34" charset="0"/>
+                <a:ea typeface="Calibri" pitchFamily="34" charset="-122"/>
+                <a:cs typeface="Calibri" pitchFamily="34" charset="-120"/>
+              </a:rPr>
+              <a:t>Audit</a:t>
+            </a:r>
+            <a:endParaRPr lang="en-US" sz="1300" dirty="0"/>
+          </a:p>
+        </p:txBody>
+      </p:sp>
+      <p:sp>
+        <p:nvSpPr>
+          <p:cNvPr id="45" name="Text 42"/>
+          <p:cNvSpPr/>
+          <p:nvPr/>
+        </p:nvSpPr>
+        <p:spPr>
+          <a:xfrm>
+            <a:off x="10073640" y="3127248"/>
+            <a:ext cx="1475232" cy="237744"/>
+          </a:xfrm>
+          <a:prstGeom prst="rect">
+            <a:avLst/>
+          </a:prstGeom>
+          <a:noFill/>
+          <a:ln/>
+        </p:spPr>
+        <p:txBody>
+          <a:bodyPr wrap="square" lIns="0" tIns="0" rIns="0" bIns="0" rtlCol="0" anchor="ctr"/>
+          <a:lstStyle/>
+          <a:p>
+            <a:pPr algn="ctr" indent="0" marL="0">
+              <a:buNone/>
+            </a:pPr>
+            <a:r>
+              <a:rPr lang="en-US" sz="900" b="1" spc="100" kern="0" dirty="0">
+                <a:solidFill>
+                  <a:srgbClr val="5A6272"/>
+                </a:solidFill>
+                <a:latin typeface="Calibri" pitchFamily="34" charset="0"/>
+                <a:ea typeface="Calibri" pitchFamily="34" charset="-122"/>
+                <a:cs typeface="Calibri" pitchFamily="34" charset="-120"/>
+              </a:rPr>
+              <a:t>CONVENTIONS SET</a:t>
+            </a:r>
+            <a:endParaRPr lang="en-US" sz="900" dirty="0"/>
+          </a:p>
+        </p:txBody>
+      </p:sp>
+      <p:sp>
+        <p:nvSpPr>
+          <p:cNvPr id="46" name="Text 43"/>
+          <p:cNvSpPr/>
+          <p:nvPr/>
+        </p:nvSpPr>
+        <p:spPr>
+          <a:xfrm>
+            <a:off x="10110216" y="3429000"/>
+            <a:ext cx="1402080" cy="1463040"/>
+          </a:xfrm>
+          <a:prstGeom prst="rect">
+            <a:avLst/>
+          </a:prstGeom>
+          <a:noFill/>
+          <a:ln/>
+        </p:spPr>
+        <p:txBody>
+          <a:bodyPr wrap="square" lIns="0" tIns="0" rIns="0" bIns="0" rtlCol="0" anchor="ctr"/>
+          <a:lstStyle/>
+          <a:p>
+            <a:pPr algn="ctr" indent="0" marL="0">
+              <a:buNone/>
+            </a:pPr>
+            <a:r>
+              <a:rPr lang="en-US" sz="1000" dirty="0">
+                <a:solidFill>
+                  <a:srgbClr val="5A6272"/>
+                </a:solidFill>
+                <a:latin typeface="Calibri" pitchFamily="34" charset="0"/>
+                <a:ea typeface="Calibri" pitchFamily="34" charset="-122"/>
+                <a:cs typeface="Calibri" pitchFamily="34" charset="-120"/>
+              </a:rPr>
+              <a:t>SHA-256 artifacts, configs, transcripts committed</a:t>
+            </a:r>
+            <a:endParaRPr lang="en-US" sz="1000" dirty="0"/>
+          </a:p>
+        </p:txBody>
+      </p:sp>
+      <p:sp>
+        <p:nvSpPr>
+          <p:cNvPr id="47" name="Text 44"/>
+          <p:cNvSpPr/>
+          <p:nvPr/>
+        </p:nvSpPr>
+        <p:spPr>
+          <a:xfrm>
+            <a:off x="548640" y="5394960"/>
+            <a:ext cx="11091672" cy="320040"/>
+          </a:xfrm>
+          <a:prstGeom prst="rect">
+            <a:avLst/>
+          </a:prstGeom>
+          <a:noFill/>
+          <a:ln/>
+        </p:spPr>
+        <p:txBody>
+          <a:bodyPr wrap="square" lIns="0" tIns="0" rIns="0" bIns="0" rtlCol="0" anchor="ctr"/>
+          <a:lstStyle/>
+          <a:p>
+            <a:pPr algn="ctr" indent="0" marL="0">
+              <a:buNone/>
+            </a:pPr>
+            <a:r>
+              <a:rPr lang="en-US" sz="1250" i="1" dirty="0">
+                <a:solidFill>
+                  <a:srgbClr val="5A6272"/>
+                </a:solidFill>
+                <a:latin typeface="Calibri" pitchFamily="34" charset="0"/>
+                <a:ea typeface="Calibri" pitchFamily="34" charset="-122"/>
+                <a:cs typeface="Calibri" pitchFamily="34" charset="-120"/>
+              </a:rPr>
+              <a:t>Policy guarantee honored: no proposed-method implementation runs as an experiment until Phases 0 and 1 are approved.</a:t>
+            </a:r>
+            <a:endParaRPr lang="en-US" sz="1250" dirty="0"/>
+          </a:p>
+        </p:txBody>
+      </p:sp>
+    </p:spTree>
+  </p:cSld>
+  <p:clrMapOvr>
+    <a:masterClrMapping/>
+  </p:clrMapOvr>
+</p:sld>
+</file>
+
+<file path=ppt/slides/slide15.xml><?xml version="1.0" encoding="utf-8"?>
+<p:sld xmlns:a="http://schemas.openxmlformats.org/drawingml/2006/main" xmlns:r="http://schemas.openxmlformats.org/officeDocument/2006/relationships" xmlns:p="http://schemas.openxmlformats.org/presentationml/2006/main">
+  <p:cSld name="Slide 15">
     <p:bg>
       <p:bgPr>
         <a:solidFill>
@@ -7429,7 +9479,7 @@
                 <a:ea typeface="Calibri" pitchFamily="34" charset="-122"/>
                 <a:cs typeface="Calibri" pitchFamily="34" charset="-120"/>
               </a:rPr>
-              <a:t>W calibration corpus — accept measure-then-freeze via the 2×2 alignment grid (§10.3)</a:t>
+              <a:t>W calibration — adopt audio-conditioned W_audio, layer 3 (measured: 1.000 vs 0.28–0.31 top-1 for silence-fitted W on audio states)</a:t>
             </a:r>
             <a:endParaRPr lang="en-US" sz="1200" dirty="0"/>
           </a:p>

</xml_diff>

<commit_message>
Exp-05 results complete the 2x2 calibration grid — deck, spec, wiki updated
Text-to-text LibriSpeech run (n_per_split=1000): W_text_ls 1.000
in-domain at layer 4; corpus effect minor (W_wikitext 0.97/0.92 on LS
text states); conditioning effect decisive and asymmetric (W_audio
transfers to text states at 0.97/0.99 while silence-fitted matrices
collapse on audio states at 0.28/0.31); text-only calibration fails
the early-prefix regime (0.06/0.13 at 25%). Deck results slide now
presents the completed grid; spec §10.3 strengthened; exp-05 filed
with cross-links.

Co-Authored-By: Claude Fable 5 <noreply@anthropic.com>
</commit_message>
<xml_diff>
--- a/phase0_spec_review.pptx
+++ b/phase0_spec_review.pptx
@@ -868,7 +868,7 @@
           <a:p>
             <a:r>
               <a:rPr lang="en-US" dirty="0"/>
-              <a:t>The transfer gap (1.000 vs 0.28/0.31 on identical pools) settles the corpus/conditioning question; the text-only LibriSpeech cell of the 2x2 remains optional completeness. Layer choice for the hook changes 4 -&gt; 3 if adopted.</a:t>
+              <a:t>2x2 decomposition: corpus effect ~3-8 points; conditioning effect ~70 points and asymmetric. W_audio dominates the grid. Text-only LS prefix collapse (0.06/0.13 at 25%) shows early utterance text alone is uninformative on LibriSpeech — cross-attention supplies the missing whole-utterance evidence.</a:t>
             </a:r>
             <a:endParaRPr lang="en-US" dirty="0"/>
           </a:p>
@@ -5574,7 +5574,7 @@
                 <a:ea typeface="Calibri" pitchFamily="34" charset="-122"/>
                 <a:cs typeface="Calibri" pitchFamily="34" charset="-120"/>
               </a:rPr>
-              <a:t>Audio-conditioned and text-only LibriSpeech alignment notebooks fit W variants and cross-evaluate every artifact — the corpus decision gets made by measurement, then frozen. Audio-conditioned run COMPLETE → next slide.</a:t>
+              <a:t>Audio-conditioned and text-only LibriSpeech alignment notebooks fit W variants and cross-evaluate every artifact — the corpus decision gets made by measurement, then frozen. BOTH runs COMPLETE → next slide.</a:t>
             </a:r>
             <a:endParaRPr lang="en-US" sz="1100" dirty="0"/>
           </a:p>
@@ -5728,7 +5728,7 @@
                 <a:ea typeface="Calibri" pitchFamily="34" charset="-122"/>
                 <a:cs typeface="Calibri" pitchFamily="34" charset="-120"/>
               </a:rPr>
-              <a:t>NEW RESULT · PHASE 0 SUPPORTING ANALYSIS</a:t>
+              <a:t>NEW RESULTS · 2×2 CALIBRATION GRID COMPLETE</a:t>
             </a:r>
             <a:endParaRPr lang="en-US" sz="1100" dirty="0"/>
           </a:p>
@@ -5767,7 +5767,7 @@
                 <a:ea typeface="Cambria" pitchFamily="34" charset="-122"/>
                 <a:cs typeface="Cambria" pitchFamily="34" charset="-120"/>
               </a:rPr>
-              <a:t>§10.3 answered by measurement: calibrate W on audio</a:t>
+              <a:t>§10.3: conditioning decides — corpus barely matters</a:t>
             </a:r>
             <a:endParaRPr lang="en-US" sz="2700" dirty="0"/>
           </a:p>
@@ -5828,7 +5828,7 @@
                 <a:ea typeface="Calibri" pitchFamily="34" charset="-122"/>
                 <a:cs typeface="Calibri" pitchFamily="34" charset="-120"/>
               </a:rPr>
-              <a:t>Audio-conditioned alignment run, 2026-07-28 — dev-clean/dev-other TUNE shards, ≈1,385 (audio, reference) pairs, teacher-forced over real encoder outputs. Supporting analysis for decision 3.</a:t>
+              <a:t>Both supporting runs complete (2026-07-28, dev TUNE shards, ≈1,385 pairs each): audio-conditioned and text-only (silence-conditioned) LibriSpeech alignment. Evidence for decision 3.</a:t>
             </a:r>
             <a:endParaRPr lang="en-US" sz="1100" dirty="0"/>
           </a:p>
@@ -5842,12 +5842,12 @@
         </p:nvSpPr>
         <p:spPr>
           <a:xfrm>
-            <a:off x="548640" y="2057400"/>
-            <a:ext cx="5394960" cy="1737360"/>
+            <a:off x="548640" y="2011680"/>
+            <a:ext cx="5394960" cy="1234440"/>
           </a:xfrm>
           <a:prstGeom prst="roundRect">
             <a:avLst>
-              <a:gd name="adj" fmla="val 4737"/>
+              <a:gd name="adj" fmla="val 6667"/>
             </a:avLst>
           </a:prstGeom>
           <a:solidFill>
@@ -5864,8 +5864,8 @@
         </p:nvSpPr>
         <p:spPr>
           <a:xfrm>
-            <a:off x="777240" y="2212848"/>
-            <a:ext cx="4937760" cy="274320"/>
+            <a:off x="777240" y="2148840"/>
+            <a:ext cx="4937760" cy="256032"/>
           </a:xfrm>
           <a:prstGeom prst="rect">
             <a:avLst/>
@@ -5881,7 +5881,7 @@
               <a:buNone/>
             </a:pPr>
             <a:r>
-              <a:rPr lang="en-US" sz="1250" b="1" dirty="0">
+              <a:rPr lang="en-US" sz="1200" b="1" dirty="0">
                 <a:solidFill>
                   <a:srgbClr val="262B38"/>
                 </a:solidFill>
@@ -5889,9 +5889,9 @@
                 <a:ea typeface="Calibri" pitchFamily="34" charset="-122"/>
                 <a:cs typeface="Calibri" pitchFamily="34" charset="-120"/>
               </a:rPr>
-              <a:t>W_audio — fitted on audio-conditioned states (layer 3)</a:t>
-            </a:r>
-            <a:endParaRPr lang="en-US" sz="1250" dirty="0"/>
+              <a:t>W_audio on audio states (deployment distribution)</a:t>
+            </a:r>
+            <a:endParaRPr lang="en-US" sz="1200" dirty="0"/>
           </a:p>
         </p:txBody>
       </p:sp>
@@ -5903,8 +5903,8 @@
         </p:nvSpPr>
         <p:spPr>
           <a:xfrm>
-            <a:off x="777240" y="2514600"/>
-            <a:ext cx="2194560" cy="685800"/>
+            <a:off x="777240" y="2423160"/>
+            <a:ext cx="1828800" cy="594360"/>
           </a:xfrm>
           <a:prstGeom prst="rect">
             <a:avLst/>
@@ -5920,7 +5920,7 @@
               <a:buNone/>
             </a:pPr>
             <a:r>
-              <a:rPr lang="en-US" sz="4000" b="1" dirty="0">
+              <a:rPr lang="en-US" sz="3200" b="1" dirty="0">
                 <a:solidFill>
                   <a:srgbClr val="2E7D52"/>
                 </a:solidFill>
@@ -5930,7 +5930,7 @@
               </a:rPr>
               <a:t>1.000</a:t>
             </a:r>
-            <a:endParaRPr lang="en-US" sz="4000" dirty="0"/>
+            <a:endParaRPr lang="en-US" sz="3200" dirty="0"/>
           </a:p>
         </p:txBody>
       </p:sp>
@@ -5942,8 +5942,8 @@
         </p:nvSpPr>
         <p:spPr>
           <a:xfrm>
-            <a:off x="3108960" y="2560320"/>
-            <a:ext cx="2651760" cy="1097280"/>
+            <a:off x="2743200" y="2487168"/>
+            <a:ext cx="3017520" cy="548640"/>
           </a:xfrm>
           <a:prstGeom prst="rect">
             <a:avLst/>
@@ -5959,7 +5959,7 @@
               <a:buNone/>
             </a:pPr>
             <a:r>
-              <a:rPr lang="en-US" sz="1100" dirty="0">
+              <a:rPr lang="en-US" sz="1050" dirty="0">
                 <a:solidFill>
                   <a:srgbClr val="5A6272"/>
                 </a:solidFill>
@@ -5967,9 +5967,9 @@
                 <a:ea typeface="Calibri" pitchFamily="34" charset="-122"/>
                 <a:cs typeface="Calibri" pitchFamily="34" charset="-120"/>
               </a:rPr>
-              <a:t>held-out top-1 retrieval on BOTH splits (test pools 67 / 71; chance ≈ 1.5%) · paired cosine 0.48–0.51 vs random 0.17–0.19</a:t>
-            </a:r>
-            <a:endParaRPr lang="en-US" sz="1100" dirty="0"/>
+              <a:t>held-out top-1, both splits · layer 3 · pools 67/71, chance ≈ 1.5%</a:t>
+            </a:r>
+            <a:endParaRPr lang="en-US" sz="1050" dirty="0"/>
           </a:p>
         </p:txBody>
       </p:sp>
@@ -5981,12 +5981,12 @@
         </p:nvSpPr>
         <p:spPr>
           <a:xfrm>
-            <a:off x="548640" y="3931920"/>
-            <a:ext cx="5394960" cy="1737360"/>
+            <a:off x="548640" y="3337560"/>
+            <a:ext cx="5394960" cy="1234440"/>
           </a:xfrm>
           <a:prstGeom prst="roundRect">
             <a:avLst>
-              <a:gd name="adj" fmla="val 4737"/>
+              <a:gd name="adj" fmla="val 6667"/>
             </a:avLst>
           </a:prstGeom>
           <a:solidFill>
@@ -6003,8 +6003,8 @@
         </p:nvSpPr>
         <p:spPr>
           <a:xfrm>
-            <a:off x="777240" y="4087368"/>
-            <a:ext cx="4937760" cy="274320"/>
+            <a:off x="777240" y="3474720"/>
+            <a:ext cx="4937760" cy="256032"/>
           </a:xfrm>
           <a:prstGeom prst="rect">
             <a:avLst/>
@@ -6020,7 +6020,7 @@
               <a:buNone/>
             </a:pPr>
             <a:r>
-              <a:rPr lang="en-US" sz="1250" b="1" dirty="0">
+              <a:rPr lang="en-US" sz="1200" b="1" dirty="0">
                 <a:solidFill>
                   <a:srgbClr val="262B38"/>
                 </a:solidFill>
@@ -6028,9 +6028,9 @@
                 <a:ea typeface="Calibri" pitchFamily="34" charset="-122"/>
                 <a:cs typeface="Calibri" pitchFamily="34" charset="-120"/>
               </a:rPr>
-              <a:t>W_silence (Exp-01) evaluated on the same audio states</a:t>
-            </a:r>
-            <a:endParaRPr lang="en-US" sz="1250" dirty="0"/>
+              <a:t>W_silence (WikiText, Exp-01) on the same audio states</a:t>
+            </a:r>
+            <a:endParaRPr lang="en-US" sz="1200" dirty="0"/>
           </a:p>
         </p:txBody>
       </p:sp>
@@ -6042,8 +6042,8 @@
         </p:nvSpPr>
         <p:spPr>
           <a:xfrm>
-            <a:off x="777240" y="4389120"/>
-            <a:ext cx="2377440" cy="685800"/>
+            <a:off x="777240" y="3749040"/>
+            <a:ext cx="2194560" cy="594360"/>
           </a:xfrm>
           <a:prstGeom prst="rect">
             <a:avLst/>
@@ -6059,7 +6059,7 @@
               <a:buNone/>
             </a:pPr>
             <a:r>
-              <a:rPr lang="en-US" sz="3400" b="1" dirty="0">
+              <a:rPr lang="en-US" sz="2800" b="1" dirty="0">
                 <a:solidFill>
                   <a:srgbClr val="C94141"/>
                 </a:solidFill>
@@ -6069,7 +6069,7 @@
               </a:rPr>
               <a:t>0.28 / 0.31</a:t>
             </a:r>
-            <a:endParaRPr lang="en-US" sz="3400" dirty="0"/>
+            <a:endParaRPr lang="en-US" sz="2800" dirty="0"/>
           </a:p>
         </p:txBody>
       </p:sp>
@@ -6081,8 +6081,8 @@
         </p:nvSpPr>
         <p:spPr>
           <a:xfrm>
-            <a:off x="3291840" y="4343400"/>
-            <a:ext cx="2468880" cy="1188720"/>
+            <a:off x="3108960" y="3767328"/>
+            <a:ext cx="2651760" cy="685800"/>
           </a:xfrm>
           <a:prstGeom prst="rect">
             <a:avLst/>
@@ -6098,7 +6098,7 @@
               <a:buNone/>
             </a:pPr>
             <a:r>
-              <a:rPr lang="en-US" sz="1100" dirty="0">
+              <a:rPr lang="en-US" sz="1050" dirty="0">
                 <a:solidFill>
                   <a:srgbClr val="5A6272"/>
                 </a:solidFill>
@@ -6106,7 +6106,82 @@
                 <a:ea typeface="Calibri" pitchFamily="34" charset="-122"/>
                 <a:cs typeface="Calibri" pitchFamily="34" charset="-120"/>
               </a:rPr>
-              <a:t>dev-clean / dev-other top-1 at its native layer 4 · paired cosine collapses to ≈ 0.13 — the conditioning mismatch is expensive at deployment</a:t>
+              <a:t>clean / other top-1 · paired cosine collapses 0.48 → 0.13 — conditioning mismatch is expensive</a:t>
+            </a:r>
+            <a:endParaRPr lang="en-US" sz="1050" dirty="0"/>
+          </a:p>
+        </p:txBody>
+      </p:sp>
+      <p:sp>
+        <p:nvSpPr>
+          <p:cNvPr id="16" name="Shape 13"/>
+          <p:cNvSpPr/>
+          <p:nvPr/>
+        </p:nvSpPr>
+        <p:spPr>
+          <a:xfrm>
+            <a:off x="548640" y="4663440"/>
+            <a:ext cx="5394960" cy="1005840"/>
+          </a:xfrm>
+          <a:prstGeom prst="roundRect">
+            <a:avLst>
+              <a:gd name="adj" fmla="val 8182"/>
+            </a:avLst>
+          </a:prstGeom>
+          <a:solidFill>
+            <a:srgbClr val="EEF4FB"/>
+          </a:solidFill>
+          <a:ln/>
+        </p:spPr>
+      </p:sp>
+      <p:sp>
+        <p:nvSpPr>
+          <p:cNvPr id="17" name="Text 14"/>
+          <p:cNvSpPr/>
+          <p:nvPr/>
+        </p:nvSpPr>
+        <p:spPr>
+          <a:xfrm>
+            <a:off x="777240" y="4800600"/>
+            <a:ext cx="4937760" cy="777240"/>
+          </a:xfrm>
+          <a:prstGeom prst="rect">
+            <a:avLst/>
+          </a:prstGeom>
+          <a:noFill/>
+          <a:ln/>
+        </p:spPr>
+        <p:txBody>
+          <a:bodyPr wrap="square" lIns="0" tIns="0" rIns="0" bIns="0" rtlCol="0" anchor="ctr"/>
+          <a:lstStyle/>
+          <a:p>
+            <a:pPr indent="0" marL="0">
+              <a:buNone/>
+            </a:pPr>
+            <a:r>
+              <a:rPr lang="en-US" sz="1100" b="1" dirty="0">
+                <a:solidFill>
+                  <a:srgbClr val="1E2761"/>
+                </a:solidFill>
+                <a:latin typeface="Calibri" pitchFamily="34" charset="0"/>
+                <a:ea typeface="Calibri" pitchFamily="34" charset="-122"/>
+                <a:cs typeface="Calibri" pitchFamily="34" charset="-120"/>
+              </a:rPr>
+              <a:t>The reverse direction is cheap — transfer is asymmetric.  </a:t>
+            </a:r>
+            <a:pPr indent="0" marL="0">
+              <a:buNone/>
+            </a:pPr>
+            <a:r>
+              <a:rPr lang="en-US" sz="1100" dirty="0">
+                <a:solidFill>
+                  <a:srgbClr val="262B38"/>
+                </a:solidFill>
+                <a:latin typeface="Calibri" pitchFamily="34" charset="0"/>
+                <a:ea typeface="Calibri" pitchFamily="34" charset="-122"/>
+                <a:cs typeface="Calibri" pitchFamily="34" charset="-120"/>
+              </a:rPr>
+              <a:t>W_audio on text states: 0.97 / 0.99. Corpus effect small: W_wikitext 0.97 / 0.92 vs W_text_ls 1.000 on LS text states. Audio-fitted W generalizes everywhere; silence-fitted does not.</a:t>
             </a:r>
             <a:endParaRPr lang="en-US" sz="1100" dirty="0"/>
           </a:p>
@@ -6127,7 +6202,7 @@
           </p:nvPr>
         </p:nvGraphicFramePr>
         <p:xfrm>
-          <a:off x="6309360" y="2057400"/>
+          <a:off x="6309360" y="2011680"/>
           <a:ext cx="5257800" cy="914400"/>
         </p:xfrm>
         <a:graphic>
@@ -6135,12 +6210,12 @@
             <a:tbl>
               <a:tblPr/>
               <a:tblGrid>
-                <a:gridCol w="1325880"/>
-                <a:gridCol w="1280160"/>
-                <a:gridCol w="1280160"/>
-                <a:gridCol w="1371600"/>
+                <a:gridCol w="868680"/>
+                <a:gridCol w="1554480"/>
+                <a:gridCol w="1417320"/>
+                <a:gridCol w="1417320"/>
               </a:tblGrid>
-              <a:tr h="365760">
+              <a:tr h="347472">
                 <a:tc>
                   <a:txBody>
                     <a:bodyPr/>
@@ -6150,7 +6225,7 @@
                         <a:buNone/>
                       </a:pPr>
                       <a:r>
-                        <a:rPr lang="en-US" sz="1150" b="1" dirty="0">
+                        <a:rPr lang="en-US" sz="1100" b="1" dirty="0">
                           <a:solidFill>
                             <a:srgbClr val="FFFFFF"/>
                           </a:solidFill>
@@ -6158,9 +6233,9 @@
                           <a:ea typeface="Calibri" pitchFamily="34" charset="-122"/>
                           <a:cs typeface="Calibri" pitchFamily="34" charset="-120"/>
                         </a:rPr>
-                        <a:t>prefix seen</a:t>
+                        <a:t>prefix</a:t>
                       </a:r>
-                      <a:endParaRPr lang="en-US" sz="1150" dirty="0">
+                      <a:endParaRPr lang="en-US" sz="1100" dirty="0">
                         <a:latin typeface="Calibri" charset="0"/>
                         <a:ea typeface="Calibri" charset="0"/>
                         <a:cs typeface="Calibri" charset="0"/>
@@ -6218,7 +6293,7 @@
                         <a:buNone/>
                       </a:pPr>
                       <a:r>
-                        <a:rPr lang="en-US" sz="1150" b="1" dirty="0">
+                        <a:rPr lang="en-US" sz="1100" b="1" dirty="0">
                           <a:solidFill>
                             <a:srgbClr val="FFFFFF"/>
                           </a:solidFill>
@@ -6226,9 +6301,9 @@
                           <a:ea typeface="Calibri" pitchFamily="34" charset="-122"/>
                           <a:cs typeface="Calibri" pitchFamily="34" charset="-120"/>
                         </a:rPr>
-                        <a:t>dev-clean</a:t>
+                        <a:t>audio-cond.</a:t>
                       </a:r>
-                      <a:endParaRPr lang="en-US" sz="1150" dirty="0">
+                      <a:endParaRPr lang="en-US" sz="1100" dirty="0">
                         <a:latin typeface="Calibri" charset="0"/>
                         <a:ea typeface="Calibri" charset="0"/>
                         <a:cs typeface="Calibri" charset="0"/>
@@ -6286,7 +6361,7 @@
                         <a:buNone/>
                       </a:pPr>
                       <a:r>
-                        <a:rPr lang="en-US" sz="1150" b="1" dirty="0">
+                        <a:rPr lang="en-US" sz="1100" b="1" dirty="0">
                           <a:solidFill>
                             <a:srgbClr val="FFFFFF"/>
                           </a:solidFill>
@@ -6294,9 +6369,9 @@
                           <a:ea typeface="Calibri" pitchFamily="34" charset="-122"/>
                           <a:cs typeface="Calibri" pitchFamily="34" charset="-120"/>
                         </a:rPr>
-                        <a:t>dev-other</a:t>
+                        <a:t>WikiText · silence</a:t>
                       </a:r>
-                      <a:endParaRPr lang="en-US" sz="1150" dirty="0">
+                      <a:endParaRPr lang="en-US" sz="1100" dirty="0">
                         <a:latin typeface="Calibri" charset="0"/>
                         <a:ea typeface="Calibri" charset="0"/>
                         <a:cs typeface="Calibri" charset="0"/>
@@ -6354,7 +6429,7 @@
                         <a:buNone/>
                       </a:pPr>
                       <a:r>
-                        <a:rPr lang="en-US" sz="1150" b="1" dirty="0">
+                        <a:rPr lang="en-US" sz="1100" b="1" dirty="0">
                           <a:solidFill>
                             <a:srgbClr val="FFFFFF"/>
                           </a:solidFill>
@@ -6362,9 +6437,9 @@
                           <a:ea typeface="Calibri" pitchFamily="34" charset="-122"/>
                           <a:cs typeface="Calibri" pitchFamily="34" charset="-120"/>
                         </a:rPr>
-                        <a:t>Exp-01 (silence)</a:t>
+                        <a:t>LS text · silence</a:t>
                       </a:r>
-                      <a:endParaRPr lang="en-US" sz="1150" dirty="0">
+                      <a:endParaRPr lang="en-US" sz="1100" dirty="0">
                         <a:latin typeface="Calibri" charset="0"/>
                         <a:ea typeface="Calibri" charset="0"/>
                         <a:cs typeface="Calibri" charset="0"/>
@@ -6414,7 +6489,7 @@
                   </a:tcPr>
                 </a:tc>
               </a:tr>
-              <a:tr h="365760">
+              <a:tr h="347472">
                 <a:tc>
                   <a:txBody>
                     <a:bodyPr/>
@@ -6424,7 +6499,7 @@
                         <a:buNone/>
                       </a:pPr>
                       <a:r>
-                        <a:rPr lang="en-US" sz="1150" dirty="0">
+                        <a:rPr lang="en-US" sz="1100" dirty="0">
                           <a:solidFill>
                             <a:srgbClr val="262B38"/>
                           </a:solidFill>
@@ -6434,7 +6509,7 @@
                         </a:rPr>
                         <a:t>25%</a:t>
                       </a:r>
-                      <a:endParaRPr lang="en-US" sz="1150" dirty="0">
+                      <a:endParaRPr lang="en-US" sz="1100" dirty="0">
                         <a:latin typeface="Calibri" charset="0"/>
                         <a:ea typeface="Calibri" charset="0"/>
                         <a:cs typeface="Calibri" charset="0"/>
@@ -6489,7 +6564,7 @@
                         <a:buNone/>
                       </a:pPr>
                       <a:r>
-                        <a:rPr lang="en-US" sz="1150" b="1" dirty="0">
+                        <a:rPr lang="en-US" sz="1100" b="1" dirty="0">
                           <a:solidFill>
                             <a:srgbClr val="2E7D52"/>
                           </a:solidFill>
@@ -6497,9 +6572,9 @@
                           <a:ea typeface="Calibri" pitchFamily="34" charset="-122"/>
                           <a:cs typeface="Calibri" pitchFamily="34" charset="-120"/>
                         </a:rPr>
-                        <a:t>0.388</a:t>
+                        <a:t>0.39 / 0.41</a:t>
                       </a:r>
-                      <a:endParaRPr lang="en-US" sz="1150" dirty="0">
+                      <a:endParaRPr lang="en-US" sz="1100" dirty="0">
                         <a:latin typeface="Calibri" charset="0"/>
                         <a:ea typeface="Calibri" charset="0"/>
                         <a:cs typeface="Calibri" charset="0"/>
@@ -6554,17 +6629,17 @@
                         <a:buNone/>
                       </a:pPr>
                       <a:r>
-                        <a:rPr lang="en-US" sz="1150" b="1" dirty="0">
+                        <a:rPr lang="en-US" sz="1100" dirty="0">
                           <a:solidFill>
-                            <a:srgbClr val="2E7D52"/>
+                            <a:srgbClr val="262B38"/>
                           </a:solidFill>
                           <a:latin typeface="Calibri" pitchFamily="34" charset="0"/>
                           <a:ea typeface="Calibri" pitchFamily="34" charset="-122"/>
                           <a:cs typeface="Calibri" pitchFamily="34" charset="-120"/>
                         </a:rPr>
-                        <a:t>0.409</a:t>
+                        <a:t>0.29</a:t>
                       </a:r>
-                      <a:endParaRPr lang="en-US" sz="1150" dirty="0">
+                      <a:endParaRPr lang="en-US" sz="1100" dirty="0">
                         <a:latin typeface="Calibri" charset="0"/>
                         <a:ea typeface="Calibri" charset="0"/>
                         <a:cs typeface="Calibri" charset="0"/>
@@ -6619,17 +6694,17 @@
                         <a:buNone/>
                       </a:pPr>
                       <a:r>
-                        <a:rPr lang="en-US" sz="1150" dirty="0">
+                        <a:rPr lang="en-US" sz="1100" b="1" dirty="0">
                           <a:solidFill>
-                            <a:srgbClr val="262B38"/>
+                            <a:srgbClr val="C94141"/>
                           </a:solidFill>
                           <a:latin typeface="Calibri" pitchFamily="34" charset="0"/>
                           <a:ea typeface="Calibri" pitchFamily="34" charset="-122"/>
                           <a:cs typeface="Calibri" pitchFamily="34" charset="-120"/>
                         </a:rPr>
-                        <a:t>0.290</a:t>
+                        <a:t>0.06 / 0.13</a:t>
                       </a:r>
-                      <a:endParaRPr lang="en-US" sz="1150" dirty="0">
+                      <a:endParaRPr lang="en-US" sz="1100" dirty="0">
                         <a:latin typeface="Calibri" charset="0"/>
                         <a:ea typeface="Calibri" charset="0"/>
                         <a:cs typeface="Calibri" charset="0"/>
@@ -6676,7 +6751,7 @@
                   </a:tcPr>
                 </a:tc>
               </a:tr>
-              <a:tr h="365760">
+              <a:tr h="347472">
                 <a:tc>
                   <a:txBody>
                     <a:bodyPr/>
@@ -6686,7 +6761,7 @@
                         <a:buNone/>
                       </a:pPr>
                       <a:r>
-                        <a:rPr lang="en-US" sz="1150" dirty="0">
+                        <a:rPr lang="en-US" sz="1100" dirty="0">
                           <a:solidFill>
                             <a:srgbClr val="262B38"/>
                           </a:solidFill>
@@ -6696,7 +6771,7 @@
                         </a:rPr>
                         <a:t>50%</a:t>
                       </a:r>
-                      <a:endParaRPr lang="en-US" sz="1150" dirty="0">
+                      <a:endParaRPr lang="en-US" sz="1100" dirty="0">
                         <a:latin typeface="Calibri" charset="0"/>
                         <a:ea typeface="Calibri" charset="0"/>
                         <a:cs typeface="Calibri" charset="0"/>
@@ -6751,7 +6826,7 @@
                         <a:buNone/>
                       </a:pPr>
                       <a:r>
-                        <a:rPr lang="en-US" sz="1150" dirty="0">
+                        <a:rPr lang="en-US" sz="1100" dirty="0">
                           <a:solidFill>
                             <a:srgbClr val="262B38"/>
                           </a:solidFill>
@@ -6759,9 +6834,9 @@
                           <a:ea typeface="Calibri" pitchFamily="34" charset="-122"/>
                           <a:cs typeface="Calibri" pitchFamily="34" charset="-120"/>
                         </a:rPr>
-                        <a:t>0.836</a:t>
+                        <a:t>0.84 / 0.78</a:t>
                       </a:r>
-                      <a:endParaRPr lang="en-US" sz="1150" dirty="0">
+                      <a:endParaRPr lang="en-US" sz="1100" dirty="0">
                         <a:latin typeface="Calibri" charset="0"/>
                         <a:ea typeface="Calibri" charset="0"/>
                         <a:cs typeface="Calibri" charset="0"/>
@@ -6816,7 +6891,7 @@
                         <a:buNone/>
                       </a:pPr>
                       <a:r>
-                        <a:rPr lang="en-US" sz="1150" dirty="0">
+                        <a:rPr lang="en-US" sz="1100" dirty="0">
                           <a:solidFill>
                             <a:srgbClr val="262B38"/>
                           </a:solidFill>
@@ -6824,9 +6899,9 @@
                           <a:ea typeface="Calibri" pitchFamily="34" charset="-122"/>
                           <a:cs typeface="Calibri" pitchFamily="34" charset="-120"/>
                         </a:rPr>
-                        <a:t>0.775</a:t>
+                        <a:t>0.77</a:t>
                       </a:r>
-                      <a:endParaRPr lang="en-US" sz="1150" dirty="0">
+                      <a:endParaRPr lang="en-US" sz="1100" dirty="0">
                         <a:latin typeface="Calibri" charset="0"/>
                         <a:ea typeface="Calibri" charset="0"/>
                         <a:cs typeface="Calibri" charset="0"/>
@@ -6881,7 +6956,7 @@
                         <a:buNone/>
                       </a:pPr>
                       <a:r>
-                        <a:rPr lang="en-US" sz="1150" dirty="0">
+                        <a:rPr lang="en-US" sz="1100" dirty="0">
                           <a:solidFill>
                             <a:srgbClr val="262B38"/>
                           </a:solidFill>
@@ -6889,9 +6964,9 @@
                           <a:ea typeface="Calibri" pitchFamily="34" charset="-122"/>
                           <a:cs typeface="Calibri" pitchFamily="34" charset="-120"/>
                         </a:rPr>
-                        <a:t>0.765</a:t>
+                        <a:t>0.60 / 0.49</a:t>
                       </a:r>
-                      <a:endParaRPr lang="en-US" sz="1150" dirty="0">
+                      <a:endParaRPr lang="en-US" sz="1100" dirty="0">
                         <a:latin typeface="Calibri" charset="0"/>
                         <a:ea typeface="Calibri" charset="0"/>
                         <a:cs typeface="Calibri" charset="0"/>
@@ -6938,7 +7013,7 @@
                   </a:tcPr>
                 </a:tc>
               </a:tr>
-              <a:tr h="365760">
+              <a:tr h="347472">
                 <a:tc>
                   <a:txBody>
                     <a:bodyPr/>
@@ -6948,7 +7023,7 @@
                         <a:buNone/>
                       </a:pPr>
                       <a:r>
-                        <a:rPr lang="en-US" sz="1150" dirty="0">
+                        <a:rPr lang="en-US" sz="1100" dirty="0">
                           <a:solidFill>
                             <a:srgbClr val="262B38"/>
                           </a:solidFill>
@@ -6958,7 +7033,7 @@
                         </a:rPr>
                         <a:t>75%</a:t>
                       </a:r>
-                      <a:endParaRPr lang="en-US" sz="1150" dirty="0">
+                      <a:endParaRPr lang="en-US" sz="1100" dirty="0">
                         <a:latin typeface="Calibri" charset="0"/>
                         <a:ea typeface="Calibri" charset="0"/>
                         <a:cs typeface="Calibri" charset="0"/>
@@ -7013,7 +7088,7 @@
                         <a:buNone/>
                       </a:pPr>
                       <a:r>
-                        <a:rPr lang="en-US" sz="1150" dirty="0">
+                        <a:rPr lang="en-US" sz="1100" dirty="0">
                           <a:solidFill>
                             <a:srgbClr val="262B38"/>
                           </a:solidFill>
@@ -7021,9 +7096,9 @@
                           <a:ea typeface="Calibri" pitchFamily="34" charset="-122"/>
                           <a:cs typeface="Calibri" pitchFamily="34" charset="-120"/>
                         </a:rPr>
-                        <a:t>0.970</a:t>
+                        <a:t>0.97 / 0.96</a:t>
                       </a:r>
-                      <a:endParaRPr lang="en-US" sz="1150" dirty="0">
+                      <a:endParaRPr lang="en-US" sz="1100" dirty="0">
                         <a:latin typeface="Calibri" charset="0"/>
                         <a:ea typeface="Calibri" charset="0"/>
                         <a:cs typeface="Calibri" charset="0"/>
@@ -7078,7 +7153,7 @@
                         <a:buNone/>
                       </a:pPr>
                       <a:r>
-                        <a:rPr lang="en-US" sz="1150" dirty="0">
+                        <a:rPr lang="en-US" sz="1100" dirty="0">
                           <a:solidFill>
                             <a:srgbClr val="262B38"/>
                           </a:solidFill>
@@ -7086,9 +7161,9 @@
                           <a:ea typeface="Calibri" pitchFamily="34" charset="-122"/>
                           <a:cs typeface="Calibri" pitchFamily="34" charset="-120"/>
                         </a:rPr>
-                        <a:t>0.958</a:t>
+                        <a:t>0.98</a:t>
                       </a:r>
-                      <a:endParaRPr lang="en-US" sz="1150" dirty="0">
+                      <a:endParaRPr lang="en-US" sz="1100" dirty="0">
                         <a:latin typeface="Calibri" charset="0"/>
                         <a:ea typeface="Calibri" charset="0"/>
                         <a:cs typeface="Calibri" charset="0"/>
@@ -7143,7 +7218,7 @@
                         <a:buNone/>
                       </a:pPr>
                       <a:r>
-                        <a:rPr lang="en-US" sz="1150" dirty="0">
+                        <a:rPr lang="en-US" sz="1100" dirty="0">
                           <a:solidFill>
                             <a:srgbClr val="262B38"/>
                           </a:solidFill>
@@ -7151,9 +7226,9 @@
                           <a:ea typeface="Calibri" pitchFamily="34" charset="-122"/>
                           <a:cs typeface="Calibri" pitchFamily="34" charset="-120"/>
                         </a:rPr>
-                        <a:t>0.975</a:t>
+                        <a:t>0.97 / 0.92</a:t>
                       </a:r>
-                      <a:endParaRPr lang="en-US" sz="1150" dirty="0">
+                      <a:endParaRPr lang="en-US" sz="1100" dirty="0">
                         <a:latin typeface="Calibri" charset="0"/>
                         <a:ea typeface="Calibri" charset="0"/>
                         <a:cs typeface="Calibri" charset="0"/>
@@ -7200,7 +7275,7 @@
                   </a:tcPr>
                 </a:tc>
               </a:tr>
-              <a:tr h="365760">
+              <a:tr h="347472">
                 <a:tc>
                   <a:txBody>
                     <a:bodyPr/>
@@ -7210,7 +7285,7 @@
                         <a:buNone/>
                       </a:pPr>
                       <a:r>
-                        <a:rPr lang="en-US" sz="1150" dirty="0">
+                        <a:rPr lang="en-US" sz="1100" dirty="0">
                           <a:solidFill>
                             <a:srgbClr val="262B38"/>
                           </a:solidFill>
@@ -7220,7 +7295,7 @@
                         </a:rPr>
                         <a:t>100%</a:t>
                       </a:r>
-                      <a:endParaRPr lang="en-US" sz="1150" dirty="0">
+                      <a:endParaRPr lang="en-US" sz="1100" dirty="0">
                         <a:latin typeface="Calibri" charset="0"/>
                         <a:ea typeface="Calibri" charset="0"/>
                         <a:cs typeface="Calibri" charset="0"/>
@@ -7275,7 +7350,7 @@
                         <a:buNone/>
                       </a:pPr>
                       <a:r>
-                        <a:rPr lang="en-US" sz="1150" dirty="0">
+                        <a:rPr lang="en-US" sz="1100" dirty="0">
                           <a:solidFill>
                             <a:srgbClr val="262B38"/>
                           </a:solidFill>
@@ -7283,9 +7358,9 @@
                           <a:ea typeface="Calibri" pitchFamily="34" charset="-122"/>
                           <a:cs typeface="Calibri" pitchFamily="34" charset="-120"/>
                         </a:rPr>
-                        <a:t>1.000</a:t>
+                        <a:t>1.00</a:t>
                       </a:r>
-                      <a:endParaRPr lang="en-US" sz="1150" dirty="0">
+                      <a:endParaRPr lang="en-US" sz="1100" dirty="0">
                         <a:latin typeface="Calibri" charset="0"/>
                         <a:ea typeface="Calibri" charset="0"/>
                         <a:cs typeface="Calibri" charset="0"/>
@@ -7340,7 +7415,7 @@
                         <a:buNone/>
                       </a:pPr>
                       <a:r>
-                        <a:rPr lang="en-US" sz="1150" dirty="0">
+                        <a:rPr lang="en-US" sz="1100" dirty="0">
                           <a:solidFill>
                             <a:srgbClr val="262B38"/>
                           </a:solidFill>
@@ -7348,9 +7423,9 @@
                           <a:ea typeface="Calibri" pitchFamily="34" charset="-122"/>
                           <a:cs typeface="Calibri" pitchFamily="34" charset="-120"/>
                         </a:rPr>
-                        <a:t>1.000</a:t>
+                        <a:t>1.00</a:t>
                       </a:r>
-                      <a:endParaRPr lang="en-US" sz="1150" dirty="0">
+                      <a:endParaRPr lang="en-US" sz="1100" dirty="0">
                         <a:latin typeface="Calibri" charset="0"/>
                         <a:ea typeface="Calibri" charset="0"/>
                         <a:cs typeface="Calibri" charset="0"/>
@@ -7405,7 +7480,7 @@
                         <a:buNone/>
                       </a:pPr>
                       <a:r>
-                        <a:rPr lang="en-US" sz="1150" dirty="0">
+                        <a:rPr lang="en-US" sz="1100" dirty="0">
                           <a:solidFill>
                             <a:srgbClr val="262B38"/>
                           </a:solidFill>
@@ -7413,9 +7488,9 @@
                           <a:ea typeface="Calibri" pitchFamily="34" charset="-122"/>
                           <a:cs typeface="Calibri" pitchFamily="34" charset="-120"/>
                         </a:rPr>
-                        <a:t>1.000</a:t>
+                        <a:t>1.00</a:t>
                       </a:r>
-                      <a:endParaRPr lang="en-US" sz="1150" dirty="0">
+                      <a:endParaRPr lang="en-US" sz="1100" dirty="0">
                         <a:latin typeface="Calibri" charset="0"/>
                         <a:ea typeface="Calibri" charset="0"/>
                         <a:cs typeface="Calibri" charset="0"/>
@@ -7468,14 +7543,14 @@
       </p:graphicFrame>
       <p:sp>
         <p:nvSpPr>
-          <p:cNvPr id="17" name="Text 13"/>
-          <p:cNvSpPr/>
-          <p:nvPr/>
-        </p:nvSpPr>
-        <p:spPr>
-          <a:xfrm>
-            <a:off x="6309360" y="4069080"/>
-            <a:ext cx="5257800" cy="1005840"/>
+          <p:cNvPr id="19" name="Text 15"/>
+          <p:cNvSpPr/>
+          <p:nvPr/>
+        </p:nvSpPr>
+        <p:spPr>
+          <a:xfrm>
+            <a:off x="6309360" y="3886200"/>
+            <a:ext cx="5257800" cy="1097280"/>
           </a:xfrm>
           <a:prstGeom prst="rect">
             <a:avLst/>
@@ -7491,7 +7566,7 @@
               <a:buNone/>
             </a:pPr>
             <a:r>
-              <a:rPr lang="en-US" sz="1150" i="1" dirty="0">
+              <a:rPr lang="en-US" sz="1100" i="1" dirty="0">
                 <a:solidFill>
                   <a:srgbClr val="5A6272"/>
                 </a:solidFill>
@@ -7499,26 +7574,26 @@
                 <a:ea typeface="Calibri" pitchFamily="34" charset="-122"/>
                 <a:cs typeface="Calibri" pitchFamily="34" charset="-120"/>
               </a:rPr>
-              <a:t>Prefix probe (top-1, W_audio): the early-decode regime — 25% of the sentence, where biasing decisions actually fire — gains ~10 points under audio conditioning. Cross-attention gives the decoder whole-utterance acoustic evidence from step one.</a:t>
-            </a:r>
-            <a:endParaRPr lang="en-US" sz="1150" dirty="0"/>
-          </a:p>
-        </p:txBody>
-      </p:sp>
-      <p:sp>
-        <p:nvSpPr>
-          <p:cNvPr id="18" name="Shape 14"/>
-          <p:cNvSpPr/>
-          <p:nvPr/>
-        </p:nvSpPr>
-        <p:spPr>
-          <a:xfrm>
-            <a:off x="548640" y="5806440"/>
-            <a:ext cx="11091672" cy="777240"/>
+              <a:t>Prefix probe (top-1, clean/other): the early-decode regime — where biasing decisions actually fire — works ONLY under audio conditioning. Text-only LibriSpeech calibration collapses to 0.06/0.13 at 25% prefix; audio conditioning reaches 0.39/0.41.</a:t>
+            </a:r>
+            <a:endParaRPr lang="en-US" sz="1100" dirty="0"/>
+          </a:p>
+        </p:txBody>
+      </p:sp>
+      <p:sp>
+        <p:nvSpPr>
+          <p:cNvPr id="20" name="Shape 16"/>
+          <p:cNvSpPr/>
+          <p:nvPr/>
+        </p:nvSpPr>
+        <p:spPr>
+          <a:xfrm>
+            <a:off x="548640" y="5852160"/>
+            <a:ext cx="11091672" cy="731520"/>
           </a:xfrm>
           <a:prstGeom prst="roundRect">
             <a:avLst>
-              <a:gd name="adj" fmla="val 10588"/>
+              <a:gd name="adj" fmla="val 11250"/>
             </a:avLst>
           </a:prstGeom>
           <a:solidFill>
@@ -7529,14 +7604,14 @@
       </p:sp>
       <p:sp>
         <p:nvSpPr>
-          <p:cNvPr id="19" name="Text 15"/>
-          <p:cNvSpPr/>
-          <p:nvPr/>
-        </p:nvSpPr>
-        <p:spPr>
-          <a:xfrm>
-            <a:off x="822960" y="5925312"/>
-            <a:ext cx="10543032" cy="594360"/>
+          <p:cNvPr id="21" name="Text 17"/>
+          <p:cNvSpPr/>
+          <p:nvPr/>
+        </p:nvSpPr>
+        <p:spPr>
+          <a:xfrm>
+            <a:off x="822960" y="5961888"/>
+            <a:ext cx="10543032" cy="548640"/>
           </a:xfrm>
           <a:prstGeom prst="rect">
             <a:avLst/>
@@ -7574,7 +7649,7 @@
                 <a:ea typeface="Calibri" pitchFamily="34" charset="-122"/>
                 <a:cs typeface="Calibri" pitchFamily="34" charset="-120"/>
               </a:rPr>
-              <a:t>freeze whisper_to_sonar_W_audio.pt — audio-conditioned, best layer 3 (shifted from silence-conditioned layer 4) — as the calibration artifact. Caveat: 67/71-utterance pools saturate full-sentence retrieval; the W_audio-vs-W_silence contrast is like-for-like on identical pools.</a:t>
+              <a:t>freeze whisper_to_sonar_W_audio.pt (layer 3; hook shifts 4 → 3) — best or near-best in every grid cell. Caveat: 67/71-utterance pools saturate full-sentence retrieval; all contrasts are like-for-like on identical pools.</a:t>
             </a:r>
             <a:endParaRPr lang="en-US" sz="1150" dirty="0"/>
           </a:p>
@@ -9479,7 +9554,7 @@
                 <a:ea typeface="Calibri" pitchFamily="34" charset="-122"/>
                 <a:cs typeface="Calibri" pitchFamily="34" charset="-120"/>
               </a:rPr>
-              <a:t>W calibration — adopt audio-conditioned W_audio, layer 3 (measured: 1.000 vs 0.28–0.31 top-1 for silence-fitted W on audio states)</a:t>
+              <a:t>W calibration — adopt audio-conditioned W_audio, layer 3: 1.000 on audio states (silence-fitted W: 0.28–0.31) and 0.97–0.99 transferred to text states — robust in every 2×2 cell</a:t>
             </a:r>
             <a:endParaRPr lang="en-US" sz="1200" dirty="0"/>
           </a:p>

</xml_diff>